<commit_message>
Blueprint deck: mark private AI routing + air-gap switch as built & tested
Update the Implementation Blueprint presentation to reflect that the two
deployment controls (ANTHROPIC_BASE_URL private routing and the AIR_GAPPED
switch) are now implemented, tested live in all three postures, and covered
by automated tests. Slides 1-2, 4-7, 9, 11-12, 14-15 and their speaker
notes updated; remaining critical path revised to ~3-5 weeks; test count
refreshed to 793.

Co-Authored-By: Claude Fable 5 <noreply@anthropic.com>
Claude-Session: https://claude.ai/code/session_0142L4rKS2AV8rxQTDWMs7dy
</commit_message>
<xml_diff>
--- a/CostVision-Implementation-Blueprint.pptx
+++ b/CostVision-Implementation-Blueprint.pptx
@@ -516,7 +516,7 @@
           <a:lstStyle/>
           <a:p>
             <a:r>
-              <a:t>Welcome. This session is the implementation blueprint for CostVision: how we deploy it securely so that no CAD data ever leaves our network, and how we integrate it with our existing CAPEE costing tool. Everything in this deck comes from an actual audit of the platform's code — not vendor promises. By the end I'll ask for one decision: approval to start Phase 1 and 2.</a:t>
+              <a:t>Welcome. This session is the implementation blueprint for CostVision: how we deploy it securely so that no CAD data ever leaves our network, and how we integrate it with our existing CAPEE costing tool. Everything in this deck comes from an actual audit of the platform's code — not vendor promises. One important update since the written plan: the two security controls at the heart of this blueprint — private AI routing and the air-gapped switch — have now been BUILT into the platform and tested live. By the end I'll ask for one decision: approval to start Phase 1 and 2.</a:t>
             </a:r>
           </a:p>
         </p:txBody>
@@ -656,7 +656,7 @@
           <a:lstStyle/>
           <a:p>
             <a:r>
-              <a:t>The scope of work, honestly sized. CostVision needs six bounded changes — private AI routing, the air-gap switch, company single sign-on, the corporate database, a clean API wrapper for CAPEE, and audit hardening. CAPEE's changes are additive, not invasive: a client in the backend, an AI-insights panel in the UI, and adopting the shared rate library — plus a one-off import of historical quotes so the memory starts smart. Total critical path: four to six engineering weeks. Nothing here is architectural surgery.</a:t>
+              <a:t>The scope of work, honestly sized. CostVision needed six bounded changes — and the first two, private AI routing and the air-gap switch, are already done: built, covered by automated tests, and demonstrated live in all three deployment modes. What remains on the CostVision side is company single sign-on, the corporate database, a clean API wrapper for CAPEE, and audit hardening. CAPEE's changes are additive, not invasive: a client in the backend, an AI-insights panel in the UI, and adopting the shared rate library — plus a one-off import of historical quotes so the memory starts smart. Remaining critical path: roughly three to five engineering weeks. Nothing here is architectural surgery.</a:t>
             </a:r>
           </a:p>
         </p:txBody>
@@ -936,7 +936,7 @@
           <a:lstStyle/>
           <a:p>
             <a:r>
-              <a:t>To summarise: secure deployment with CAD fully internal is feasible — in fact, the platform was built that way; one endpoint change completes it. CAPEE integration is feasible and high-value, with CAPEE remaining the front door. The changes are bounded — weeks, not months — and governance is defined. The ask today is simple: approve Phases 1 and 2, the security assessment and the architecture design. The full written plan, including the security checklist, is ready to hand to the IT-Security team. Thank you — questions welcome.</a:t>
+              <a:t>To summarise: secure deployment with CAD fully internal is feasible — in fact, the platform was built that way, and the two controls that complete it — private AI routing and the air-gapped switch — are already built, tested and demonstrated live. CAPEE integration is feasible and high-value, with CAPEE remaining the front door. The remaining changes are bounded — roughly three to five weeks, not months — and governance is defined. The ask today is simple: approve Phases 1 and 2, the security assessment and the architecture design. The full written plan, including the security checklist, is ready to hand to the IT-Security team. Thank you — questions welcome.</a:t>
             </a:r>
           </a:p>
         </p:txBody>
@@ -1006,7 +1006,7 @@
           <a:lstStyle/>
           <a:p>
             <a:r>
-              <a:t>One clear ask: approve the first two phases — the security assessment and the architecture design. That's five to seven weeks with existing teams and no new licence spend. Why now? Because the tool itself is finished and proven; what remains is deployment. Why is it safe? Because CAD processing already happens entirely inside the server — we verified this in the code. And why does CAPEE win? Because we are not replacing CAPEE — we're giving it an AI engine and a memory.</a:t>
+              <a:t>One clear ask: approve the first two phases — the security assessment and the architecture design. That's five to seven weeks with existing teams and no new licence spend. Why now? Because the tool itself is finished and proven; what remains is deployment. Why is it safe? Because CAD processing already happens entirely inside the server — we verified this in the code — and the two security controls this plan called for, private AI routing and the air-gapped switch, are now built into the platform and tested live. And why does CAPEE win? Because we are not replacing CAPEE — we're giving it an AI engine and a memory.</a:t>
             </a:r>
           </a:p>
         </p:txBody>
@@ -1146,7 +1146,7 @@
           <a:lstStyle/>
           <a:p>
             <a:r>
-              <a:t>Before the architecture, the five building blocks in plain words. The FRONTEND is simply what users see in their browser — nothing installs on laptops. The BACKEND is the engine room on our server, where all calculations happen. The DATABASE is the memory — a standard corporate database our IT already knows how to run and back up. The GEOMETRY ENGINE is the specialist CAD reader — and note, it runs inside our backend, not in any cloud. The AI LAYER is the only piece that currently talks to an external service — and moving that inside our control is exactly what this blueprint does.</a:t>
+              <a:t>Before the architecture, the five building blocks in plain words. The FRONTEND is simply what users see in their browser — nothing installs on laptops. The BACKEND is the engine room on our server, where all calculations happen. The DATABASE is the memory — a standard corporate database our IT already knows how to run and back up. The GEOMETRY ENGINE is the specialist CAD reader — and note, it runs inside our backend, not in any cloud. The AI LAYER is the only piece that talks to an external service — and the control for that is now BUILT into the platform: a single switchboard that every AI call must pass through. Point it at a private endpoint with one setting, or flip the air-gapped switch and it makes no external calls at all. We tested all three modes live and the server announces its mode at start-up for audit.</a:t>
             </a:r>
           </a:p>
         </p:txBody>
@@ -1216,7 +1216,7 @@
           <a:lstStyle/>
           <a:p>
             <a:r>
-              <a:t>The requirement is absolute: CAD data must never leave our network. Here is the finding that makes this project straightforward: it already doesn't. We audited every outbound connection in the source code. CAD models are processed in memory, inside our server, by the local geometry engine — they are not even saved to disk. The only traffic that leaves today is the AI layer — photographs and derived summaries — plus two optional public feeds we can simply switch off. So the job is not a redesign; it is closing one connection.</a:t>
+              <a:t>The requirement is absolute: CAD data must never leave our network. Here is the finding that makes this project straightforward: it already doesn't. We audited every outbound connection in the source code. CAD models are processed in memory, inside our server, by the local geometry engine — they are not even saved to disk. The only traffic that leaves today is the AI layer — photographs and derived summaries — plus two optional public feeds. And here is the update since the written plan: the controls that close this gap are already built. Every AI call now goes through one switchboard that can be pointed at a private endpoint or switched off entirely, and we tested all three modes live. So the job is not a redesign — the software side is done; what remains is infrastructure.</a:t>
             </a:r>
           </a:p>
         </p:txBody>
@@ -1286,7 +1286,7 @@
           <a:lstStyle/>
           <a:p>
             <a:r>
-              <a:t>The whole security story on one slide. Green, left: what already stays inside — CAD processing, all cost engines, the learning loop, reports. That is the overwhelming majority of the platform. Amber, right: the three flows that currently go out. The AI layer is the one that matters — photos and derived summaries — and the next slides show how we bring it under our control. The other two are optional conveniences we simply switch off.</a:t>
+              <a:t>The whole security story on one slide. Green, left: what already stays inside — CAD processing, all cost engines, the learning loop, reports. That is the overwhelming majority of the platform. Amber, right: the three flows that go out — and all three are now under our control in the shipped code. The AI layer is the one that matters — photos and derived summaries — and its private routing is built: one setting points every call at our own endpoint. The other two are optional conveniences, and the new air-gapped switch silences them along with everything else, which we verified live.</a:t>
             </a:r>
           </a:p>
         </p:txBody>
@@ -1356,7 +1356,7 @@
           <a:lstStyle/>
           <a:p>
             <a:r>
-              <a:t>Three ways to deploy. Option A: fully air-gapped — everything on our machines, zero external connections, available today, but the vision AI features are reduced. Option C is the public API — I include it only to reject it, because photos would traverse a public endpoint. Option B is our recommendation: the platform runs on-premise, and the AI model runs in OUR OWN cloud tenancy, reached over a private link with a no-data-retention configuration. Full capability, and both contractual and technical control of the data. And note — the two options combine: the most sensitive programmes can run air-gapped while the rest use B.</a:t>
+              <a:t>Three ways to deploy. Option A: fully air-gapped — everything on our machines, zero external connections, and the switch that enforces it is already implemented and tested; but the vision AI features are reduced. Option C is the public API — I include it only to reject it, because photos would traverse a public endpoint. Option B is our recommendation: the platform runs on-premise, and the AI model runs in OUR OWN cloud tenancy, reached over a private link with a no-data-retention configuration. The routing for this is also already built — a single setting points every AI call at our endpoint; we demonstrated it live. So the software work for both A and B is done; the remaining effort is infrastructure and sign-off. And note — the two options combine: the most sensitive programmes can run air-gapped while the rest use B.</a:t>
             </a:r>
           </a:p>
         </p:txBody>
@@ -1496,7 +1496,7 @@
           <a:lstStyle/>
           <a:p>
             <a:r>
-              <a:t>Function by function: where does CAD data actually go? Opening and measuring the model, detecting features, extracting BOMs, calculating cost — all of it already happens inside our backend, verified in code. The single amber row is photo analysis and AI narrative, which moves to the private AI endpoint. And note the last row — CostVision never stores CAD files at all; they are processed in memory and released. We will also give security an air-gapped switch so they can prove zero egress in a witnessed test, not take our word for it.</a:t>
+              <a:t>Function by function: where does CAD data actually go? Opening and measuring the model, detecting features, extracting BOMs, calculating cost — all of it already happens inside our backend, verified in code. The single amber row is photo analysis and AI narrative — and the routing for it is now built: one configuration value points it at the private endpoint. And note the last row — CostVision never stores CAD files at all; they are processed in memory and released. Finally, the air-gapped switch is no longer a promise — it is built and tested, so security can prove zero egress in a witnessed firewall test rather than take our word for it.</a:t>
             </a:r>
           </a:p>
         </p:txBody>
@@ -4760,7 +4760,7 @@
               </a:spcAft>
             </a:pPr>
             <a:r>
-              <a:rPr sz="4200" b="1" i="0">
+              <a:rPr sz="3600" b="1" i="0">
                 <a:solidFill>
                   <a:srgbClr val="0F172A"/>
                 </a:solidFill>
@@ -4937,7 +4937,7 @@
                 </a:solidFill>
                 <a:latin typeface="Calibri"/>
               </a:rPr>
-              <a:t>CAPEE integration ready</a:t>
+              <a:t>AI controls BUILT &amp; tested</a:t>
             </a:r>
           </a:p>
         </p:txBody>
@@ -4992,7 +4992,7 @@
                 </a:solidFill>
                 <a:latin typeface="Calibri"/>
               </a:rPr>
-              <a:t>4–6 weeks of changes</a:t>
+              <a:t>~3–5 weeks remaining</a:t>
             </a:r>
           </a:p>
         </p:txBody>
@@ -6735,7 +6735,7 @@
                 </a:solidFill>
                 <a:latin typeface="Calibri"/>
               </a:rPr>
-              <a:t>CostVision — 6 bounded items</a:t>
+              <a:t>CostVision — 6 items (2 DONE)</a:t>
             </a:r>
           </a:p>
         </p:txBody>
@@ -6773,20 +6773,20 @@
             <a:r>
               <a:rPr sz="1200" b="1" i="0">
                 <a:solidFill>
-                  <a:srgbClr val="0F172A"/>
-                </a:solidFill>
-                <a:latin typeface="Calibri"/>
-              </a:rPr>
-              <a:t>1. Private AI routing — </a:t>
+                  <a:srgbClr val="059669"/>
+                </a:solidFill>
+                <a:latin typeface="Calibri"/>
+              </a:rPr>
+              <a:t>✓ Private AI routing — </a:t>
             </a:r>
             <a:r>
               <a:rPr sz="1100" b="0" i="0">
                 <a:solidFill>
-                  <a:srgbClr val="334155"/>
-                </a:solidFill>
-                <a:latin typeface="Calibri"/>
-              </a:rPr>
-              <a:t>point the AI client at our endpoint (config + small factory)</a:t>
+                  <a:srgbClr val="059669"/>
+                </a:solidFill>
+                <a:latin typeface="Calibri"/>
+              </a:rPr>
+              <a:t>DONE — one setting routes every AI call to our endpoint</a:t>
             </a:r>
           </a:p>
         </p:txBody>
@@ -6824,20 +6824,20 @@
             <a:r>
               <a:rPr sz="1200" b="1" i="0">
                 <a:solidFill>
-                  <a:srgbClr val="0F172A"/>
-                </a:solidFill>
-                <a:latin typeface="Calibri"/>
-              </a:rPr>
-              <a:t>2. "Air-gapped" switch — </a:t>
+                  <a:srgbClr val="059669"/>
+                </a:solidFill>
+                <a:latin typeface="Calibri"/>
+              </a:rPr>
+              <a:t>✓ "Air-gapped" switch — </a:t>
             </a:r>
             <a:r>
               <a:rPr sz="1100" b="0" i="0">
                 <a:solidFill>
-                  <a:srgbClr val="334155"/>
-                </a:solidFill>
-                <a:latin typeface="Calibri"/>
-              </a:rPr>
-              <a:t>provably disable all external calls</a:t>
+                  <a:srgbClr val="059669"/>
+                </a:solidFill>
+                <a:latin typeface="Calibri"/>
+              </a:rPr>
+              <a:t>DONE — provably disables all external calls; tested live</a:t>
             </a:r>
           </a:p>
         </p:txBody>
@@ -7381,7 +7381,7 @@
                 </a:solidFill>
                 <a:latin typeface="Calibri"/>
               </a:rPr>
-              <a:t>Total critical path: ~4–6 engineering weeks. No architectural surgery on either side.</a:t>
+              <a:t>Items 1–2 are built &amp; tested. Remaining critical path: ~3–5 engineering weeks. No architectural surgery on either side.</a:t>
             </a:r>
           </a:p>
         </p:txBody>
@@ -8232,7 +8232,7 @@
                 </a:solidFill>
                 <a:latin typeface="Calibri"/>
               </a:rPr>
-              <a:t>One AI exit door, inspected and logged; firewall denies everything else; witnessed air-gap test</a:t>
+              <a:t>One AI exit door, inspected and logged; firewall denies everything else; witnessed air-gap test (switch built)</a:t>
             </a:r>
           </a:p>
         </p:txBody>
@@ -10754,7 +10754,7 @@
                 </a:solidFill>
                 <a:latin typeface="Calibri"/>
               </a:rPr>
-              <a:t>790 automated tests, written architecture docs, and a named CAPEE-side maintainer trained during Phase 4.</a:t>
+              <a:t>793 automated tests, written architecture docs, and a named CAPEE-side maintainer trained during Phase 4.</a:t>
             </a:r>
           </a:p>
         </p:txBody>
@@ -11438,7 +11438,7 @@
                 </a:solidFill>
                 <a:latin typeface="Calibri"/>
               </a:rPr>
-              <a:t>FEASIBLE — CAD already never leaves; one AI endpoint change closes the gap</a:t>
+              <a:t>FEASIBLE — CAD never leaves; AI routing + air-gap switch already BUILT</a:t>
             </a:r>
           </a:p>
         </p:txBody>
@@ -11698,7 +11698,7 @@
                 </a:solidFill>
                 <a:latin typeface="Calibri"/>
               </a:rPr>
-              <a:t>Bounded: ~4–6 engineering weeks critical path</a:t>
+              <a:t>Head start delivered: 2 of 6 items built — ~3–5 engineering weeks remain</a:t>
             </a:r>
           </a:p>
         </p:txBody>
@@ -12569,7 +12569,7 @@
                 </a:solidFill>
                 <a:latin typeface="Calibri"/>
               </a:rPr>
-              <a:t>The tool is built, tested (790 automated tests) and proven on live runs — the value is waiting on deployment, not development.</a:t>
+              <a:t>The tool is built, tested (793 automated tests) and proven on live runs — the value is waiting on deployment, not development.</a:t>
             </a:r>
           </a:p>
         </p:txBody>
@@ -12743,7 +12743,7 @@
                 </a:solidFill>
                 <a:latin typeface="Calibri"/>
               </a:rPr>
-              <a:t>CAD processing already runs fully inside the server. One configuration change closes the only external AI connection.</a:t>
+              <a:t>CAD processing already runs fully inside the server. The private AI routing and the air-gapped switch are now BUILT and tested live.</a:t>
             </a:r>
           </a:p>
         </p:txBody>
@@ -14039,7 +14039,7 @@
                 </a:solidFill>
                 <a:latin typeface="Calibri"/>
               </a:rPr>
-              <a:t>estimating error cut from 10.9% to 0.3% after learning from 3 real quotes  ·  £512k/yr of pricing issues found autonomously in the live demo  ·  790 automated tests protect it all.</a:t>
+              <a:t>estimating error cut from 10.9% to 0.3% after learning from 3 real quotes  ·  £512k/yr of pricing issues found autonomously in the live demo  ·  793 automated tests protect it all.</a:t>
             </a:r>
           </a:p>
         </p:txBody>
@@ -15298,7 +15298,7 @@
             <a:avLst/>
           </a:prstGeom>
           <a:solidFill>
-            <a:srgbClr val="D97706"/>
+            <a:srgbClr val="059669"/>
           </a:solidFill>
           <a:ln>
             <a:noFill/>
@@ -15360,7 +15360,7 @@
             <a:r>
               <a:rPr sz="1500" b="1" i="0">
                 <a:solidFill>
-                  <a:srgbClr val="D97706"/>
+                  <a:srgbClr val="059669"/>
                 </a:solidFill>
                 <a:latin typeface="Calibri"/>
               </a:rPr>
@@ -15448,7 +15448,7 @@
                 </a:solidFill>
                 <a:latin typeface="Calibri"/>
               </a:rPr>
-              <a:t>The AI model used for vision and language tasks. Today it calls an external API — the ONE connection this blueprint moves inside our control.</a:t>
+              <a:t>The AI model used for vision and language tasks. NOW BUILT: one switchboard controls every AI call — route it to a private endpoint, or turn it fully OFF (air-gapped).</a:t>
             </a:r>
           </a:p>
         </p:txBody>
@@ -15990,7 +15990,7 @@
                 </a:solidFill>
                 <a:latin typeface="Calibri"/>
               </a:rPr>
-              <a:t>The geometry engine runs inside our backend and processes CAD models in memory — files are not even written to disk, let alone sent anywhere. The only outbound flows are the AI layer (photos and derived summaries) and two optional public feeds. One endpoint change closes the gap.</a:t>
+              <a:t>The geometry engine runs inside our backend and processes CAD models in memory — files are not even written to disk, let alone sent anywhere. The only outbound flows are the AI layer (photos and derived summaries) and two optional public feeds. The controls that close this gap are now BUILT: private AI routing and a provable air-gapped switch, tested live in all three modes.</a:t>
             </a:r>
           </a:p>
         </p:txBody>
@@ -16966,7 +16966,7 @@
                 </a:solidFill>
                 <a:latin typeface="Calibri"/>
               </a:rPr>
-              <a:t>LEAVES TODAY — to fix</a:t>
+              <a:t>LEAVES TODAY — controlled ✓</a:t>
             </a:r>
           </a:p>
         </p:txBody>
@@ -17071,7 +17071,7 @@
                 </a:solidFill>
                 <a:latin typeface="Calibri"/>
               </a:rPr>
-              <a:t>Part/PCB photos + CAD-derived summaries → route to a private AI endpoint (§ next slides)</a:t>
+              <a:t>Photos + CAD-derived summaries. Private routing BUILT — one setting points every call at our endpoint</a:t>
             </a:r>
           </a:p>
         </p:txBody>
@@ -17176,7 +17176,7 @@
                 </a:solidFill>
                 <a:latin typeface="Calibri"/>
               </a:rPr>
-              <a:t>Part-number text only — keep off, or approve separately</a:t>
+              <a:t>Part-number text only — silenced by the air-gap switch</a:t>
             </a:r>
           </a:p>
         </p:txBody>
@@ -17281,7 +17281,7 @@
                 </a:solidFill>
                 <a:latin typeface="Calibri"/>
               </a:rPr>
-              <a:t>Public news fetch, no company data — switch off or proxy</a:t>
+              <a:t>Public news, no company data — silenced by the air-gap switch</a:t>
             </a:r>
           </a:p>
         </p:txBody>
@@ -17826,7 +17826,7 @@
                 </a:solidFill>
                 <a:latin typeface="Calibri"/>
               </a:rPr>
-              <a:t>Everything on our VMs. AI features off (or a self-hosted model later). Deterministic engines fully working.</a:t>
+              <a:t>Everything on our VMs. AI features off via the built-in AIR-GAPPED switch (already implemented and tested). Deterministic engines fully working.</a:t>
             </a:r>
           </a:p>
         </p:txBody>
@@ -17877,7 +17877,7 @@
                 </a:solidFill>
                 <a:latin typeface="Calibri"/>
               </a:rPr>
-              <a:t>Zero external connections — provable today</a:t>
+              <a:t>Zero external connections — provable today, switch is built</a:t>
             </a:r>
           </a:p>
         </p:txBody>
@@ -18195,7 +18195,7 @@
                 </a:solidFill>
                 <a:latin typeface="Calibri"/>
               </a:rPr>
-              <a:t>Full capability + contractual &amp; technical data control</a:t>
+              <a:t>Full capability + data control — routing already BUILT (one setting)</a:t>
             </a:r>
           </a:p>
         </p:txBody>
@@ -18606,7 +18606,7 @@
                 </a:solidFill>
                 <a:latin typeface="Calibri"/>
               </a:rPr>
-              <a:t>Recommendation: Option B — with Option A available immediately for the most sensitive programmes.</a:t>
+              <a:t>Recommendation: Option B — the software for BOTH A and B is already built; what remains is infrastructure sign-off.</a:t>
             </a:r>
           </a:p>
         </p:txBody>
@@ -21231,7 +21231,7 @@
                 </a:solidFill>
                 <a:latin typeface="Calibri"/>
               </a:rPr>
-              <a:t>→  The one change we make</a:t>
+              <a:t>→  Routing BUILT — set one value</a:t>
             </a:r>
           </a:p>
         </p:txBody>
@@ -21445,7 +21445,7 @@
                 </a:solidFill>
                 <a:latin typeface="Calibri"/>
               </a:rPr>
-              <a:t>Plus: logs never contain CAD payloads; metadata goes to the corporate SIEM; an "air-gapped" switch lets security PROVE zero egress in a witnessed firewall test.</a:t>
+              <a:t>Plus: logs never contain CAD payloads; metadata goes to the corporate SIEM; and the "air-gapped" switch is now BUILT &amp; tested — security can PROVE zero egress in a witnessed firewall test.</a:t>
             </a:r>
           </a:p>
         </p:txBody>

</xml_diff>

<commit_message>
Blueprint deck: add 2 backup slides on market landscape & differentiation
Slide 16 answers 'has anyone done this?' — established should-cost vendors
(aPriori, Siemens PCM, Tset/A2MAC1, Boothroyd DFMA, new AI entrants) with
source links on-slide. Slide 17 covers what no vendor offers today (PCB
photo-to-BOM costing, self-learning on own PO data, on-prem/air-gap
deployment, single-platform breadth), an honest data-depth caveat, and the
positioning line. Speaker notes on both.

Co-Authored-By: Claude Fable 5 <noreply@anthropic.com>
Claude-Session: https://claude.ai/code/session_0142L4rKS2AV8rxQTDWMs7dy
</commit_message>
<xml_diff>
--- a/CostVision-Implementation-Blueprint.pptx
+++ b/CostVision-Implementation-Blueprint.pptx
@@ -20,6 +20,8 @@
     <p:sldId id="268" r:id="rId20"/>
     <p:sldId id="269" r:id="rId21"/>
     <p:sldId id="270" r:id="rId22"/>
+    <p:sldId id="271" r:id="rId23"/>
+    <p:sldId id="272" r:id="rId24"/>
   </p:sldIdLst>
   <p:sldSz cx="12191695" cy="6858000" type="screen4x3"/>
   <p:notesSz cx="6858000" cy="9144000"/>
@@ -937,6 +939,146 @@
           <a:p>
             <a:r>
               <a:t>To summarise: secure deployment with CAD fully internal is feasible — in fact, the platform was built that way, and the two controls that complete it — private AI routing and the air-gapped switch — are already built, tested and demonstrated live. CAPEE integration is feasible and high-value, with CAPEE remaining the front door. The remaining changes are bounded — roughly three to five weeks, not months — and governance is defined. The ask today is simple: approve Phases 1 and 2, the security assessment and the architecture design. The full written plan, including the security checklist, is ready to hand to the IT-Security team. Thank you — questions welcome.</a:t>
+            </a:r>
+          </a:p>
+        </p:txBody>
+      </p:sp>
+      <p:sp>
+        <p:nvSpPr>
+          <p:cNvPr id="4" name="Slide Number Placeholder 3"/>
+          <p:cNvSpPr>
+            <a:spLocks noGrp="1"/>
+          </p:cNvSpPr>
+          <p:nvPr>
+            <p:ph type="sldNum" idx="5" sz="quarter"/>
+          </p:nvPr>
+        </p:nvSpPr>
+        <p:spPr/>
+      </p:sp>
+    </p:spTree>
+  </p:cSld>
+  <p:clrMapOvr>
+    <a:masterClrMapping/>
+  </p:clrMapOvr>
+</p:notes>
+</file>
+
+<file path=ppt/notesSlides/notesSlide16.xml><?xml version="1.0" encoding="utf-8"?>
+<p:notes xmlns:a="http://schemas.openxmlformats.org/drawingml/2006/main" xmlns:p="http://schemas.openxmlformats.org/presentationml/2006/main" xmlns:r="http://schemas.openxmlformats.org/officeDocument/2006/relationships">
+  <p:cSld>
+    <p:spTree>
+      <p:nvGrpSpPr>
+        <p:cNvPr id="1" name=""/>
+        <p:cNvGrpSpPr/>
+        <p:nvPr/>
+      </p:nvGrpSpPr>
+      <p:grpSpPr>
+        <a:xfrm>
+          <a:off x="0" y="0"/>
+          <a:ext cx="0" cy="0"/>
+          <a:chOff x="0" y="0"/>
+          <a:chExt cx="0" cy="0"/>
+        </a:xfrm>
+      </p:grpSpPr>
+      <p:sp>
+        <p:nvSpPr>
+          <p:cNvPr id="2" name="Slide Image Placeholder 1"/>
+          <p:cNvSpPr>
+            <a:spLocks noGrp="1"/>
+          </p:cNvSpPr>
+          <p:nvPr>
+            <p:ph type="sldImg" idx="2"/>
+          </p:nvPr>
+        </p:nvSpPr>
+        <p:spPr/>
+      </p:sp>
+      <p:sp>
+        <p:nvSpPr>
+          <p:cNvPr id="3" name="Notes Placeholder 2"/>
+          <p:cNvSpPr>
+            <a:spLocks noGrp="1"/>
+          </p:cNvSpPr>
+          <p:nvPr>
+            <p:ph type="body" idx="3" sz="quarter"/>
+          </p:nvPr>
+        </p:nvSpPr>
+        <p:spPr/>
+        <p:txBody>
+          <a:bodyPr/>
+          <a:lstStyle/>
+          <a:p>
+            <a:r>
+              <a:t>Backup slide, for the question 'has anyone done this before — are we the only ones?' The answer is reassuring in both directions. No, we are not inventing an unproven category: should-cost software is an established market. aPriori is the leader — CAD-to-cost with physics models, sold to exactly our kind of company. Siemens ships it inside the PLM suite. Tset is the automotive AI challenger — and notably A2MAC1 agreed to acquire them in June 2026 specifically to build AI-enabled costing intelligence, which tells you the whole market believes in the direction we've already built. Boothroyd Dewhurst is the classic methodology, and a wave of AI start-ups is doing CAD-to-quote. So the category is validated by the market. The real question is why our own tool rather than buying one — and that's the next slide.</a:t>
+            </a:r>
+          </a:p>
+        </p:txBody>
+      </p:sp>
+      <p:sp>
+        <p:nvSpPr>
+          <p:cNvPr id="4" name="Slide Number Placeholder 3"/>
+          <p:cNvSpPr>
+            <a:spLocks noGrp="1"/>
+          </p:cNvSpPr>
+          <p:nvPr>
+            <p:ph type="sldNum" idx="5" sz="quarter"/>
+          </p:nvPr>
+        </p:nvSpPr>
+        <p:spPr/>
+      </p:sp>
+    </p:spTree>
+  </p:cSld>
+  <p:clrMapOvr>
+    <a:masterClrMapping/>
+  </p:clrMapOvr>
+</p:notes>
+</file>
+
+<file path=ppt/notesSlides/notesSlide17.xml><?xml version="1.0" encoding="utf-8"?>
+<p:notes xmlns:a="http://schemas.openxmlformats.org/drawingml/2006/main" xmlns:p="http://schemas.openxmlformats.org/presentationml/2006/main" xmlns:r="http://schemas.openxmlformats.org/officeDocument/2006/relationships">
+  <p:cSld>
+    <p:spTree>
+      <p:nvGrpSpPr>
+        <p:cNvPr id="1" name=""/>
+        <p:cNvGrpSpPr/>
+        <p:nvPr/>
+      </p:nvGrpSpPr>
+      <p:grpSpPr>
+        <a:xfrm>
+          <a:off x="0" y="0"/>
+          <a:ext cx="0" cy="0"/>
+          <a:chOff x="0" y="0"/>
+          <a:chExt cx="0" cy="0"/>
+        </a:xfrm>
+      </p:grpSpPr>
+      <p:sp>
+        <p:nvSpPr>
+          <p:cNvPr id="2" name="Slide Image Placeholder 1"/>
+          <p:cNvSpPr>
+            <a:spLocks noGrp="1"/>
+          </p:cNvSpPr>
+          <p:nvPr>
+            <p:ph type="sldImg" idx="2"/>
+          </p:nvPr>
+        </p:nvSpPr>
+        <p:spPr/>
+      </p:sp>
+      <p:sp>
+        <p:nvSpPr>
+          <p:cNvPr id="3" name="Notes Placeholder 2"/>
+          <p:cNvSpPr>
+            <a:spLocks noGrp="1"/>
+          </p:cNvSpPr>
+          <p:nvPr>
+            <p:ph type="body" idx="3" sz="quarter"/>
+          </p:nvPr>
+        </p:nvSpPr>
+        <p:spPr/>
+        <p:txBody>
+          <a:bodyPr/>
+          <a:lstStyle/>
+          <a:p>
+            <a:r>
+              <a:t>The second half of the backup answer: given the market exists, why build our own? Four things no vendor offers today. One — photo-to-cost for PCBs: photograph a supplier's or competitor's board and get a costed bill of materials; design tools generate BOMs during design, but no costing suite does this from photos. Two — the self-learning loop: CostVision calibrates on our own purchase-order prices, cutting error from about eleven percent to under one percent in testing after just three quotes, and raises findings on its own; the incumbents are only now marketing toward AI-enabled costing. Three — deployment: the commercial tools are cloud SaaS, meaning our CAD and our rates would sit in a vendor's cloud; CostVision runs inside our network with the private-AI and air-gap controls already built. Four — breadth without per-module licences. And the honest caveat management should hear: aPriori's strength is decades of curated cost data. Our counter is that every quote CAPEE logs makes CostVision smarter on OUR parts, OUR suppliers, OUR regions — data no vendor has. The positioning is not 'better than aPriori'; it is an internal, secure, self-learning engine behind CAPEE.</a:t>
             </a:r>
           </a:p>
         </p:txBody>
@@ -11971,6 +12113,2928 @@
           <a:lstStyle/>
           <a:p>
             <a:pPr algn="ctr"/>
+          </a:p>
+        </p:txBody>
+      </p:sp>
+    </p:spTree>
+  </p:cSld>
+  <p:clrMapOvr>
+    <a:masterClrMapping/>
+  </p:clrMapOvr>
+</p:sld>
+</file>
+
+<file path=ppt/slides/slide16.xml><?xml version="1.0" encoding="utf-8"?>
+<p:sld xmlns:a="http://schemas.openxmlformats.org/drawingml/2006/main" xmlns:p="http://schemas.openxmlformats.org/presentationml/2006/main" xmlns:r="http://schemas.openxmlformats.org/officeDocument/2006/relationships">
+  <p:cSld>
+    <p:spTree>
+      <p:nvGrpSpPr>
+        <p:cNvPr id="1" name=""/>
+        <p:cNvGrpSpPr/>
+        <p:nvPr/>
+      </p:nvGrpSpPr>
+      <p:grpSpPr/>
+      <p:sp>
+        <p:nvSpPr>
+          <p:cNvPr id="2" name="Rectangle 1"/>
+          <p:cNvSpPr/>
+          <p:nvPr/>
+        </p:nvSpPr>
+        <p:spPr>
+          <a:xfrm>
+            <a:off x="0" y="0"/>
+            <a:ext cx="12191695" cy="6858000"/>
+          </a:xfrm>
+          <a:prstGeom prst="rect">
+            <a:avLst/>
+          </a:prstGeom>
+          <a:solidFill>
+            <a:srgbClr val="FFFFFF"/>
+          </a:solidFill>
+          <a:ln>
+            <a:noFill/>
+          </a:ln>
+          <a:effectLst/>
+        </p:spPr>
+        <p:style>
+          <a:lnRef idx="1">
+            <a:schemeClr val="accent1"/>
+          </a:lnRef>
+          <a:fillRef idx="3">
+            <a:schemeClr val="accent1"/>
+          </a:fillRef>
+          <a:effectRef idx="2">
+            <a:schemeClr val="accent1"/>
+          </a:effectRef>
+          <a:fontRef idx="minor">
+            <a:schemeClr val="lt1"/>
+          </a:fontRef>
+        </p:style>
+        <p:txBody>
+          <a:bodyPr rtlCol="0" anchor="ctr"/>
+          <a:lstStyle/>
+          <a:p>
+            <a:pPr algn="ctr"/>
+          </a:p>
+        </p:txBody>
+      </p:sp>
+      <p:sp>
+        <p:nvSpPr>
+          <p:cNvPr id="3" name="Rounded Rectangle 2"/>
+          <p:cNvSpPr/>
+          <p:nvPr/>
+        </p:nvSpPr>
+        <p:spPr>
+          <a:xfrm>
+            <a:off x="320040" y="201168"/>
+            <a:ext cx="384048" cy="384048"/>
+          </a:xfrm>
+          <a:prstGeom prst="roundRect">
+            <a:avLst>
+              <a:gd name="adj" fmla="val 28000"/>
+            </a:avLst>
+          </a:prstGeom>
+          <a:solidFill>
+            <a:srgbClr val="4F46E5"/>
+          </a:solidFill>
+          <a:ln>
+            <a:noFill/>
+          </a:ln>
+          <a:effectLst/>
+        </p:spPr>
+        <p:style>
+          <a:lnRef idx="1">
+            <a:schemeClr val="accent1"/>
+          </a:lnRef>
+          <a:fillRef idx="3">
+            <a:schemeClr val="accent1"/>
+          </a:fillRef>
+          <a:effectRef idx="2">
+            <a:schemeClr val="accent1"/>
+          </a:effectRef>
+          <a:fontRef idx="minor">
+            <a:schemeClr val="lt1"/>
+          </a:fontRef>
+        </p:style>
+        <p:txBody>
+          <a:bodyPr rtlCol="0" anchor="ctr" lIns="0" rIns="0" tIns="0" bIns="0"/>
+          <a:lstStyle/>
+          <a:p>
+            <a:pPr algn="ctr"/>
+            <a:r>
+              <a:rPr sz="1700" b="1">
+                <a:solidFill>
+                  <a:srgbClr val="FFFFFF"/>
+                </a:solidFill>
+                <a:latin typeface="Calibri"/>
+              </a:rPr>
+              <a:t>cv</a:t>
+            </a:r>
+          </a:p>
+        </p:txBody>
+      </p:sp>
+      <p:sp>
+        <p:nvSpPr>
+          <p:cNvPr id="4" name="TextBox 3"/>
+          <p:cNvSpPr txBox="1"/>
+          <p:nvPr/>
+        </p:nvSpPr>
+        <p:spPr>
+          <a:xfrm>
+            <a:off x="795528" y="173736"/>
+            <a:ext cx="2377440" cy="292608"/>
+          </a:xfrm>
+          <a:prstGeom prst="rect">
+            <a:avLst/>
+          </a:prstGeom>
+          <a:noFill/>
+        </p:spPr>
+        <p:txBody>
+          <a:bodyPr wrap="square" anchor="t" lIns="0" rIns="0" tIns="0" bIns="0">
+            <a:spAutoFit/>
+          </a:bodyPr>
+          <a:lstStyle/>
+          <a:p>
+            <a:pPr algn="l">
+              <a:lnSpc>
+                <a:spcPct val="100000"/>
+              </a:lnSpc>
+              <a:spcAft>
+                <a:spcPts val="400"/>
+              </a:spcAft>
+            </a:pPr>
+            <a:r>
+              <a:rPr sz="1800" b="1" i="0">
+                <a:solidFill>
+                  <a:srgbClr val="2563EB"/>
+                </a:solidFill>
+                <a:latin typeface="Calibri"/>
+              </a:rPr>
+              <a:t>CostVision</a:t>
+            </a:r>
+          </a:p>
+        </p:txBody>
+      </p:sp>
+      <p:sp>
+        <p:nvSpPr>
+          <p:cNvPr id="5" name="TextBox 4"/>
+          <p:cNvSpPr txBox="1"/>
+          <p:nvPr/>
+        </p:nvSpPr>
+        <p:spPr>
+          <a:xfrm>
+            <a:off x="795528" y="420624"/>
+            <a:ext cx="2560320" cy="201168"/>
+          </a:xfrm>
+          <a:prstGeom prst="rect">
+            <a:avLst/>
+          </a:prstGeom>
+          <a:noFill/>
+        </p:spPr>
+        <p:txBody>
+          <a:bodyPr wrap="square" anchor="t" lIns="0" rIns="0" tIns="0" bIns="0">
+            <a:spAutoFit/>
+          </a:bodyPr>
+          <a:lstStyle/>
+          <a:p>
+            <a:pPr algn="l">
+              <a:lnSpc>
+                <a:spcPct val="100000"/>
+              </a:lnSpc>
+              <a:spcAft>
+                <a:spcPts val="400"/>
+              </a:spcAft>
+            </a:pPr>
+            <a:r>
+              <a:rPr sz="750" b="0" i="0">
+                <a:solidFill>
+                  <a:srgbClr val="64748B"/>
+                </a:solidFill>
+                <a:latin typeface="Calibri"/>
+              </a:rPr>
+              <a:t>AI  COST  INTELLIGENCE</a:t>
+            </a:r>
+          </a:p>
+        </p:txBody>
+      </p:sp>
+      <p:sp>
+        <p:nvSpPr>
+          <p:cNvPr id="6" name="Rectangle 5"/>
+          <p:cNvSpPr/>
+          <p:nvPr/>
+        </p:nvSpPr>
+        <p:spPr>
+          <a:xfrm>
+            <a:off x="0" y="713232"/>
+            <a:ext cx="12191695" cy="27940"/>
+          </a:xfrm>
+          <a:prstGeom prst="rect">
+            <a:avLst/>
+          </a:prstGeom>
+          <a:solidFill>
+            <a:srgbClr val="4F46E5"/>
+          </a:solidFill>
+          <a:ln>
+            <a:noFill/>
+          </a:ln>
+          <a:effectLst/>
+        </p:spPr>
+        <p:style>
+          <a:lnRef idx="1">
+            <a:schemeClr val="accent1"/>
+          </a:lnRef>
+          <a:fillRef idx="3">
+            <a:schemeClr val="accent1"/>
+          </a:fillRef>
+          <a:effectRef idx="2">
+            <a:schemeClr val="accent1"/>
+          </a:effectRef>
+          <a:fontRef idx="minor">
+            <a:schemeClr val="lt1"/>
+          </a:fontRef>
+        </p:style>
+        <p:txBody>
+          <a:bodyPr rtlCol="0" anchor="ctr"/>
+          <a:lstStyle/>
+          <a:p>
+            <a:pPr algn="ctr"/>
+          </a:p>
+        </p:txBody>
+      </p:sp>
+      <p:sp>
+        <p:nvSpPr>
+          <p:cNvPr id="7" name="TextBox 6"/>
+          <p:cNvSpPr txBox="1"/>
+          <p:nvPr/>
+        </p:nvSpPr>
+        <p:spPr>
+          <a:xfrm>
+            <a:off x="411480" y="868680"/>
+            <a:ext cx="10515600" cy="274320"/>
+          </a:xfrm>
+          <a:prstGeom prst="rect">
+            <a:avLst/>
+          </a:prstGeom>
+          <a:noFill/>
+        </p:spPr>
+        <p:txBody>
+          <a:bodyPr wrap="square" anchor="t" lIns="0" rIns="0" tIns="0" bIns="0">
+            <a:spAutoFit/>
+          </a:bodyPr>
+          <a:lstStyle/>
+          <a:p>
+            <a:pPr algn="l">
+              <a:lnSpc>
+                <a:spcPct val="100000"/>
+              </a:lnSpc>
+              <a:spcAft>
+                <a:spcPts val="400"/>
+              </a:spcAft>
+            </a:pPr>
+            <a:r>
+              <a:rPr sz="1100" b="1" i="0">
+                <a:solidFill>
+                  <a:srgbClr val="2563EB"/>
+                </a:solidFill>
+                <a:latin typeface="Calibri"/>
+              </a:rPr>
+              <a:t>BACKUP · MARKET LANDSCAPE</a:t>
+            </a:r>
+          </a:p>
+        </p:txBody>
+      </p:sp>
+      <p:sp>
+        <p:nvSpPr>
+          <p:cNvPr id="8" name="TextBox 7"/>
+          <p:cNvSpPr txBox="1"/>
+          <p:nvPr/>
+        </p:nvSpPr>
+        <p:spPr>
+          <a:xfrm>
+            <a:off x="411480" y="1115568"/>
+            <a:ext cx="11338560" cy="548640"/>
+          </a:xfrm>
+          <a:prstGeom prst="rect">
+            <a:avLst/>
+          </a:prstGeom>
+          <a:noFill/>
+        </p:spPr>
+        <p:txBody>
+          <a:bodyPr wrap="square" anchor="t" lIns="0" rIns="0" tIns="0" bIns="0">
+            <a:spAutoFit/>
+          </a:bodyPr>
+          <a:lstStyle/>
+          <a:p>
+            <a:pPr algn="l">
+              <a:lnSpc>
+                <a:spcPct val="100000"/>
+              </a:lnSpc>
+              <a:spcAft>
+                <a:spcPts val="400"/>
+              </a:spcAft>
+            </a:pPr>
+            <a:r>
+              <a:rPr sz="2700" b="1" i="0">
+                <a:solidFill>
+                  <a:srgbClr val="0F172A"/>
+                </a:solidFill>
+                <a:latin typeface="Calibri"/>
+              </a:rPr>
+              <a:t>Has anyone done this? Yes — the market is real</a:t>
+            </a:r>
+          </a:p>
+        </p:txBody>
+      </p:sp>
+      <p:sp>
+        <p:nvSpPr>
+          <p:cNvPr id="9" name="Rounded Rectangle 8"/>
+          <p:cNvSpPr/>
+          <p:nvPr/>
+        </p:nvSpPr>
+        <p:spPr>
+          <a:xfrm>
+            <a:off x="411480" y="1810512"/>
+            <a:ext cx="11384280" cy="713232"/>
+          </a:xfrm>
+          <a:prstGeom prst="roundRect">
+            <a:avLst>
+              <a:gd name="adj" fmla="val 14000"/>
+            </a:avLst>
+          </a:prstGeom>
+          <a:solidFill>
+            <a:srgbClr val="F1F5F9"/>
+          </a:solidFill>
+          <a:ln>
+            <a:noFill/>
+          </a:ln>
+          <a:effectLst/>
+        </p:spPr>
+        <p:style>
+          <a:lnRef idx="1">
+            <a:schemeClr val="accent1"/>
+          </a:lnRef>
+          <a:fillRef idx="3">
+            <a:schemeClr val="accent1"/>
+          </a:fillRef>
+          <a:effectRef idx="2">
+            <a:schemeClr val="accent1"/>
+          </a:effectRef>
+          <a:fontRef idx="minor">
+            <a:schemeClr val="lt1"/>
+          </a:fontRef>
+        </p:style>
+        <p:txBody>
+          <a:bodyPr rtlCol="0" anchor="ctr"/>
+          <a:lstStyle/>
+          <a:p>
+            <a:pPr algn="ctr"/>
+          </a:p>
+        </p:txBody>
+      </p:sp>
+      <p:sp>
+        <p:nvSpPr>
+          <p:cNvPr id="10" name="Rectangle 9"/>
+          <p:cNvSpPr/>
+          <p:nvPr/>
+        </p:nvSpPr>
+        <p:spPr>
+          <a:xfrm>
+            <a:off x="411480" y="1810512"/>
+            <a:ext cx="82296" cy="713232"/>
+          </a:xfrm>
+          <a:prstGeom prst="rect">
+            <a:avLst/>
+          </a:prstGeom>
+          <a:solidFill>
+            <a:srgbClr val="2563EB"/>
+          </a:solidFill>
+          <a:ln>
+            <a:noFill/>
+          </a:ln>
+          <a:effectLst/>
+        </p:spPr>
+        <p:style>
+          <a:lnRef idx="1">
+            <a:schemeClr val="accent1"/>
+          </a:lnRef>
+          <a:fillRef idx="3">
+            <a:schemeClr val="accent1"/>
+          </a:fillRef>
+          <a:effectRef idx="2">
+            <a:schemeClr val="accent1"/>
+          </a:effectRef>
+          <a:fontRef idx="minor">
+            <a:schemeClr val="lt1"/>
+          </a:fontRef>
+        </p:style>
+        <p:txBody>
+          <a:bodyPr rtlCol="0" anchor="ctr"/>
+          <a:lstStyle/>
+          <a:p>
+            <a:pPr algn="ctr"/>
+          </a:p>
+        </p:txBody>
+      </p:sp>
+      <p:sp>
+        <p:nvSpPr>
+          <p:cNvPr id="11" name="TextBox 10"/>
+          <p:cNvSpPr txBox="1"/>
+          <p:nvPr/>
+        </p:nvSpPr>
+        <p:spPr>
+          <a:xfrm>
+            <a:off x="685800" y="1883664"/>
+            <a:ext cx="2331720" cy="365760"/>
+          </a:xfrm>
+          <a:prstGeom prst="rect">
+            <a:avLst/>
+          </a:prstGeom>
+          <a:noFill/>
+        </p:spPr>
+        <p:txBody>
+          <a:bodyPr wrap="square" anchor="t" lIns="0" rIns="0" tIns="0" bIns="0">
+            <a:spAutoFit/>
+          </a:bodyPr>
+          <a:lstStyle/>
+          <a:p>
+            <a:pPr algn="l">
+              <a:lnSpc>
+                <a:spcPct val="100000"/>
+              </a:lnSpc>
+              <a:spcAft>
+                <a:spcPts val="400"/>
+              </a:spcAft>
+            </a:pPr>
+            <a:r>
+              <a:rPr sz="1300" b="1" i="0">
+                <a:solidFill>
+                  <a:srgbClr val="2563EB"/>
+                </a:solidFill>
+                <a:latin typeface="Calibri"/>
+              </a:rPr>
+              <a:t>aPriori</a:t>
+            </a:r>
+          </a:p>
+        </p:txBody>
+      </p:sp>
+      <p:sp>
+        <p:nvSpPr>
+          <p:cNvPr id="12" name="TextBox 11"/>
+          <p:cNvSpPr txBox="1"/>
+          <p:nvPr/>
+        </p:nvSpPr>
+        <p:spPr>
+          <a:xfrm>
+            <a:off x="685800" y="2212848"/>
+            <a:ext cx="2331720" cy="274320"/>
+          </a:xfrm>
+          <a:prstGeom prst="rect">
+            <a:avLst/>
+          </a:prstGeom>
+          <a:noFill/>
+        </p:spPr>
+        <p:txBody>
+          <a:bodyPr wrap="square" anchor="t" lIns="0" rIns="0" tIns="0" bIns="0">
+            <a:spAutoFit/>
+          </a:bodyPr>
+          <a:lstStyle/>
+          <a:p>
+            <a:pPr algn="l">
+              <a:lnSpc>
+                <a:spcPct val="100000"/>
+              </a:lnSpc>
+              <a:spcAft>
+                <a:spcPts val="400"/>
+              </a:spcAft>
+            </a:pPr>
+            <a:r>
+              <a:rPr sz="900" b="0" i="1">
+                <a:solidFill>
+                  <a:srgbClr val="64748B"/>
+                </a:solidFill>
+                <a:latin typeface="Calibri"/>
+              </a:rPr>
+              <a:t>Market leader (US)</a:t>
+            </a:r>
+          </a:p>
+        </p:txBody>
+      </p:sp>
+      <p:sp>
+        <p:nvSpPr>
+          <p:cNvPr id="13" name="TextBox 12"/>
+          <p:cNvSpPr txBox="1"/>
+          <p:nvPr/>
+        </p:nvSpPr>
+        <p:spPr>
+          <a:xfrm>
+            <a:off x="3154680" y="1883664"/>
+            <a:ext cx="8412480" cy="411480"/>
+          </a:xfrm>
+          <a:prstGeom prst="rect">
+            <a:avLst/>
+          </a:prstGeom>
+          <a:noFill/>
+        </p:spPr>
+        <p:txBody>
+          <a:bodyPr wrap="square" anchor="t" lIns="0" rIns="0" tIns="0" bIns="0">
+            <a:spAutoFit/>
+          </a:bodyPr>
+          <a:lstStyle/>
+          <a:p>
+            <a:pPr algn="l">
+              <a:lnSpc>
+                <a:spcPct val="105000"/>
+              </a:lnSpc>
+              <a:spcAft>
+                <a:spcPts val="400"/>
+              </a:spcAft>
+            </a:pPr>
+            <a:r>
+              <a:rPr sz="1050" b="0" i="0">
+                <a:solidFill>
+                  <a:srgbClr val="334155"/>
+                </a:solidFill>
+                <a:latin typeface="Calibri"/>
+              </a:rPr>
+              <a:t>CAD-to-cost with physics-based models and regional cost databases. Used by Fortune-500 OEMs and Tier-1 suppliers — companies our size already pay for this category.</a:t>
+            </a:r>
+          </a:p>
+        </p:txBody>
+      </p:sp>
+      <p:sp>
+        <p:nvSpPr>
+          <p:cNvPr id="14" name="TextBox 13"/>
+          <p:cNvSpPr txBox="1"/>
+          <p:nvPr/>
+        </p:nvSpPr>
+        <p:spPr>
+          <a:xfrm>
+            <a:off x="3154680" y="2313432"/>
+            <a:ext cx="8412480" cy="201168"/>
+          </a:xfrm>
+          <a:prstGeom prst="rect">
+            <a:avLst/>
+          </a:prstGeom>
+          <a:noFill/>
+        </p:spPr>
+        <p:txBody>
+          <a:bodyPr wrap="square" anchor="t" lIns="0" rIns="0" tIns="0" bIns="0">
+            <a:spAutoFit/>
+          </a:bodyPr>
+          <a:lstStyle/>
+          <a:p>
+            <a:pPr algn="l">
+              <a:lnSpc>
+                <a:spcPct val="100000"/>
+              </a:lnSpc>
+              <a:spcAft>
+                <a:spcPts val="400"/>
+              </a:spcAft>
+            </a:pPr>
+            <a:r>
+              <a:rPr sz="850" b="0" i="1">
+                <a:solidFill>
+                  <a:srgbClr val="64748B"/>
+                </a:solidFill>
+                <a:latin typeface="Calibri"/>
+              </a:rPr>
+              <a:t>Source: apriori.com</a:t>
+            </a:r>
+          </a:p>
+        </p:txBody>
+      </p:sp>
+      <p:sp>
+        <p:nvSpPr>
+          <p:cNvPr id="15" name="Rounded Rectangle 14"/>
+          <p:cNvSpPr/>
+          <p:nvPr/>
+        </p:nvSpPr>
+        <p:spPr>
+          <a:xfrm>
+            <a:off x="411480" y="2606040"/>
+            <a:ext cx="11384280" cy="713232"/>
+          </a:xfrm>
+          <a:prstGeom prst="roundRect">
+            <a:avLst>
+              <a:gd name="adj" fmla="val 14000"/>
+            </a:avLst>
+          </a:prstGeom>
+          <a:solidFill>
+            <a:srgbClr val="F1F5F9"/>
+          </a:solidFill>
+          <a:ln>
+            <a:noFill/>
+          </a:ln>
+          <a:effectLst/>
+        </p:spPr>
+        <p:style>
+          <a:lnRef idx="1">
+            <a:schemeClr val="accent1"/>
+          </a:lnRef>
+          <a:fillRef idx="3">
+            <a:schemeClr val="accent1"/>
+          </a:fillRef>
+          <a:effectRef idx="2">
+            <a:schemeClr val="accent1"/>
+          </a:effectRef>
+          <a:fontRef idx="minor">
+            <a:schemeClr val="lt1"/>
+          </a:fontRef>
+        </p:style>
+        <p:txBody>
+          <a:bodyPr rtlCol="0" anchor="ctr"/>
+          <a:lstStyle/>
+          <a:p>
+            <a:pPr algn="ctr"/>
+          </a:p>
+        </p:txBody>
+      </p:sp>
+      <p:sp>
+        <p:nvSpPr>
+          <p:cNvPr id="16" name="Rectangle 15"/>
+          <p:cNvSpPr/>
+          <p:nvPr/>
+        </p:nvSpPr>
+        <p:spPr>
+          <a:xfrm>
+            <a:off x="411480" y="2606040"/>
+            <a:ext cx="82296" cy="713232"/>
+          </a:xfrm>
+          <a:prstGeom prst="rect">
+            <a:avLst/>
+          </a:prstGeom>
+          <a:solidFill>
+            <a:srgbClr val="4F46E5"/>
+          </a:solidFill>
+          <a:ln>
+            <a:noFill/>
+          </a:ln>
+          <a:effectLst/>
+        </p:spPr>
+        <p:style>
+          <a:lnRef idx="1">
+            <a:schemeClr val="accent1"/>
+          </a:lnRef>
+          <a:fillRef idx="3">
+            <a:schemeClr val="accent1"/>
+          </a:fillRef>
+          <a:effectRef idx="2">
+            <a:schemeClr val="accent1"/>
+          </a:effectRef>
+          <a:fontRef idx="minor">
+            <a:schemeClr val="lt1"/>
+          </a:fontRef>
+        </p:style>
+        <p:txBody>
+          <a:bodyPr rtlCol="0" anchor="ctr"/>
+          <a:lstStyle/>
+          <a:p>
+            <a:pPr algn="ctr"/>
+          </a:p>
+        </p:txBody>
+      </p:sp>
+      <p:sp>
+        <p:nvSpPr>
+          <p:cNvPr id="17" name="TextBox 16"/>
+          <p:cNvSpPr txBox="1"/>
+          <p:nvPr/>
+        </p:nvSpPr>
+        <p:spPr>
+          <a:xfrm>
+            <a:off x="685800" y="2679192"/>
+            <a:ext cx="2331720" cy="365760"/>
+          </a:xfrm>
+          <a:prstGeom prst="rect">
+            <a:avLst/>
+          </a:prstGeom>
+          <a:noFill/>
+        </p:spPr>
+        <p:txBody>
+          <a:bodyPr wrap="square" anchor="t" lIns="0" rIns="0" tIns="0" bIns="0">
+            <a:spAutoFit/>
+          </a:bodyPr>
+          <a:lstStyle/>
+          <a:p>
+            <a:pPr algn="l">
+              <a:lnSpc>
+                <a:spcPct val="100000"/>
+              </a:lnSpc>
+              <a:spcAft>
+                <a:spcPts val="400"/>
+              </a:spcAft>
+            </a:pPr>
+            <a:r>
+              <a:rPr sz="1300" b="1" i="0">
+                <a:solidFill>
+                  <a:srgbClr val="4F46E5"/>
+                </a:solidFill>
+                <a:latin typeface="Calibri"/>
+              </a:rPr>
+              <a:t>Siemens PCM</a:t>
+            </a:r>
+          </a:p>
+        </p:txBody>
+      </p:sp>
+      <p:sp>
+        <p:nvSpPr>
+          <p:cNvPr id="18" name="TextBox 17"/>
+          <p:cNvSpPr txBox="1"/>
+          <p:nvPr/>
+        </p:nvSpPr>
+        <p:spPr>
+          <a:xfrm>
+            <a:off x="685800" y="3008376"/>
+            <a:ext cx="2331720" cy="274320"/>
+          </a:xfrm>
+          <a:prstGeom prst="rect">
+            <a:avLst/>
+          </a:prstGeom>
+          <a:noFill/>
+        </p:spPr>
+        <p:txBody>
+          <a:bodyPr wrap="square" anchor="t" lIns="0" rIns="0" tIns="0" bIns="0">
+            <a:spAutoFit/>
+          </a:bodyPr>
+          <a:lstStyle/>
+          <a:p>
+            <a:pPr algn="l">
+              <a:lnSpc>
+                <a:spcPct val="100000"/>
+              </a:lnSpc>
+              <a:spcAft>
+                <a:spcPts val="400"/>
+              </a:spcAft>
+            </a:pPr>
+            <a:r>
+              <a:rPr sz="900" b="0" i="1">
+                <a:solidFill>
+                  <a:srgbClr val="64748B"/>
+                </a:solidFill>
+                <a:latin typeface="Calibri"/>
+              </a:rPr>
+              <a:t>PLM giant (Teamcenter)</a:t>
+            </a:r>
+          </a:p>
+        </p:txBody>
+      </p:sp>
+      <p:sp>
+        <p:nvSpPr>
+          <p:cNvPr id="19" name="TextBox 18"/>
+          <p:cNvSpPr txBox="1"/>
+          <p:nvPr/>
+        </p:nvSpPr>
+        <p:spPr>
+          <a:xfrm>
+            <a:off x="3154680" y="2679192"/>
+            <a:ext cx="8412480" cy="411480"/>
+          </a:xfrm>
+          <a:prstGeom prst="rect">
+            <a:avLst/>
+          </a:prstGeom>
+          <a:noFill/>
+        </p:spPr>
+        <p:txBody>
+          <a:bodyPr wrap="square" anchor="t" lIns="0" rIns="0" tIns="0" bIns="0">
+            <a:spAutoFit/>
+          </a:bodyPr>
+          <a:lstStyle/>
+          <a:p>
+            <a:pPr algn="l">
+              <a:lnSpc>
+                <a:spcPct val="105000"/>
+              </a:lnSpc>
+              <a:spcAft>
+                <a:spcPts val="400"/>
+              </a:spcAft>
+            </a:pPr>
+            <a:r>
+              <a:rPr sz="1050" b="0" i="0">
+                <a:solidFill>
+                  <a:srgbClr val="334155"/>
+                </a:solidFill>
+                <a:latin typeface="Calibri"/>
+              </a:rPr>
+              <a:t>Bottom-up should-costing with process models and supplier collaboration, embedded in the Siemens PLM suite.</a:t>
+            </a:r>
+          </a:p>
+        </p:txBody>
+      </p:sp>
+      <p:sp>
+        <p:nvSpPr>
+          <p:cNvPr id="20" name="TextBox 19"/>
+          <p:cNvSpPr txBox="1"/>
+          <p:nvPr/>
+        </p:nvSpPr>
+        <p:spPr>
+          <a:xfrm>
+            <a:off x="3154680" y="3108960"/>
+            <a:ext cx="8412480" cy="201168"/>
+          </a:xfrm>
+          <a:prstGeom prst="rect">
+            <a:avLst/>
+          </a:prstGeom>
+          <a:noFill/>
+        </p:spPr>
+        <p:txBody>
+          <a:bodyPr wrap="square" anchor="t" lIns="0" rIns="0" tIns="0" bIns="0">
+            <a:spAutoFit/>
+          </a:bodyPr>
+          <a:lstStyle/>
+          <a:p>
+            <a:pPr algn="l">
+              <a:lnSpc>
+                <a:spcPct val="100000"/>
+              </a:lnSpc>
+              <a:spcAft>
+                <a:spcPts val="400"/>
+              </a:spcAft>
+            </a:pPr>
+            <a:r>
+              <a:rPr sz="850" b="0" i="1">
+                <a:solidFill>
+                  <a:srgbClr val="64748B"/>
+                </a:solidFill>
+                <a:latin typeface="Calibri"/>
+              </a:rPr>
+              <a:t>Source: siemens.com/teamcenter</a:t>
+            </a:r>
+          </a:p>
+        </p:txBody>
+      </p:sp>
+      <p:sp>
+        <p:nvSpPr>
+          <p:cNvPr id="21" name="Rounded Rectangle 20"/>
+          <p:cNvSpPr/>
+          <p:nvPr/>
+        </p:nvSpPr>
+        <p:spPr>
+          <a:xfrm>
+            <a:off x="411480" y="3401568"/>
+            <a:ext cx="11384280" cy="713232"/>
+          </a:xfrm>
+          <a:prstGeom prst="roundRect">
+            <a:avLst>
+              <a:gd name="adj" fmla="val 14000"/>
+            </a:avLst>
+          </a:prstGeom>
+          <a:solidFill>
+            <a:srgbClr val="F1F5F9"/>
+          </a:solidFill>
+          <a:ln>
+            <a:noFill/>
+          </a:ln>
+          <a:effectLst/>
+        </p:spPr>
+        <p:style>
+          <a:lnRef idx="1">
+            <a:schemeClr val="accent1"/>
+          </a:lnRef>
+          <a:fillRef idx="3">
+            <a:schemeClr val="accent1"/>
+          </a:fillRef>
+          <a:effectRef idx="2">
+            <a:schemeClr val="accent1"/>
+          </a:effectRef>
+          <a:fontRef idx="minor">
+            <a:schemeClr val="lt1"/>
+          </a:fontRef>
+        </p:style>
+        <p:txBody>
+          <a:bodyPr rtlCol="0" anchor="ctr"/>
+          <a:lstStyle/>
+          <a:p>
+            <a:pPr algn="ctr"/>
+          </a:p>
+        </p:txBody>
+      </p:sp>
+      <p:sp>
+        <p:nvSpPr>
+          <p:cNvPr id="22" name="Rectangle 21"/>
+          <p:cNvSpPr/>
+          <p:nvPr/>
+        </p:nvSpPr>
+        <p:spPr>
+          <a:xfrm>
+            <a:off x="411480" y="3401568"/>
+            <a:ext cx="82296" cy="713232"/>
+          </a:xfrm>
+          <a:prstGeom prst="rect">
+            <a:avLst/>
+          </a:prstGeom>
+          <a:solidFill>
+            <a:srgbClr val="7C3AED"/>
+          </a:solidFill>
+          <a:ln>
+            <a:noFill/>
+          </a:ln>
+          <a:effectLst/>
+        </p:spPr>
+        <p:style>
+          <a:lnRef idx="1">
+            <a:schemeClr val="accent1"/>
+          </a:lnRef>
+          <a:fillRef idx="3">
+            <a:schemeClr val="accent1"/>
+          </a:fillRef>
+          <a:effectRef idx="2">
+            <a:schemeClr val="accent1"/>
+          </a:effectRef>
+          <a:fontRef idx="minor">
+            <a:schemeClr val="lt1"/>
+          </a:fontRef>
+        </p:style>
+        <p:txBody>
+          <a:bodyPr rtlCol="0" anchor="ctr"/>
+          <a:lstStyle/>
+          <a:p>
+            <a:pPr algn="ctr"/>
+          </a:p>
+        </p:txBody>
+      </p:sp>
+      <p:sp>
+        <p:nvSpPr>
+          <p:cNvPr id="23" name="TextBox 22"/>
+          <p:cNvSpPr txBox="1"/>
+          <p:nvPr/>
+        </p:nvSpPr>
+        <p:spPr>
+          <a:xfrm>
+            <a:off x="685800" y="3474720"/>
+            <a:ext cx="2331720" cy="365760"/>
+          </a:xfrm>
+          <a:prstGeom prst="rect">
+            <a:avLst/>
+          </a:prstGeom>
+          <a:noFill/>
+        </p:spPr>
+        <p:txBody>
+          <a:bodyPr wrap="square" anchor="t" lIns="0" rIns="0" tIns="0" bIns="0">
+            <a:spAutoFit/>
+          </a:bodyPr>
+          <a:lstStyle/>
+          <a:p>
+            <a:pPr algn="l">
+              <a:lnSpc>
+                <a:spcPct val="100000"/>
+              </a:lnSpc>
+              <a:spcAft>
+                <a:spcPts val="400"/>
+              </a:spcAft>
+            </a:pPr>
+            <a:r>
+              <a:rPr sz="1300" b="1" i="0">
+                <a:solidFill>
+                  <a:srgbClr val="7C3AED"/>
+                </a:solidFill>
+                <a:latin typeface="Calibri"/>
+              </a:rPr>
+              <a:t>Tset</a:t>
+            </a:r>
+          </a:p>
+        </p:txBody>
+      </p:sp>
+      <p:sp>
+        <p:nvSpPr>
+          <p:cNvPr id="24" name="TextBox 23"/>
+          <p:cNvSpPr txBox="1"/>
+          <p:nvPr/>
+        </p:nvSpPr>
+        <p:spPr>
+          <a:xfrm>
+            <a:off x="685800" y="3803904"/>
+            <a:ext cx="2331720" cy="274320"/>
+          </a:xfrm>
+          <a:prstGeom prst="rect">
+            <a:avLst/>
+          </a:prstGeom>
+          <a:noFill/>
+        </p:spPr>
+        <p:txBody>
+          <a:bodyPr wrap="square" anchor="t" lIns="0" rIns="0" tIns="0" bIns="0">
+            <a:spAutoFit/>
+          </a:bodyPr>
+          <a:lstStyle/>
+          <a:p>
+            <a:pPr algn="l">
+              <a:lnSpc>
+                <a:spcPct val="100000"/>
+              </a:lnSpc>
+              <a:spcAft>
+                <a:spcPts val="400"/>
+              </a:spcAft>
+            </a:pPr>
+            <a:r>
+              <a:rPr sz="900" b="0" i="1">
+                <a:solidFill>
+                  <a:srgbClr val="64748B"/>
+                </a:solidFill>
+                <a:latin typeface="Calibri"/>
+              </a:rPr>
+              <a:t>AI challenger (Austria, 2018)</a:t>
+            </a:r>
+          </a:p>
+        </p:txBody>
+      </p:sp>
+      <p:sp>
+        <p:nvSpPr>
+          <p:cNvPr id="25" name="TextBox 24"/>
+          <p:cNvSpPr txBox="1"/>
+          <p:nvPr/>
+        </p:nvSpPr>
+        <p:spPr>
+          <a:xfrm>
+            <a:off x="3154680" y="3474720"/>
+            <a:ext cx="8412480" cy="411480"/>
+          </a:xfrm>
+          <a:prstGeom prst="rect">
+            <a:avLst/>
+          </a:prstGeom>
+          <a:noFill/>
+        </p:spPr>
+        <p:txBody>
+          <a:bodyPr wrap="square" anchor="t" lIns="0" rIns="0" tIns="0" bIns="0">
+            <a:spAutoFit/>
+          </a:bodyPr>
+          <a:lstStyle/>
+          <a:p>
+            <a:pPr algn="l">
+              <a:lnSpc>
+                <a:spcPct val="105000"/>
+              </a:lnSpc>
+              <a:spcAft>
+                <a:spcPts val="400"/>
+              </a:spcAft>
+            </a:pPr>
+            <a:r>
+              <a:rPr sz="1050" b="0" i="0">
+                <a:solidFill>
+                  <a:srgbClr val="334155"/>
+                </a:solidFill>
+                <a:latin typeface="Calibri"/>
+              </a:rPr>
+              <a:t>Automotive-focused costing from 3D models and BOMs, 50+ calculation modules plus CO2. Being acquired by A2MAC1 (June 2026) to build "AI-enabled costing intelligence".</a:t>
+            </a:r>
+          </a:p>
+        </p:txBody>
+      </p:sp>
+      <p:sp>
+        <p:nvSpPr>
+          <p:cNvPr id="26" name="TextBox 25"/>
+          <p:cNvSpPr txBox="1"/>
+          <p:nvPr/>
+        </p:nvSpPr>
+        <p:spPr>
+          <a:xfrm>
+            <a:off x="3154680" y="3904488"/>
+            <a:ext cx="8412480" cy="201168"/>
+          </a:xfrm>
+          <a:prstGeom prst="rect">
+            <a:avLst/>
+          </a:prstGeom>
+          <a:noFill/>
+        </p:spPr>
+        <p:txBody>
+          <a:bodyPr wrap="square" anchor="t" lIns="0" rIns="0" tIns="0" bIns="0">
+            <a:spAutoFit/>
+          </a:bodyPr>
+          <a:lstStyle/>
+          <a:p>
+            <a:pPr algn="l">
+              <a:lnSpc>
+                <a:spcPct val="100000"/>
+              </a:lnSpc>
+              <a:spcAft>
+                <a:spcPts val="400"/>
+              </a:spcAft>
+            </a:pPr>
+            <a:r>
+              <a:rPr sz="850" b="0" i="1">
+                <a:solidFill>
+                  <a:srgbClr val="64748B"/>
+                </a:solidFill>
+                <a:latin typeface="Calibri"/>
+              </a:rPr>
+              <a:t>Source: tset.com · globenewswire.com (18 Jun 2026)</a:t>
+            </a:r>
+          </a:p>
+        </p:txBody>
+      </p:sp>
+      <p:sp>
+        <p:nvSpPr>
+          <p:cNvPr id="27" name="Rounded Rectangle 26"/>
+          <p:cNvSpPr/>
+          <p:nvPr/>
+        </p:nvSpPr>
+        <p:spPr>
+          <a:xfrm>
+            <a:off x="411480" y="4197096"/>
+            <a:ext cx="11384280" cy="713232"/>
+          </a:xfrm>
+          <a:prstGeom prst="roundRect">
+            <a:avLst>
+              <a:gd name="adj" fmla="val 14000"/>
+            </a:avLst>
+          </a:prstGeom>
+          <a:solidFill>
+            <a:srgbClr val="F1F5F9"/>
+          </a:solidFill>
+          <a:ln>
+            <a:noFill/>
+          </a:ln>
+          <a:effectLst/>
+        </p:spPr>
+        <p:style>
+          <a:lnRef idx="1">
+            <a:schemeClr val="accent1"/>
+          </a:lnRef>
+          <a:fillRef idx="3">
+            <a:schemeClr val="accent1"/>
+          </a:fillRef>
+          <a:effectRef idx="2">
+            <a:schemeClr val="accent1"/>
+          </a:effectRef>
+          <a:fontRef idx="minor">
+            <a:schemeClr val="lt1"/>
+          </a:fontRef>
+        </p:style>
+        <p:txBody>
+          <a:bodyPr rtlCol="0" anchor="ctr"/>
+          <a:lstStyle/>
+          <a:p>
+            <a:pPr algn="ctr"/>
+          </a:p>
+        </p:txBody>
+      </p:sp>
+      <p:sp>
+        <p:nvSpPr>
+          <p:cNvPr id="28" name="Rectangle 27"/>
+          <p:cNvSpPr/>
+          <p:nvPr/>
+        </p:nvSpPr>
+        <p:spPr>
+          <a:xfrm>
+            <a:off x="411480" y="4197096"/>
+            <a:ext cx="82296" cy="713232"/>
+          </a:xfrm>
+          <a:prstGeom prst="rect">
+            <a:avLst/>
+          </a:prstGeom>
+          <a:solidFill>
+            <a:srgbClr val="0891B2"/>
+          </a:solidFill>
+          <a:ln>
+            <a:noFill/>
+          </a:ln>
+          <a:effectLst/>
+        </p:spPr>
+        <p:style>
+          <a:lnRef idx="1">
+            <a:schemeClr val="accent1"/>
+          </a:lnRef>
+          <a:fillRef idx="3">
+            <a:schemeClr val="accent1"/>
+          </a:fillRef>
+          <a:effectRef idx="2">
+            <a:schemeClr val="accent1"/>
+          </a:effectRef>
+          <a:fontRef idx="minor">
+            <a:schemeClr val="lt1"/>
+          </a:fontRef>
+        </p:style>
+        <p:txBody>
+          <a:bodyPr rtlCol="0" anchor="ctr"/>
+          <a:lstStyle/>
+          <a:p>
+            <a:pPr algn="ctr"/>
+          </a:p>
+        </p:txBody>
+      </p:sp>
+      <p:sp>
+        <p:nvSpPr>
+          <p:cNvPr id="29" name="TextBox 28"/>
+          <p:cNvSpPr txBox="1"/>
+          <p:nvPr/>
+        </p:nvSpPr>
+        <p:spPr>
+          <a:xfrm>
+            <a:off x="685800" y="4270248"/>
+            <a:ext cx="2331720" cy="365760"/>
+          </a:xfrm>
+          <a:prstGeom prst="rect">
+            <a:avLst/>
+          </a:prstGeom>
+          <a:noFill/>
+        </p:spPr>
+        <p:txBody>
+          <a:bodyPr wrap="square" anchor="t" lIns="0" rIns="0" tIns="0" bIns="0">
+            <a:spAutoFit/>
+          </a:bodyPr>
+          <a:lstStyle/>
+          <a:p>
+            <a:pPr algn="l">
+              <a:lnSpc>
+                <a:spcPct val="100000"/>
+              </a:lnSpc>
+              <a:spcAft>
+                <a:spcPts val="400"/>
+              </a:spcAft>
+            </a:pPr>
+            <a:r>
+              <a:rPr sz="1300" b="1" i="0">
+                <a:solidFill>
+                  <a:srgbClr val="0891B2"/>
+                </a:solidFill>
+                <a:latin typeface="Calibri"/>
+              </a:rPr>
+              <a:t>Boothroyd DFMA</a:t>
+            </a:r>
+          </a:p>
+        </p:txBody>
+      </p:sp>
+      <p:sp>
+        <p:nvSpPr>
+          <p:cNvPr id="30" name="TextBox 29"/>
+          <p:cNvSpPr txBox="1"/>
+          <p:nvPr/>
+        </p:nvSpPr>
+        <p:spPr>
+          <a:xfrm>
+            <a:off x="685800" y="4599432"/>
+            <a:ext cx="2331720" cy="274320"/>
+          </a:xfrm>
+          <a:prstGeom prst="rect">
+            <a:avLst/>
+          </a:prstGeom>
+          <a:noFill/>
+        </p:spPr>
+        <p:txBody>
+          <a:bodyPr wrap="square" anchor="t" lIns="0" rIns="0" tIns="0" bIns="0">
+            <a:spAutoFit/>
+          </a:bodyPr>
+          <a:lstStyle/>
+          <a:p>
+            <a:pPr algn="l">
+              <a:lnSpc>
+                <a:spcPct val="100000"/>
+              </a:lnSpc>
+              <a:spcAft>
+                <a:spcPts val="400"/>
+              </a:spcAft>
+            </a:pPr>
+            <a:r>
+              <a:rPr sz="900" b="0" i="1">
+                <a:solidFill>
+                  <a:srgbClr val="64748B"/>
+                </a:solidFill>
+                <a:latin typeface="Calibri"/>
+              </a:rPr>
+              <a:t>The classic (Dewhurst)</a:t>
+            </a:r>
+          </a:p>
+        </p:txBody>
+      </p:sp>
+      <p:sp>
+        <p:nvSpPr>
+          <p:cNvPr id="31" name="TextBox 30"/>
+          <p:cNvSpPr txBox="1"/>
+          <p:nvPr/>
+        </p:nvSpPr>
+        <p:spPr>
+          <a:xfrm>
+            <a:off x="3154680" y="4270248"/>
+            <a:ext cx="8412480" cy="411480"/>
+          </a:xfrm>
+          <a:prstGeom prst="rect">
+            <a:avLst/>
+          </a:prstGeom>
+          <a:noFill/>
+        </p:spPr>
+        <p:txBody>
+          <a:bodyPr wrap="square" anchor="t" lIns="0" rIns="0" tIns="0" bIns="0">
+            <a:spAutoFit/>
+          </a:bodyPr>
+          <a:lstStyle/>
+          <a:p>
+            <a:pPr algn="l">
+              <a:lnSpc>
+                <a:spcPct val="105000"/>
+              </a:lnSpc>
+              <a:spcAft>
+                <a:spcPts val="400"/>
+              </a:spcAft>
+            </a:pPr>
+            <a:r>
+              <a:rPr sz="1050" b="0" i="0">
+                <a:solidFill>
+                  <a:srgbClr val="334155"/>
+                </a:solidFill>
+                <a:latin typeface="Calibri"/>
+              </a:rPr>
+              <a:t>Design-for-manufacture and concurrent costing — the methodology textbooks are built on, used for decades.</a:t>
+            </a:r>
+          </a:p>
+        </p:txBody>
+      </p:sp>
+      <p:sp>
+        <p:nvSpPr>
+          <p:cNvPr id="32" name="TextBox 31"/>
+          <p:cNvSpPr txBox="1"/>
+          <p:nvPr/>
+        </p:nvSpPr>
+        <p:spPr>
+          <a:xfrm>
+            <a:off x="3154680" y="4700016"/>
+            <a:ext cx="8412480" cy="201168"/>
+          </a:xfrm>
+          <a:prstGeom prst="rect">
+            <a:avLst/>
+          </a:prstGeom>
+          <a:noFill/>
+        </p:spPr>
+        <p:txBody>
+          <a:bodyPr wrap="square" anchor="t" lIns="0" rIns="0" tIns="0" bIns="0">
+            <a:spAutoFit/>
+          </a:bodyPr>
+          <a:lstStyle/>
+          <a:p>
+            <a:pPr algn="l">
+              <a:lnSpc>
+                <a:spcPct val="100000"/>
+              </a:lnSpc>
+              <a:spcAft>
+                <a:spcPts val="400"/>
+              </a:spcAft>
+            </a:pPr>
+            <a:r>
+              <a:rPr sz="850" b="0" i="1">
+                <a:solidFill>
+                  <a:srgbClr val="64748B"/>
+                </a:solidFill>
+                <a:latin typeface="Calibri"/>
+              </a:rPr>
+              <a:t>Source: dfma.com</a:t>
+            </a:r>
+          </a:p>
+        </p:txBody>
+      </p:sp>
+      <p:sp>
+        <p:nvSpPr>
+          <p:cNvPr id="33" name="Rounded Rectangle 32"/>
+          <p:cNvSpPr/>
+          <p:nvPr/>
+        </p:nvSpPr>
+        <p:spPr>
+          <a:xfrm>
+            <a:off x="411480" y="4992624"/>
+            <a:ext cx="11384280" cy="713232"/>
+          </a:xfrm>
+          <a:prstGeom prst="roundRect">
+            <a:avLst>
+              <a:gd name="adj" fmla="val 14000"/>
+            </a:avLst>
+          </a:prstGeom>
+          <a:solidFill>
+            <a:srgbClr val="F1F5F9"/>
+          </a:solidFill>
+          <a:ln>
+            <a:noFill/>
+          </a:ln>
+          <a:effectLst/>
+        </p:spPr>
+        <p:style>
+          <a:lnRef idx="1">
+            <a:schemeClr val="accent1"/>
+          </a:lnRef>
+          <a:fillRef idx="3">
+            <a:schemeClr val="accent1"/>
+          </a:fillRef>
+          <a:effectRef idx="2">
+            <a:schemeClr val="accent1"/>
+          </a:effectRef>
+          <a:fontRef idx="minor">
+            <a:schemeClr val="lt1"/>
+          </a:fontRef>
+        </p:style>
+        <p:txBody>
+          <a:bodyPr rtlCol="0" anchor="ctr"/>
+          <a:lstStyle/>
+          <a:p>
+            <a:pPr algn="ctr"/>
+          </a:p>
+        </p:txBody>
+      </p:sp>
+      <p:sp>
+        <p:nvSpPr>
+          <p:cNvPr id="34" name="Rectangle 33"/>
+          <p:cNvSpPr/>
+          <p:nvPr/>
+        </p:nvSpPr>
+        <p:spPr>
+          <a:xfrm>
+            <a:off x="411480" y="4992624"/>
+            <a:ext cx="82296" cy="713232"/>
+          </a:xfrm>
+          <a:prstGeom prst="rect">
+            <a:avLst/>
+          </a:prstGeom>
+          <a:solidFill>
+            <a:srgbClr val="64748B"/>
+          </a:solidFill>
+          <a:ln>
+            <a:noFill/>
+          </a:ln>
+          <a:effectLst/>
+        </p:spPr>
+        <p:style>
+          <a:lnRef idx="1">
+            <a:schemeClr val="accent1"/>
+          </a:lnRef>
+          <a:fillRef idx="3">
+            <a:schemeClr val="accent1"/>
+          </a:fillRef>
+          <a:effectRef idx="2">
+            <a:schemeClr val="accent1"/>
+          </a:effectRef>
+          <a:fontRef idx="minor">
+            <a:schemeClr val="lt1"/>
+          </a:fontRef>
+        </p:style>
+        <p:txBody>
+          <a:bodyPr rtlCol="0" anchor="ctr"/>
+          <a:lstStyle/>
+          <a:p>
+            <a:pPr algn="ctr"/>
+          </a:p>
+        </p:txBody>
+      </p:sp>
+      <p:sp>
+        <p:nvSpPr>
+          <p:cNvPr id="35" name="TextBox 34"/>
+          <p:cNvSpPr txBox="1"/>
+          <p:nvPr/>
+        </p:nvSpPr>
+        <p:spPr>
+          <a:xfrm>
+            <a:off x="685800" y="5065776"/>
+            <a:ext cx="2331720" cy="365760"/>
+          </a:xfrm>
+          <a:prstGeom prst="rect">
+            <a:avLst/>
+          </a:prstGeom>
+          <a:noFill/>
+        </p:spPr>
+        <p:txBody>
+          <a:bodyPr wrap="square" anchor="t" lIns="0" rIns="0" tIns="0" bIns="0">
+            <a:spAutoFit/>
+          </a:bodyPr>
+          <a:lstStyle/>
+          <a:p>
+            <a:pPr algn="l">
+              <a:lnSpc>
+                <a:spcPct val="100000"/>
+              </a:lnSpc>
+              <a:spcAft>
+                <a:spcPts val="400"/>
+              </a:spcAft>
+            </a:pPr>
+            <a:r>
+              <a:rPr sz="1300" b="1" i="0">
+                <a:solidFill>
+                  <a:srgbClr val="64748B"/>
+                </a:solidFill>
+                <a:latin typeface="Calibri"/>
+              </a:rPr>
+              <a:t>New AI entrants</a:t>
+            </a:r>
+          </a:p>
+        </p:txBody>
+      </p:sp>
+      <p:sp>
+        <p:nvSpPr>
+          <p:cNvPr id="36" name="TextBox 35"/>
+          <p:cNvSpPr txBox="1"/>
+          <p:nvPr/>
+        </p:nvSpPr>
+        <p:spPr>
+          <a:xfrm>
+            <a:off x="685800" y="5394960"/>
+            <a:ext cx="2331720" cy="274320"/>
+          </a:xfrm>
+          <a:prstGeom prst="rect">
+            <a:avLst/>
+          </a:prstGeom>
+          <a:noFill/>
+        </p:spPr>
+        <p:txBody>
+          <a:bodyPr wrap="square" anchor="t" lIns="0" rIns="0" tIns="0" bIns="0">
+            <a:spAutoFit/>
+          </a:bodyPr>
+          <a:lstStyle/>
+          <a:p>
+            <a:pPr algn="l">
+              <a:lnSpc>
+                <a:spcPct val="100000"/>
+              </a:lnSpc>
+              <a:spcAft>
+                <a:spcPts val="400"/>
+              </a:spcAft>
+            </a:pPr>
+            <a:r>
+              <a:rPr sz="900" b="0" i="1">
+                <a:solidFill>
+                  <a:srgbClr val="64748B"/>
+                </a:solidFill>
+                <a:latin typeface="Calibri"/>
+              </a:rPr>
+              <a:t>Start-ups</a:t>
+            </a:r>
+          </a:p>
+        </p:txBody>
+      </p:sp>
+      <p:sp>
+        <p:nvSpPr>
+          <p:cNvPr id="37" name="TextBox 36"/>
+          <p:cNvSpPr txBox="1"/>
+          <p:nvPr/>
+        </p:nvSpPr>
+        <p:spPr>
+          <a:xfrm>
+            <a:off x="3154680" y="5065776"/>
+            <a:ext cx="8412480" cy="411480"/>
+          </a:xfrm>
+          <a:prstGeom prst="rect">
+            <a:avLst/>
+          </a:prstGeom>
+          <a:noFill/>
+        </p:spPr>
+        <p:txBody>
+          <a:bodyPr wrap="square" anchor="t" lIns="0" rIns="0" tIns="0" bIns="0">
+            <a:spAutoFit/>
+          </a:bodyPr>
+          <a:lstStyle/>
+          <a:p>
+            <a:pPr algn="l">
+              <a:lnSpc>
+                <a:spcPct val="105000"/>
+              </a:lnSpc>
+              <a:spcAft>
+                <a:spcPts val="400"/>
+              </a:spcAft>
+            </a:pPr>
+            <a:r>
+              <a:rPr sz="1050" b="0" i="0">
+                <a:solidFill>
+                  <a:srgbClr val="334155"/>
+                </a:solidFill>
+                <a:latin typeface="Calibri"/>
+              </a:rPr>
+              <a:t>Razorlabs Cost Advisor, Emithran and others: AI quotes from CAD files, calibrated on live machining data.</a:t>
+            </a:r>
+          </a:p>
+        </p:txBody>
+      </p:sp>
+      <p:sp>
+        <p:nvSpPr>
+          <p:cNvPr id="38" name="TextBox 37"/>
+          <p:cNvSpPr txBox="1"/>
+          <p:nvPr/>
+        </p:nvSpPr>
+        <p:spPr>
+          <a:xfrm>
+            <a:off x="3154680" y="5495544"/>
+            <a:ext cx="8412480" cy="201168"/>
+          </a:xfrm>
+          <a:prstGeom prst="rect">
+            <a:avLst/>
+          </a:prstGeom>
+          <a:noFill/>
+        </p:spPr>
+        <p:txBody>
+          <a:bodyPr wrap="square" anchor="t" lIns="0" rIns="0" tIns="0" bIns="0">
+            <a:spAutoFit/>
+          </a:bodyPr>
+          <a:lstStyle/>
+          <a:p>
+            <a:pPr algn="l">
+              <a:lnSpc>
+                <a:spcPct val="100000"/>
+              </a:lnSpc>
+              <a:spcAft>
+                <a:spcPts val="400"/>
+              </a:spcAft>
+            </a:pPr>
+            <a:r>
+              <a:rPr sz="850" b="0" i="1">
+                <a:solidFill>
+                  <a:srgbClr val="64748B"/>
+                </a:solidFill>
+                <a:latin typeface="Calibri"/>
+              </a:rPr>
+              <a:t>Source: emithran.com</a:t>
+            </a:r>
+          </a:p>
+        </p:txBody>
+      </p:sp>
+      <p:sp>
+        <p:nvSpPr>
+          <p:cNvPr id="39" name="Rounded Rectangle 38"/>
+          <p:cNvSpPr/>
+          <p:nvPr/>
+        </p:nvSpPr>
+        <p:spPr>
+          <a:xfrm>
+            <a:off x="411480" y="5897880"/>
+            <a:ext cx="11384280" cy="685800"/>
+          </a:xfrm>
+          <a:prstGeom prst="roundRect">
+            <a:avLst>
+              <a:gd name="adj" fmla="val 10000"/>
+            </a:avLst>
+          </a:prstGeom>
+          <a:solidFill>
+            <a:srgbClr val="EFF6FF"/>
+          </a:solidFill>
+          <a:ln>
+            <a:noFill/>
+          </a:ln>
+          <a:effectLst/>
+        </p:spPr>
+        <p:style>
+          <a:lnRef idx="1">
+            <a:schemeClr val="accent1"/>
+          </a:lnRef>
+          <a:fillRef idx="3">
+            <a:schemeClr val="accent1"/>
+          </a:fillRef>
+          <a:effectRef idx="2">
+            <a:schemeClr val="accent1"/>
+          </a:effectRef>
+          <a:fontRef idx="minor">
+            <a:schemeClr val="lt1"/>
+          </a:fontRef>
+        </p:style>
+        <p:txBody>
+          <a:bodyPr rtlCol="0" anchor="ctr"/>
+          <a:lstStyle/>
+          <a:p>
+            <a:pPr algn="ctr"/>
+          </a:p>
+        </p:txBody>
+      </p:sp>
+      <p:sp>
+        <p:nvSpPr>
+          <p:cNvPr id="40" name="TextBox 39"/>
+          <p:cNvSpPr txBox="1"/>
+          <p:nvPr/>
+        </p:nvSpPr>
+        <p:spPr>
+          <a:xfrm>
+            <a:off x="685800" y="6016752"/>
+            <a:ext cx="10881360" cy="502920"/>
+          </a:xfrm>
+          <a:prstGeom prst="rect">
+            <a:avLst/>
+          </a:prstGeom>
+          <a:noFill/>
+        </p:spPr>
+        <p:txBody>
+          <a:bodyPr wrap="square" anchor="t" lIns="0" rIns="0" tIns="0" bIns="0">
+            <a:spAutoFit/>
+          </a:bodyPr>
+          <a:lstStyle/>
+          <a:p>
+            <a:pPr algn="l">
+              <a:lnSpc>
+                <a:spcPct val="112000"/>
+              </a:lnSpc>
+              <a:spcAft>
+                <a:spcPts val="400"/>
+              </a:spcAft>
+            </a:pPr>
+            <a:r>
+              <a:rPr sz="1200" b="1" i="0">
+                <a:solidFill>
+                  <a:srgbClr val="2563EB"/>
+                </a:solidFill>
+                <a:latin typeface="Calibri"/>
+              </a:rPr>
+              <a:t>Takeaway: </a:t>
+            </a:r>
+            <a:r>
+              <a:rPr sz="1200" b="0" i="0">
+                <a:solidFill>
+                  <a:srgbClr val="334155"/>
+                </a:solidFill>
+                <a:latin typeface="Calibri"/>
+              </a:rPr>
+              <a:t>the should-cost category is proven — large OEMs already pay for it. The question is not IF it works, but why OURS fits us better: security, learning on our own data, and CAPEE integration (next slide).</a:t>
+            </a:r>
+          </a:p>
+        </p:txBody>
+      </p:sp>
+    </p:spTree>
+  </p:cSld>
+  <p:clrMapOvr>
+    <a:masterClrMapping/>
+  </p:clrMapOvr>
+</p:sld>
+</file>
+
+<file path=ppt/slides/slide17.xml><?xml version="1.0" encoding="utf-8"?>
+<p:sld xmlns:a="http://schemas.openxmlformats.org/drawingml/2006/main" xmlns:p="http://schemas.openxmlformats.org/presentationml/2006/main" xmlns:r="http://schemas.openxmlformats.org/officeDocument/2006/relationships">
+  <p:cSld>
+    <p:spTree>
+      <p:nvGrpSpPr>
+        <p:cNvPr id="1" name=""/>
+        <p:cNvGrpSpPr/>
+        <p:nvPr/>
+      </p:nvGrpSpPr>
+      <p:grpSpPr/>
+      <p:sp>
+        <p:nvSpPr>
+          <p:cNvPr id="2" name="Rectangle 1"/>
+          <p:cNvSpPr/>
+          <p:nvPr/>
+        </p:nvSpPr>
+        <p:spPr>
+          <a:xfrm>
+            <a:off x="0" y="0"/>
+            <a:ext cx="12191695" cy="6858000"/>
+          </a:xfrm>
+          <a:prstGeom prst="rect">
+            <a:avLst/>
+          </a:prstGeom>
+          <a:solidFill>
+            <a:srgbClr val="FFFFFF"/>
+          </a:solidFill>
+          <a:ln>
+            <a:noFill/>
+          </a:ln>
+          <a:effectLst/>
+        </p:spPr>
+        <p:style>
+          <a:lnRef idx="1">
+            <a:schemeClr val="accent1"/>
+          </a:lnRef>
+          <a:fillRef idx="3">
+            <a:schemeClr val="accent1"/>
+          </a:fillRef>
+          <a:effectRef idx="2">
+            <a:schemeClr val="accent1"/>
+          </a:effectRef>
+          <a:fontRef idx="minor">
+            <a:schemeClr val="lt1"/>
+          </a:fontRef>
+        </p:style>
+        <p:txBody>
+          <a:bodyPr rtlCol="0" anchor="ctr"/>
+          <a:lstStyle/>
+          <a:p>
+            <a:pPr algn="ctr"/>
+          </a:p>
+        </p:txBody>
+      </p:sp>
+      <p:sp>
+        <p:nvSpPr>
+          <p:cNvPr id="3" name="Rounded Rectangle 2"/>
+          <p:cNvSpPr/>
+          <p:nvPr/>
+        </p:nvSpPr>
+        <p:spPr>
+          <a:xfrm>
+            <a:off x="320040" y="201168"/>
+            <a:ext cx="384048" cy="384048"/>
+          </a:xfrm>
+          <a:prstGeom prst="roundRect">
+            <a:avLst>
+              <a:gd name="adj" fmla="val 28000"/>
+            </a:avLst>
+          </a:prstGeom>
+          <a:solidFill>
+            <a:srgbClr val="4F46E5"/>
+          </a:solidFill>
+          <a:ln>
+            <a:noFill/>
+          </a:ln>
+          <a:effectLst/>
+        </p:spPr>
+        <p:style>
+          <a:lnRef idx="1">
+            <a:schemeClr val="accent1"/>
+          </a:lnRef>
+          <a:fillRef idx="3">
+            <a:schemeClr val="accent1"/>
+          </a:fillRef>
+          <a:effectRef idx="2">
+            <a:schemeClr val="accent1"/>
+          </a:effectRef>
+          <a:fontRef idx="minor">
+            <a:schemeClr val="lt1"/>
+          </a:fontRef>
+        </p:style>
+        <p:txBody>
+          <a:bodyPr rtlCol="0" anchor="ctr" lIns="0" rIns="0" tIns="0" bIns="0"/>
+          <a:lstStyle/>
+          <a:p>
+            <a:pPr algn="ctr"/>
+            <a:r>
+              <a:rPr sz="1700" b="1">
+                <a:solidFill>
+                  <a:srgbClr val="FFFFFF"/>
+                </a:solidFill>
+                <a:latin typeface="Calibri"/>
+              </a:rPr>
+              <a:t>cv</a:t>
+            </a:r>
+          </a:p>
+        </p:txBody>
+      </p:sp>
+      <p:sp>
+        <p:nvSpPr>
+          <p:cNvPr id="4" name="TextBox 3"/>
+          <p:cNvSpPr txBox="1"/>
+          <p:nvPr/>
+        </p:nvSpPr>
+        <p:spPr>
+          <a:xfrm>
+            <a:off x="795528" y="173736"/>
+            <a:ext cx="2377440" cy="292608"/>
+          </a:xfrm>
+          <a:prstGeom prst="rect">
+            <a:avLst/>
+          </a:prstGeom>
+          <a:noFill/>
+        </p:spPr>
+        <p:txBody>
+          <a:bodyPr wrap="square" anchor="t" lIns="0" rIns="0" tIns="0" bIns="0">
+            <a:spAutoFit/>
+          </a:bodyPr>
+          <a:lstStyle/>
+          <a:p>
+            <a:pPr algn="l">
+              <a:lnSpc>
+                <a:spcPct val="100000"/>
+              </a:lnSpc>
+              <a:spcAft>
+                <a:spcPts val="400"/>
+              </a:spcAft>
+            </a:pPr>
+            <a:r>
+              <a:rPr sz="1800" b="1" i="0">
+                <a:solidFill>
+                  <a:srgbClr val="2563EB"/>
+                </a:solidFill>
+                <a:latin typeface="Calibri"/>
+              </a:rPr>
+              <a:t>CostVision</a:t>
+            </a:r>
+          </a:p>
+        </p:txBody>
+      </p:sp>
+      <p:sp>
+        <p:nvSpPr>
+          <p:cNvPr id="5" name="TextBox 4"/>
+          <p:cNvSpPr txBox="1"/>
+          <p:nvPr/>
+        </p:nvSpPr>
+        <p:spPr>
+          <a:xfrm>
+            <a:off x="795528" y="420624"/>
+            <a:ext cx="2560320" cy="201168"/>
+          </a:xfrm>
+          <a:prstGeom prst="rect">
+            <a:avLst/>
+          </a:prstGeom>
+          <a:noFill/>
+        </p:spPr>
+        <p:txBody>
+          <a:bodyPr wrap="square" anchor="t" lIns="0" rIns="0" tIns="0" bIns="0">
+            <a:spAutoFit/>
+          </a:bodyPr>
+          <a:lstStyle/>
+          <a:p>
+            <a:pPr algn="l">
+              <a:lnSpc>
+                <a:spcPct val="100000"/>
+              </a:lnSpc>
+              <a:spcAft>
+                <a:spcPts val="400"/>
+              </a:spcAft>
+            </a:pPr>
+            <a:r>
+              <a:rPr sz="750" b="0" i="0">
+                <a:solidFill>
+                  <a:srgbClr val="64748B"/>
+                </a:solidFill>
+                <a:latin typeface="Calibri"/>
+              </a:rPr>
+              <a:t>AI  COST  INTELLIGENCE</a:t>
+            </a:r>
+          </a:p>
+        </p:txBody>
+      </p:sp>
+      <p:sp>
+        <p:nvSpPr>
+          <p:cNvPr id="6" name="Rectangle 5"/>
+          <p:cNvSpPr/>
+          <p:nvPr/>
+        </p:nvSpPr>
+        <p:spPr>
+          <a:xfrm>
+            <a:off x="0" y="713232"/>
+            <a:ext cx="12191695" cy="27940"/>
+          </a:xfrm>
+          <a:prstGeom prst="rect">
+            <a:avLst/>
+          </a:prstGeom>
+          <a:solidFill>
+            <a:srgbClr val="4F46E5"/>
+          </a:solidFill>
+          <a:ln>
+            <a:noFill/>
+          </a:ln>
+          <a:effectLst/>
+        </p:spPr>
+        <p:style>
+          <a:lnRef idx="1">
+            <a:schemeClr val="accent1"/>
+          </a:lnRef>
+          <a:fillRef idx="3">
+            <a:schemeClr val="accent1"/>
+          </a:fillRef>
+          <a:effectRef idx="2">
+            <a:schemeClr val="accent1"/>
+          </a:effectRef>
+          <a:fontRef idx="minor">
+            <a:schemeClr val="lt1"/>
+          </a:fontRef>
+        </p:style>
+        <p:txBody>
+          <a:bodyPr rtlCol="0" anchor="ctr"/>
+          <a:lstStyle/>
+          <a:p>
+            <a:pPr algn="ctr"/>
+          </a:p>
+        </p:txBody>
+      </p:sp>
+      <p:sp>
+        <p:nvSpPr>
+          <p:cNvPr id="7" name="TextBox 6"/>
+          <p:cNvSpPr txBox="1"/>
+          <p:nvPr/>
+        </p:nvSpPr>
+        <p:spPr>
+          <a:xfrm>
+            <a:off x="411480" y="868680"/>
+            <a:ext cx="10515600" cy="274320"/>
+          </a:xfrm>
+          <a:prstGeom prst="rect">
+            <a:avLst/>
+          </a:prstGeom>
+          <a:noFill/>
+        </p:spPr>
+        <p:txBody>
+          <a:bodyPr wrap="square" anchor="t" lIns="0" rIns="0" tIns="0" bIns="0">
+            <a:spAutoFit/>
+          </a:bodyPr>
+          <a:lstStyle/>
+          <a:p>
+            <a:pPr algn="l">
+              <a:lnSpc>
+                <a:spcPct val="100000"/>
+              </a:lnSpc>
+              <a:spcAft>
+                <a:spcPts val="400"/>
+              </a:spcAft>
+            </a:pPr>
+            <a:r>
+              <a:rPr sz="1100" b="1" i="0">
+                <a:solidFill>
+                  <a:srgbClr val="2563EB"/>
+                </a:solidFill>
+                <a:latin typeface="Calibri"/>
+              </a:rPr>
+              <a:t>BACKUP · DIFFERENTIATION</a:t>
+            </a:r>
+          </a:p>
+        </p:txBody>
+      </p:sp>
+      <p:sp>
+        <p:nvSpPr>
+          <p:cNvPr id="8" name="TextBox 7"/>
+          <p:cNvSpPr txBox="1"/>
+          <p:nvPr/>
+        </p:nvSpPr>
+        <p:spPr>
+          <a:xfrm>
+            <a:off x="411480" y="1115568"/>
+            <a:ext cx="11338560" cy="548640"/>
+          </a:xfrm>
+          <a:prstGeom prst="rect">
+            <a:avLst/>
+          </a:prstGeom>
+          <a:noFill/>
+        </p:spPr>
+        <p:txBody>
+          <a:bodyPr wrap="square" anchor="t" lIns="0" rIns="0" tIns="0" bIns="0">
+            <a:spAutoFit/>
+          </a:bodyPr>
+          <a:lstStyle/>
+          <a:p>
+            <a:pPr algn="l">
+              <a:lnSpc>
+                <a:spcPct val="100000"/>
+              </a:lnSpc>
+              <a:spcAft>
+                <a:spcPts val="400"/>
+              </a:spcAft>
+            </a:pPr>
+            <a:r>
+              <a:rPr sz="2700" b="1" i="0">
+                <a:solidFill>
+                  <a:srgbClr val="0F172A"/>
+                </a:solidFill>
+                <a:latin typeface="Calibri"/>
+              </a:rPr>
+              <a:t>Why ours — what no vendor offers today</a:t>
+            </a:r>
+          </a:p>
+        </p:txBody>
+      </p:sp>
+      <p:sp>
+        <p:nvSpPr>
+          <p:cNvPr id="9" name="Rounded Rectangle 8"/>
+          <p:cNvSpPr/>
+          <p:nvPr/>
+        </p:nvSpPr>
+        <p:spPr>
+          <a:xfrm>
+            <a:off x="411480" y="1828800"/>
+            <a:ext cx="5577840" cy="1325880"/>
+          </a:xfrm>
+          <a:prstGeom prst="roundRect">
+            <a:avLst>
+              <a:gd name="adj" fmla="val 9000"/>
+            </a:avLst>
+          </a:prstGeom>
+          <a:solidFill>
+            <a:srgbClr val="ECFDF5"/>
+          </a:solidFill>
+          <a:ln>
+            <a:noFill/>
+          </a:ln>
+          <a:effectLst/>
+        </p:spPr>
+        <p:style>
+          <a:lnRef idx="1">
+            <a:schemeClr val="accent1"/>
+          </a:lnRef>
+          <a:fillRef idx="3">
+            <a:schemeClr val="accent1"/>
+          </a:fillRef>
+          <a:effectRef idx="2">
+            <a:schemeClr val="accent1"/>
+          </a:effectRef>
+          <a:fontRef idx="minor">
+            <a:schemeClr val="lt1"/>
+          </a:fontRef>
+        </p:style>
+        <p:txBody>
+          <a:bodyPr rtlCol="0" anchor="ctr"/>
+          <a:lstStyle/>
+          <a:p>
+            <a:pPr algn="ctr"/>
+          </a:p>
+        </p:txBody>
+      </p:sp>
+      <p:sp>
+        <p:nvSpPr>
+          <p:cNvPr id="10" name="Rectangle 9"/>
+          <p:cNvSpPr/>
+          <p:nvPr/>
+        </p:nvSpPr>
+        <p:spPr>
+          <a:xfrm>
+            <a:off x="411480" y="1828800"/>
+            <a:ext cx="82296" cy="1325880"/>
+          </a:xfrm>
+          <a:prstGeom prst="rect">
+            <a:avLst/>
+          </a:prstGeom>
+          <a:solidFill>
+            <a:srgbClr val="059669"/>
+          </a:solidFill>
+          <a:ln>
+            <a:noFill/>
+          </a:ln>
+          <a:effectLst/>
+        </p:spPr>
+        <p:style>
+          <a:lnRef idx="1">
+            <a:schemeClr val="accent1"/>
+          </a:lnRef>
+          <a:fillRef idx="3">
+            <a:schemeClr val="accent1"/>
+          </a:fillRef>
+          <a:effectRef idx="2">
+            <a:schemeClr val="accent1"/>
+          </a:effectRef>
+          <a:fontRef idx="minor">
+            <a:schemeClr val="lt1"/>
+          </a:fontRef>
+        </p:style>
+        <p:txBody>
+          <a:bodyPr rtlCol="0" anchor="ctr"/>
+          <a:lstStyle/>
+          <a:p>
+            <a:pPr algn="ctr"/>
+          </a:p>
+        </p:txBody>
+      </p:sp>
+      <p:sp>
+        <p:nvSpPr>
+          <p:cNvPr id="11" name="TextBox 10"/>
+          <p:cNvSpPr txBox="1"/>
+          <p:nvPr/>
+        </p:nvSpPr>
+        <p:spPr>
+          <a:xfrm>
+            <a:off x="667512" y="1938528"/>
+            <a:ext cx="5120640" cy="320040"/>
+          </a:xfrm>
+          <a:prstGeom prst="rect">
+            <a:avLst/>
+          </a:prstGeom>
+          <a:noFill/>
+        </p:spPr>
+        <p:txBody>
+          <a:bodyPr wrap="square" anchor="t" lIns="0" rIns="0" tIns="0" bIns="0">
+            <a:spAutoFit/>
+          </a:bodyPr>
+          <a:lstStyle/>
+          <a:p>
+            <a:pPr algn="l">
+              <a:lnSpc>
+                <a:spcPct val="100000"/>
+              </a:lnSpc>
+              <a:spcAft>
+                <a:spcPts val="400"/>
+              </a:spcAft>
+            </a:pPr>
+            <a:r>
+              <a:rPr sz="1350" b="1" i="0">
+                <a:solidFill>
+                  <a:srgbClr val="059669"/>
+                </a:solidFill>
+                <a:latin typeface="Calibri"/>
+              </a:rPr>
+              <a:t>PCB photo → costed BOM</a:t>
+            </a:r>
+          </a:p>
+        </p:txBody>
+      </p:sp>
+      <p:sp>
+        <p:nvSpPr>
+          <p:cNvPr id="12" name="TextBox 11"/>
+          <p:cNvSpPr txBox="1"/>
+          <p:nvPr/>
+        </p:nvSpPr>
+        <p:spPr>
+          <a:xfrm>
+            <a:off x="667512" y="2286000"/>
+            <a:ext cx="5120640" cy="822960"/>
+          </a:xfrm>
+          <a:prstGeom prst="rect">
+            <a:avLst/>
+          </a:prstGeom>
+          <a:noFill/>
+        </p:spPr>
+        <p:txBody>
+          <a:bodyPr wrap="square" anchor="t" lIns="0" rIns="0" tIns="0" bIns="0">
+            <a:spAutoFit/>
+          </a:bodyPr>
+          <a:lstStyle/>
+          <a:p>
+            <a:pPr algn="l">
+              <a:lnSpc>
+                <a:spcPct val="110000"/>
+              </a:lnSpc>
+              <a:spcAft>
+                <a:spcPts val="400"/>
+              </a:spcAft>
+            </a:pPr>
+            <a:r>
+              <a:rPr sz="1050" b="0" i="0">
+                <a:solidFill>
+                  <a:srgbClr val="334155"/>
+                </a:solidFill>
+                <a:latin typeface="Calibri"/>
+              </a:rPr>
+              <a:t>Photograph a circuit board, get a costed bill of materials with live component pricing. Design tools generate BOMs; no mainstream costing suite costs a board from photos.</a:t>
+            </a:r>
+          </a:p>
+        </p:txBody>
+      </p:sp>
+      <p:sp>
+        <p:nvSpPr>
+          <p:cNvPr id="13" name="Rounded Rectangle 12"/>
+          <p:cNvSpPr/>
+          <p:nvPr/>
+        </p:nvSpPr>
+        <p:spPr>
+          <a:xfrm>
+            <a:off x="6217920" y="1828800"/>
+            <a:ext cx="5577840" cy="1325880"/>
+          </a:xfrm>
+          <a:prstGeom prst="roundRect">
+            <a:avLst>
+              <a:gd name="adj" fmla="val 9000"/>
+            </a:avLst>
+          </a:prstGeom>
+          <a:solidFill>
+            <a:srgbClr val="ECFDF5"/>
+          </a:solidFill>
+          <a:ln>
+            <a:noFill/>
+          </a:ln>
+          <a:effectLst/>
+        </p:spPr>
+        <p:style>
+          <a:lnRef idx="1">
+            <a:schemeClr val="accent1"/>
+          </a:lnRef>
+          <a:fillRef idx="3">
+            <a:schemeClr val="accent1"/>
+          </a:fillRef>
+          <a:effectRef idx="2">
+            <a:schemeClr val="accent1"/>
+          </a:effectRef>
+          <a:fontRef idx="minor">
+            <a:schemeClr val="lt1"/>
+          </a:fontRef>
+        </p:style>
+        <p:txBody>
+          <a:bodyPr rtlCol="0" anchor="ctr"/>
+          <a:lstStyle/>
+          <a:p>
+            <a:pPr algn="ctr"/>
+          </a:p>
+        </p:txBody>
+      </p:sp>
+      <p:sp>
+        <p:nvSpPr>
+          <p:cNvPr id="14" name="Rectangle 13"/>
+          <p:cNvSpPr/>
+          <p:nvPr/>
+        </p:nvSpPr>
+        <p:spPr>
+          <a:xfrm>
+            <a:off x="6217920" y="1828800"/>
+            <a:ext cx="82296" cy="1325880"/>
+          </a:xfrm>
+          <a:prstGeom prst="rect">
+            <a:avLst/>
+          </a:prstGeom>
+          <a:solidFill>
+            <a:srgbClr val="059669"/>
+          </a:solidFill>
+          <a:ln>
+            <a:noFill/>
+          </a:ln>
+          <a:effectLst/>
+        </p:spPr>
+        <p:style>
+          <a:lnRef idx="1">
+            <a:schemeClr val="accent1"/>
+          </a:lnRef>
+          <a:fillRef idx="3">
+            <a:schemeClr val="accent1"/>
+          </a:fillRef>
+          <a:effectRef idx="2">
+            <a:schemeClr val="accent1"/>
+          </a:effectRef>
+          <a:fontRef idx="minor">
+            <a:schemeClr val="lt1"/>
+          </a:fontRef>
+        </p:style>
+        <p:txBody>
+          <a:bodyPr rtlCol="0" anchor="ctr"/>
+          <a:lstStyle/>
+          <a:p>
+            <a:pPr algn="ctr"/>
+          </a:p>
+        </p:txBody>
+      </p:sp>
+      <p:sp>
+        <p:nvSpPr>
+          <p:cNvPr id="15" name="TextBox 14"/>
+          <p:cNvSpPr txBox="1"/>
+          <p:nvPr/>
+        </p:nvSpPr>
+        <p:spPr>
+          <a:xfrm>
+            <a:off x="6473952" y="1938528"/>
+            <a:ext cx="5120640" cy="320040"/>
+          </a:xfrm>
+          <a:prstGeom prst="rect">
+            <a:avLst/>
+          </a:prstGeom>
+          <a:noFill/>
+        </p:spPr>
+        <p:txBody>
+          <a:bodyPr wrap="square" anchor="t" lIns="0" rIns="0" tIns="0" bIns="0">
+            <a:spAutoFit/>
+          </a:bodyPr>
+          <a:lstStyle/>
+          <a:p>
+            <a:pPr algn="l">
+              <a:lnSpc>
+                <a:spcPct val="100000"/>
+              </a:lnSpc>
+              <a:spcAft>
+                <a:spcPts val="400"/>
+              </a:spcAft>
+            </a:pPr>
+            <a:r>
+              <a:rPr sz="1350" b="1" i="0">
+                <a:solidFill>
+                  <a:srgbClr val="059669"/>
+                </a:solidFill>
+                <a:latin typeface="Calibri"/>
+              </a:rPr>
+              <a:t>Self-learning on OUR data</a:t>
+            </a:r>
+          </a:p>
+        </p:txBody>
+      </p:sp>
+      <p:sp>
+        <p:nvSpPr>
+          <p:cNvPr id="16" name="TextBox 15"/>
+          <p:cNvSpPr txBox="1"/>
+          <p:nvPr/>
+        </p:nvSpPr>
+        <p:spPr>
+          <a:xfrm>
+            <a:off x="6473952" y="2286000"/>
+            <a:ext cx="5120640" cy="822960"/>
+          </a:xfrm>
+          <a:prstGeom prst="rect">
+            <a:avLst/>
+          </a:prstGeom>
+          <a:noFill/>
+        </p:spPr>
+        <p:txBody>
+          <a:bodyPr wrap="square" anchor="t" lIns="0" rIns="0" tIns="0" bIns="0">
+            <a:spAutoFit/>
+          </a:bodyPr>
+          <a:lstStyle/>
+          <a:p>
+            <a:pPr algn="l">
+              <a:lnSpc>
+                <a:spcPct val="110000"/>
+              </a:lnSpc>
+              <a:spcAft>
+                <a:spcPts val="400"/>
+              </a:spcAft>
+            </a:pPr>
+            <a:r>
+              <a:rPr sz="1050" b="0" i="0">
+                <a:solidFill>
+                  <a:srgbClr val="334155"/>
+                </a:solidFill>
+                <a:latin typeface="Calibri"/>
+              </a:rPr>
+              <a:t>Calibrates itself on our real PO prices (error 10.9% → 0.3% after 3 quotes in testing) and raises findings autonomously. Incumbents are still marketing toward this.</a:t>
+            </a:r>
+          </a:p>
+        </p:txBody>
+      </p:sp>
+      <p:sp>
+        <p:nvSpPr>
+          <p:cNvPr id="17" name="Rounded Rectangle 16"/>
+          <p:cNvSpPr/>
+          <p:nvPr/>
+        </p:nvSpPr>
+        <p:spPr>
+          <a:xfrm>
+            <a:off x="411480" y="3310128"/>
+            <a:ext cx="5577840" cy="1325880"/>
+          </a:xfrm>
+          <a:prstGeom prst="roundRect">
+            <a:avLst>
+              <a:gd name="adj" fmla="val 9000"/>
+            </a:avLst>
+          </a:prstGeom>
+          <a:solidFill>
+            <a:srgbClr val="ECFDF5"/>
+          </a:solidFill>
+          <a:ln>
+            <a:noFill/>
+          </a:ln>
+          <a:effectLst/>
+        </p:spPr>
+        <p:style>
+          <a:lnRef idx="1">
+            <a:schemeClr val="accent1"/>
+          </a:lnRef>
+          <a:fillRef idx="3">
+            <a:schemeClr val="accent1"/>
+          </a:fillRef>
+          <a:effectRef idx="2">
+            <a:schemeClr val="accent1"/>
+          </a:effectRef>
+          <a:fontRef idx="minor">
+            <a:schemeClr val="lt1"/>
+          </a:fontRef>
+        </p:style>
+        <p:txBody>
+          <a:bodyPr rtlCol="0" anchor="ctr"/>
+          <a:lstStyle/>
+          <a:p>
+            <a:pPr algn="ctr"/>
+          </a:p>
+        </p:txBody>
+      </p:sp>
+      <p:sp>
+        <p:nvSpPr>
+          <p:cNvPr id="18" name="Rectangle 17"/>
+          <p:cNvSpPr/>
+          <p:nvPr/>
+        </p:nvSpPr>
+        <p:spPr>
+          <a:xfrm>
+            <a:off x="411480" y="3310128"/>
+            <a:ext cx="82296" cy="1325880"/>
+          </a:xfrm>
+          <a:prstGeom prst="rect">
+            <a:avLst/>
+          </a:prstGeom>
+          <a:solidFill>
+            <a:srgbClr val="059669"/>
+          </a:solidFill>
+          <a:ln>
+            <a:noFill/>
+          </a:ln>
+          <a:effectLst/>
+        </p:spPr>
+        <p:style>
+          <a:lnRef idx="1">
+            <a:schemeClr val="accent1"/>
+          </a:lnRef>
+          <a:fillRef idx="3">
+            <a:schemeClr val="accent1"/>
+          </a:fillRef>
+          <a:effectRef idx="2">
+            <a:schemeClr val="accent1"/>
+          </a:effectRef>
+          <a:fontRef idx="minor">
+            <a:schemeClr val="lt1"/>
+          </a:fontRef>
+        </p:style>
+        <p:txBody>
+          <a:bodyPr rtlCol="0" anchor="ctr"/>
+          <a:lstStyle/>
+          <a:p>
+            <a:pPr algn="ctr"/>
+          </a:p>
+        </p:txBody>
+      </p:sp>
+      <p:sp>
+        <p:nvSpPr>
+          <p:cNvPr id="19" name="TextBox 18"/>
+          <p:cNvSpPr txBox="1"/>
+          <p:nvPr/>
+        </p:nvSpPr>
+        <p:spPr>
+          <a:xfrm>
+            <a:off x="667512" y="3419856"/>
+            <a:ext cx="5120640" cy="320040"/>
+          </a:xfrm>
+          <a:prstGeom prst="rect">
+            <a:avLst/>
+          </a:prstGeom>
+          <a:noFill/>
+        </p:spPr>
+        <p:txBody>
+          <a:bodyPr wrap="square" anchor="t" lIns="0" rIns="0" tIns="0" bIns="0">
+            <a:spAutoFit/>
+          </a:bodyPr>
+          <a:lstStyle/>
+          <a:p>
+            <a:pPr algn="l">
+              <a:lnSpc>
+                <a:spcPct val="100000"/>
+              </a:lnSpc>
+              <a:spcAft>
+                <a:spcPts val="400"/>
+              </a:spcAft>
+            </a:pPr>
+            <a:r>
+              <a:rPr sz="1350" b="1" i="0">
+                <a:solidFill>
+                  <a:srgbClr val="059669"/>
+                </a:solidFill>
+                <a:latin typeface="Calibri"/>
+              </a:rPr>
+              <a:t>Runs inside our walls</a:t>
+            </a:r>
+          </a:p>
+        </p:txBody>
+      </p:sp>
+      <p:sp>
+        <p:nvSpPr>
+          <p:cNvPr id="20" name="TextBox 19"/>
+          <p:cNvSpPr txBox="1"/>
+          <p:nvPr/>
+        </p:nvSpPr>
+        <p:spPr>
+          <a:xfrm>
+            <a:off x="667512" y="3767328"/>
+            <a:ext cx="5120640" cy="822960"/>
+          </a:xfrm>
+          <a:prstGeom prst="rect">
+            <a:avLst/>
+          </a:prstGeom>
+          <a:noFill/>
+        </p:spPr>
+        <p:txBody>
+          <a:bodyPr wrap="square" anchor="t" lIns="0" rIns="0" tIns="0" bIns="0">
+            <a:spAutoFit/>
+          </a:bodyPr>
+          <a:lstStyle/>
+          <a:p>
+            <a:pPr algn="l">
+              <a:lnSpc>
+                <a:spcPct val="110000"/>
+              </a:lnSpc>
+              <a:spcAft>
+                <a:spcPts val="400"/>
+              </a:spcAft>
+            </a:pPr>
+            <a:r>
+              <a:rPr sz="1050" b="0" i="0">
+                <a:solidFill>
+                  <a:srgbClr val="334155"/>
+                </a:solidFill>
+                <a:latin typeface="Calibri"/>
+              </a:rPr>
+              <a:t>Commercial tools are cloud SaaS — our CAD would live in their cloud. CostVision is on-prem with private AI routing and a provable air-gapped switch, both already built.</a:t>
+            </a:r>
+          </a:p>
+        </p:txBody>
+      </p:sp>
+      <p:sp>
+        <p:nvSpPr>
+          <p:cNvPr id="21" name="Rounded Rectangle 20"/>
+          <p:cNvSpPr/>
+          <p:nvPr/>
+        </p:nvSpPr>
+        <p:spPr>
+          <a:xfrm>
+            <a:off x="6217920" y="3310128"/>
+            <a:ext cx="5577840" cy="1325880"/>
+          </a:xfrm>
+          <a:prstGeom prst="roundRect">
+            <a:avLst>
+              <a:gd name="adj" fmla="val 9000"/>
+            </a:avLst>
+          </a:prstGeom>
+          <a:solidFill>
+            <a:srgbClr val="ECFDF5"/>
+          </a:solidFill>
+          <a:ln>
+            <a:noFill/>
+          </a:ln>
+          <a:effectLst/>
+        </p:spPr>
+        <p:style>
+          <a:lnRef idx="1">
+            <a:schemeClr val="accent1"/>
+          </a:lnRef>
+          <a:fillRef idx="3">
+            <a:schemeClr val="accent1"/>
+          </a:fillRef>
+          <a:effectRef idx="2">
+            <a:schemeClr val="accent1"/>
+          </a:effectRef>
+          <a:fontRef idx="minor">
+            <a:schemeClr val="lt1"/>
+          </a:fontRef>
+        </p:style>
+        <p:txBody>
+          <a:bodyPr rtlCol="0" anchor="ctr"/>
+          <a:lstStyle/>
+          <a:p>
+            <a:pPr algn="ctr"/>
+          </a:p>
+        </p:txBody>
+      </p:sp>
+      <p:sp>
+        <p:nvSpPr>
+          <p:cNvPr id="22" name="Rectangle 21"/>
+          <p:cNvSpPr/>
+          <p:nvPr/>
+        </p:nvSpPr>
+        <p:spPr>
+          <a:xfrm>
+            <a:off x="6217920" y="3310128"/>
+            <a:ext cx="82296" cy="1325880"/>
+          </a:xfrm>
+          <a:prstGeom prst="rect">
+            <a:avLst/>
+          </a:prstGeom>
+          <a:solidFill>
+            <a:srgbClr val="059669"/>
+          </a:solidFill>
+          <a:ln>
+            <a:noFill/>
+          </a:ln>
+          <a:effectLst/>
+        </p:spPr>
+        <p:style>
+          <a:lnRef idx="1">
+            <a:schemeClr val="accent1"/>
+          </a:lnRef>
+          <a:fillRef idx="3">
+            <a:schemeClr val="accent1"/>
+          </a:fillRef>
+          <a:effectRef idx="2">
+            <a:schemeClr val="accent1"/>
+          </a:effectRef>
+          <a:fontRef idx="minor">
+            <a:schemeClr val="lt1"/>
+          </a:fontRef>
+        </p:style>
+        <p:txBody>
+          <a:bodyPr rtlCol="0" anchor="ctr"/>
+          <a:lstStyle/>
+          <a:p>
+            <a:pPr algn="ctr"/>
+          </a:p>
+        </p:txBody>
+      </p:sp>
+      <p:sp>
+        <p:nvSpPr>
+          <p:cNvPr id="23" name="TextBox 22"/>
+          <p:cNvSpPr txBox="1"/>
+          <p:nvPr/>
+        </p:nvSpPr>
+        <p:spPr>
+          <a:xfrm>
+            <a:off x="6473952" y="3419856"/>
+            <a:ext cx="5120640" cy="320040"/>
+          </a:xfrm>
+          <a:prstGeom prst="rect">
+            <a:avLst/>
+          </a:prstGeom>
+          <a:noFill/>
+        </p:spPr>
+        <p:txBody>
+          <a:bodyPr wrap="square" anchor="t" lIns="0" rIns="0" tIns="0" bIns="0">
+            <a:spAutoFit/>
+          </a:bodyPr>
+          <a:lstStyle/>
+          <a:p>
+            <a:pPr algn="l">
+              <a:lnSpc>
+                <a:spcPct val="100000"/>
+              </a:lnSpc>
+              <a:spcAft>
+                <a:spcPts val="400"/>
+              </a:spcAft>
+            </a:pPr>
+            <a:r>
+              <a:rPr sz="1350" b="1" i="0">
+                <a:solidFill>
+                  <a:srgbClr val="059669"/>
+                </a:solidFill>
+                <a:latin typeface="Calibri"/>
+              </a:rPr>
+              <a:t>One platform, no module licences</a:t>
+            </a:r>
+          </a:p>
+        </p:txBody>
+      </p:sp>
+      <p:sp>
+        <p:nvSpPr>
+          <p:cNvPr id="24" name="TextBox 23"/>
+          <p:cNvSpPr txBox="1"/>
+          <p:nvPr/>
+        </p:nvSpPr>
+        <p:spPr>
+          <a:xfrm>
+            <a:off x="6473952" y="3767328"/>
+            <a:ext cx="5120640" cy="822960"/>
+          </a:xfrm>
+          <a:prstGeom prst="rect">
+            <a:avLst/>
+          </a:prstGeom>
+          <a:noFill/>
+        </p:spPr>
+        <p:txBody>
+          <a:bodyPr wrap="square" anchor="t" lIns="0" rIns="0" tIns="0" bIns="0">
+            <a:spAutoFit/>
+          </a:bodyPr>
+          <a:lstStyle/>
+          <a:p>
+            <a:pPr algn="l">
+              <a:lnSpc>
+                <a:spcPct val="110000"/>
+              </a:lnSpc>
+              <a:spcAft>
+                <a:spcPts val="400"/>
+              </a:spcAft>
+            </a:pPr>
+            <a:r>
+              <a:rPr sz="1050" b="0" i="0">
+                <a:solidFill>
+                  <a:srgbClr val="334155"/>
+                </a:solidFill>
+                <a:latin typeface="Calibri"/>
+              </a:rPr>
+              <a:t>18 commodity engines + automotive software costing + carbon + RFQ generation in one codebase. Vendors sell comparable breadth as separately licensed modules.</a:t>
+            </a:r>
+          </a:p>
+        </p:txBody>
+      </p:sp>
+      <p:sp>
+        <p:nvSpPr>
+          <p:cNvPr id="25" name="Rounded Rectangle 24"/>
+          <p:cNvSpPr/>
+          <p:nvPr/>
+        </p:nvSpPr>
+        <p:spPr>
+          <a:xfrm>
+            <a:off x="411480" y="4937760"/>
+            <a:ext cx="11384280" cy="914400"/>
+          </a:xfrm>
+          <a:prstGeom prst="roundRect">
+            <a:avLst>
+              <a:gd name="adj" fmla="val 8000"/>
+            </a:avLst>
+          </a:prstGeom>
+          <a:solidFill>
+            <a:srgbClr val="FFFBEB"/>
+          </a:solidFill>
+          <a:ln>
+            <a:noFill/>
+          </a:ln>
+          <a:effectLst/>
+        </p:spPr>
+        <p:style>
+          <a:lnRef idx="1">
+            <a:schemeClr val="accent1"/>
+          </a:lnRef>
+          <a:fillRef idx="3">
+            <a:schemeClr val="accent1"/>
+          </a:fillRef>
+          <a:effectRef idx="2">
+            <a:schemeClr val="accent1"/>
+          </a:effectRef>
+          <a:fontRef idx="minor">
+            <a:schemeClr val="lt1"/>
+          </a:fontRef>
+        </p:style>
+        <p:txBody>
+          <a:bodyPr rtlCol="0" anchor="ctr"/>
+          <a:lstStyle/>
+          <a:p>
+            <a:pPr algn="ctr"/>
+          </a:p>
+        </p:txBody>
+      </p:sp>
+      <p:sp>
+        <p:nvSpPr>
+          <p:cNvPr id="26" name="TextBox 25"/>
+          <p:cNvSpPr txBox="1"/>
+          <p:nvPr/>
+        </p:nvSpPr>
+        <p:spPr>
+          <a:xfrm>
+            <a:off x="685800" y="5056632"/>
+            <a:ext cx="10881360" cy="731520"/>
+          </a:xfrm>
+          <a:prstGeom prst="rect">
+            <a:avLst/>
+          </a:prstGeom>
+          <a:noFill/>
+        </p:spPr>
+        <p:txBody>
+          <a:bodyPr wrap="square" anchor="t" lIns="0" rIns="0" tIns="0" bIns="0">
+            <a:spAutoFit/>
+          </a:bodyPr>
+          <a:lstStyle/>
+          <a:p>
+            <a:pPr algn="l">
+              <a:lnSpc>
+                <a:spcPct val="115000"/>
+              </a:lnSpc>
+              <a:spcAft>
+                <a:spcPts val="400"/>
+              </a:spcAft>
+            </a:pPr>
+            <a:r>
+              <a:rPr sz="1200" b="1" i="0">
+                <a:solidFill>
+                  <a:srgbClr val="D97706"/>
+                </a:solidFill>
+                <a:latin typeface="Calibri"/>
+              </a:rPr>
+              <a:t>Honest caveat: </a:t>
+            </a:r>
+            <a:r>
+              <a:rPr sz="1150" b="0" i="0">
+                <a:solidFill>
+                  <a:srgbClr val="334155"/>
+                </a:solidFill>
+                <a:latin typeface="Calibri"/>
+              </a:rPr>
+              <a:t>vendors like aPriori have decades of curated global cost data behind their numbers. Our answer is the learning loop: every quote CAPEE logs turns OUR history into a moat no vendor can buy — and our rates stay confidential.</a:t>
+            </a:r>
+          </a:p>
+        </p:txBody>
+      </p:sp>
+      <p:sp>
+        <p:nvSpPr>
+          <p:cNvPr id="27" name="TextBox 26"/>
+          <p:cNvSpPr txBox="1"/>
+          <p:nvPr/>
+        </p:nvSpPr>
+        <p:spPr>
+          <a:xfrm>
+            <a:off x="411480" y="5989320"/>
+            <a:ext cx="11338560" cy="320040"/>
+          </a:xfrm>
+          <a:prstGeom prst="rect">
+            <a:avLst/>
+          </a:prstGeom>
+          <a:noFill/>
+        </p:spPr>
+        <p:txBody>
+          <a:bodyPr wrap="square" anchor="t" lIns="0" rIns="0" tIns="0" bIns="0">
+            <a:spAutoFit/>
+          </a:bodyPr>
+          <a:lstStyle/>
+          <a:p>
+            <a:pPr algn="l">
+              <a:lnSpc>
+                <a:spcPct val="100000"/>
+              </a:lnSpc>
+              <a:spcAft>
+                <a:spcPts val="400"/>
+              </a:spcAft>
+            </a:pPr>
+            <a:r>
+              <a:rPr sz="1200" b="1" i="0">
+                <a:solidFill>
+                  <a:srgbClr val="0F172A"/>
+                </a:solidFill>
+                <a:latin typeface="Calibri"/>
+              </a:rPr>
+              <a:t>Positioning: not "better than aPriori" — an internal, secure, self-learning costing engine behind CAPEE that gets smarter on our own data.</a:t>
+            </a:r>
+          </a:p>
+        </p:txBody>
+      </p:sp>
+      <p:sp>
+        <p:nvSpPr>
+          <p:cNvPr id="28" name="TextBox 27"/>
+          <p:cNvSpPr txBox="1"/>
+          <p:nvPr/>
+        </p:nvSpPr>
+        <p:spPr>
+          <a:xfrm>
+            <a:off x="411480" y="6355080"/>
+            <a:ext cx="11338560" cy="228600"/>
+          </a:xfrm>
+          <a:prstGeom prst="rect">
+            <a:avLst/>
+          </a:prstGeom>
+          <a:noFill/>
+        </p:spPr>
+        <p:txBody>
+          <a:bodyPr wrap="square" anchor="t" lIns="0" rIns="0" tIns="0" bIns="0">
+            <a:spAutoFit/>
+          </a:bodyPr>
+          <a:lstStyle/>
+          <a:p>
+            <a:pPr algn="l">
+              <a:lnSpc>
+                <a:spcPct val="100000"/>
+              </a:lnSpc>
+              <a:spcAft>
+                <a:spcPts val="400"/>
+              </a:spcAft>
+            </a:pPr>
+            <a:r>
+              <a:rPr sz="850" b="0" i="1">
+                <a:solidFill>
+                  <a:srgbClr val="64748B"/>
+                </a:solidFill>
+                <a:latin typeface="Calibri"/>
+              </a:rPr>
+              <a:t>Sources: apriori.com · siemens.com/teamcenter · tset.com · globenewswire.com (A2MAC1-Tset, 18 Jun 2026) · dfma.com · emithran.com · flux.ai · circuitmind.io</a:t>
+            </a:r>
           </a:p>
         </p:txBody>
       </p:sp>

</xml_diff>

<commit_message>
Fix rate-library xlsx upload + blueprint backup slide with live proof
The multer fileFilter in rate-library.ts called cb(null) on accepted files,
which multer treats as 'skip' — so every company rate-library upload (main
and SW) failed with 'No file uploaded'. Accept now passes cb(null, true),
matching pcb.ts. Verified live: full template workbook (328 materials,
155 machines, 42 labour, 11 energy, 9 FX, 23 overhead rows) uploads,
validates and activates. 793 tests pass.

Blueprint deck: new backup slide 18 'Your rates, not vendor rates' with a
live screenshot of the Rate Library screen showing the company workbook
uploaded and active, the 3-step admin flow, live-proof counts and speaker
notes.

Co-Authored-By: Claude Fable 5 <noreply@anthropic.com>
Claude-Session: https://claude.ai/code/session_0142L4rKS2AV8rxQTDWMs7dy
</commit_message>
<xml_diff>
--- a/CostVision-Implementation-Blueprint.pptx
+++ b/CostVision-Implementation-Blueprint.pptx
@@ -22,6 +22,7 @@
     <p:sldId id="270" r:id="rId22"/>
     <p:sldId id="271" r:id="rId23"/>
     <p:sldId id="272" r:id="rId24"/>
+    <p:sldId id="273" r:id="rId25"/>
   </p:sldIdLst>
   <p:sldSz cx="12191695" cy="6858000" type="screen4x3"/>
   <p:notesSz cx="6858000" cy="9144000"/>
@@ -1079,6 +1080,76 @@
           <a:p>
             <a:r>
               <a:t>The second half of the backup answer: given the market exists, why build our own? Four things no vendor offers today. One — photo-to-cost for PCBs: photograph a supplier's or competitor's board and get a costed bill of materials; design tools generate BOMs during design, but no costing suite does this from photos. Two — the self-learning loop: CostVision calibrates on our own purchase-order prices, cutting error from about eleven percent to under one percent in testing after just three quotes, and raises findings on its own; the incumbents are only now marketing toward AI-enabled costing. Three — deployment: the commercial tools are cloud SaaS, meaning our CAD and our rates would sit in a vendor's cloud; CostVision runs inside our network with the private-AI and air-gap controls already built. Four — breadth without per-module licences. And the honest caveat management should hear: aPriori's strength is decades of curated cost data. Our counter is that every quote CAPEE logs makes CostVision smarter on OUR parts, OUR suppliers, OUR regions — data no vendor has. The positioning is not 'better than aPriori'; it is an internal, secure, self-learning engine behind CAPEE.</a:t>
+            </a:r>
+          </a:p>
+        </p:txBody>
+      </p:sp>
+      <p:sp>
+        <p:nvSpPr>
+          <p:cNvPr id="4" name="Slide Number Placeholder 3"/>
+          <p:cNvSpPr>
+            <a:spLocks noGrp="1"/>
+          </p:cNvSpPr>
+          <p:nvPr>
+            <p:ph type="sldNum" idx="5" sz="quarter"/>
+          </p:nvPr>
+        </p:nvSpPr>
+        <p:spPr/>
+      </p:sp>
+    </p:spTree>
+  </p:cSld>
+  <p:clrMapOvr>
+    <a:masterClrMapping/>
+  </p:clrMapOvr>
+</p:notes>
+</file>
+
+<file path=ppt/notesSlides/notesSlide18.xml><?xml version="1.0" encoding="utf-8"?>
+<p:notes xmlns:a="http://schemas.openxmlformats.org/drawingml/2006/main" xmlns:p="http://schemas.openxmlformats.org/presentationml/2006/main" xmlns:r="http://schemas.openxmlformats.org/officeDocument/2006/relationships">
+  <p:cSld>
+    <p:spTree>
+      <p:nvGrpSpPr>
+        <p:cNvPr id="1" name=""/>
+        <p:cNvGrpSpPr/>
+        <p:nvPr/>
+      </p:nvGrpSpPr>
+      <p:grpSpPr>
+        <a:xfrm>
+          <a:off x="0" y="0"/>
+          <a:ext cx="0" cy="0"/>
+          <a:chOff x="0" y="0"/>
+          <a:chExt cx="0" cy="0"/>
+        </a:xfrm>
+      </p:grpSpPr>
+      <p:sp>
+        <p:nvSpPr>
+          <p:cNvPr id="2" name="Slide Image Placeholder 1"/>
+          <p:cNvSpPr>
+            <a:spLocks noGrp="1"/>
+          </p:cNvSpPr>
+          <p:nvPr>
+            <p:ph type="sldImg" idx="2"/>
+          </p:nvPr>
+        </p:nvSpPr>
+        <p:spPr/>
+      </p:sp>
+      <p:sp>
+        <p:nvSpPr>
+          <p:cNvPr id="3" name="Notes Placeholder 2"/>
+          <p:cNvSpPr>
+            <a:spLocks noGrp="1"/>
+          </p:cNvSpPr>
+          <p:nvPr>
+            <p:ph type="body" idx="3" sz="quarter"/>
+          </p:nvPr>
+        </p:nvSpPr>
+        <p:spPr/>
+        <p:txBody>
+          <a:bodyPr/>
+          <a:lstStyle/>
+          <a:p>
+            <a:r>
+              <a:t>This backup slide answers 'whose numbers are these?' The answer: ours, whenever we want them to be. What you see is a live screenshot of the tool, not a mock-up. An administrator downloads an Excel template with six sheets — materials, machines, labour, energy, exchange rates and overheads — fills in our company rates, and uploads it. The file is validated row by row and becomes the active rate library instantly; the green badge confirms company rates are in force. After that, any single cell can be fine-tuned in the on-screen tables, and every change is recorded with the user's name and a timestamp — a full audit trail. We proved this live: a complete workbook with over five hundred rows across the six sheets uploaded, validated and activated. On top of that, the tool ships twenty country rate sets with eight labour categories each, the PCB country cost table is editable the same way, and the software-costing engine has its own separate library. And if anything goes wrong, one click returns to the built-in defaults. So management should hear this clearly: the tool calculates on OUR labour, material, machine and energy rates, by country — vendor tools can't offer that level of transparency and control.</a:t>
             </a:r>
           </a:p>
         </p:txBody>
@@ -15034,6 +15105,720 @@
                 <a:latin typeface="Calibri"/>
               </a:rPr>
               <a:t>Sources: apriori.com · siemens.com/teamcenter · tset.com · globenewswire.com (A2MAC1-Tset, 18 Jun 2026) · dfma.com · emithran.com · flux.ai · circuitmind.io</a:t>
+            </a:r>
+          </a:p>
+        </p:txBody>
+      </p:sp>
+    </p:spTree>
+  </p:cSld>
+  <p:clrMapOvr>
+    <a:masterClrMapping/>
+  </p:clrMapOvr>
+</p:sld>
+</file>
+
+<file path=ppt/slides/slide18.xml><?xml version="1.0" encoding="utf-8"?>
+<p:sld xmlns:a="http://schemas.openxmlformats.org/drawingml/2006/main" xmlns:p="http://schemas.openxmlformats.org/presentationml/2006/main" xmlns:r="http://schemas.openxmlformats.org/officeDocument/2006/relationships">
+  <p:cSld>
+    <p:spTree>
+      <p:nvGrpSpPr>
+        <p:cNvPr id="1" name=""/>
+        <p:cNvGrpSpPr/>
+        <p:nvPr/>
+      </p:nvGrpSpPr>
+      <p:grpSpPr/>
+      <p:sp>
+        <p:nvSpPr>
+          <p:cNvPr id="2" name="Rectangle 1"/>
+          <p:cNvSpPr/>
+          <p:nvPr/>
+        </p:nvSpPr>
+        <p:spPr>
+          <a:xfrm>
+            <a:off x="0" y="0"/>
+            <a:ext cx="12191695" cy="6858000"/>
+          </a:xfrm>
+          <a:prstGeom prst="rect">
+            <a:avLst/>
+          </a:prstGeom>
+          <a:solidFill>
+            <a:srgbClr val="FFFFFF"/>
+          </a:solidFill>
+          <a:ln>
+            <a:noFill/>
+          </a:ln>
+          <a:effectLst/>
+        </p:spPr>
+        <p:style>
+          <a:lnRef idx="1">
+            <a:schemeClr val="accent1"/>
+          </a:lnRef>
+          <a:fillRef idx="3">
+            <a:schemeClr val="accent1"/>
+          </a:fillRef>
+          <a:effectRef idx="2">
+            <a:schemeClr val="accent1"/>
+          </a:effectRef>
+          <a:fontRef idx="minor">
+            <a:schemeClr val="lt1"/>
+          </a:fontRef>
+        </p:style>
+        <p:txBody>
+          <a:bodyPr rtlCol="0" anchor="ctr"/>
+          <a:lstStyle/>
+          <a:p>
+            <a:pPr algn="ctr"/>
+          </a:p>
+        </p:txBody>
+      </p:sp>
+      <p:sp>
+        <p:nvSpPr>
+          <p:cNvPr id="3" name="Rounded Rectangle 2"/>
+          <p:cNvSpPr/>
+          <p:nvPr/>
+        </p:nvSpPr>
+        <p:spPr>
+          <a:xfrm>
+            <a:off x="320040" y="201168"/>
+            <a:ext cx="384048" cy="384048"/>
+          </a:xfrm>
+          <a:prstGeom prst="roundRect">
+            <a:avLst>
+              <a:gd name="adj" fmla="val 28000"/>
+            </a:avLst>
+          </a:prstGeom>
+          <a:solidFill>
+            <a:srgbClr val="4F46E5"/>
+          </a:solidFill>
+          <a:ln>
+            <a:noFill/>
+          </a:ln>
+          <a:effectLst/>
+        </p:spPr>
+        <p:style>
+          <a:lnRef idx="1">
+            <a:schemeClr val="accent1"/>
+          </a:lnRef>
+          <a:fillRef idx="3">
+            <a:schemeClr val="accent1"/>
+          </a:fillRef>
+          <a:effectRef idx="2">
+            <a:schemeClr val="accent1"/>
+          </a:effectRef>
+          <a:fontRef idx="minor">
+            <a:schemeClr val="lt1"/>
+          </a:fontRef>
+        </p:style>
+        <p:txBody>
+          <a:bodyPr rtlCol="0" anchor="ctr" lIns="0" rIns="0" tIns="0" bIns="0"/>
+          <a:lstStyle/>
+          <a:p>
+            <a:pPr algn="ctr"/>
+            <a:r>
+              <a:rPr sz="1700" b="1">
+                <a:solidFill>
+                  <a:srgbClr val="FFFFFF"/>
+                </a:solidFill>
+                <a:latin typeface="Calibri"/>
+              </a:rPr>
+              <a:t>cv</a:t>
+            </a:r>
+          </a:p>
+        </p:txBody>
+      </p:sp>
+      <p:sp>
+        <p:nvSpPr>
+          <p:cNvPr id="4" name="TextBox 3"/>
+          <p:cNvSpPr txBox="1"/>
+          <p:nvPr/>
+        </p:nvSpPr>
+        <p:spPr>
+          <a:xfrm>
+            <a:off x="795528" y="173736"/>
+            <a:ext cx="2377440" cy="292608"/>
+          </a:xfrm>
+          <a:prstGeom prst="rect">
+            <a:avLst/>
+          </a:prstGeom>
+          <a:noFill/>
+        </p:spPr>
+        <p:txBody>
+          <a:bodyPr wrap="square" anchor="t" lIns="0" rIns="0" tIns="0" bIns="0">
+            <a:spAutoFit/>
+          </a:bodyPr>
+          <a:lstStyle/>
+          <a:p>
+            <a:pPr algn="l">
+              <a:lnSpc>
+                <a:spcPct val="100000"/>
+              </a:lnSpc>
+              <a:spcAft>
+                <a:spcPts val="400"/>
+              </a:spcAft>
+            </a:pPr>
+            <a:r>
+              <a:rPr sz="1800" b="1" i="0">
+                <a:solidFill>
+                  <a:srgbClr val="2563EB"/>
+                </a:solidFill>
+                <a:latin typeface="Calibri"/>
+              </a:rPr>
+              <a:t>CostVision</a:t>
+            </a:r>
+          </a:p>
+        </p:txBody>
+      </p:sp>
+      <p:sp>
+        <p:nvSpPr>
+          <p:cNvPr id="5" name="TextBox 4"/>
+          <p:cNvSpPr txBox="1"/>
+          <p:nvPr/>
+        </p:nvSpPr>
+        <p:spPr>
+          <a:xfrm>
+            <a:off x="795528" y="420624"/>
+            <a:ext cx="2560320" cy="201168"/>
+          </a:xfrm>
+          <a:prstGeom prst="rect">
+            <a:avLst/>
+          </a:prstGeom>
+          <a:noFill/>
+        </p:spPr>
+        <p:txBody>
+          <a:bodyPr wrap="square" anchor="t" lIns="0" rIns="0" tIns="0" bIns="0">
+            <a:spAutoFit/>
+          </a:bodyPr>
+          <a:lstStyle/>
+          <a:p>
+            <a:pPr algn="l">
+              <a:lnSpc>
+                <a:spcPct val="100000"/>
+              </a:lnSpc>
+              <a:spcAft>
+                <a:spcPts val="400"/>
+              </a:spcAft>
+            </a:pPr>
+            <a:r>
+              <a:rPr sz="750" b="0" i="0">
+                <a:solidFill>
+                  <a:srgbClr val="64748B"/>
+                </a:solidFill>
+                <a:latin typeface="Calibri"/>
+              </a:rPr>
+              <a:t>AI  COST  INTELLIGENCE</a:t>
+            </a:r>
+          </a:p>
+        </p:txBody>
+      </p:sp>
+      <p:sp>
+        <p:nvSpPr>
+          <p:cNvPr id="6" name="Rectangle 5"/>
+          <p:cNvSpPr/>
+          <p:nvPr/>
+        </p:nvSpPr>
+        <p:spPr>
+          <a:xfrm>
+            <a:off x="0" y="713232"/>
+            <a:ext cx="12191695" cy="27940"/>
+          </a:xfrm>
+          <a:prstGeom prst="rect">
+            <a:avLst/>
+          </a:prstGeom>
+          <a:solidFill>
+            <a:srgbClr val="4F46E5"/>
+          </a:solidFill>
+          <a:ln>
+            <a:noFill/>
+          </a:ln>
+          <a:effectLst/>
+        </p:spPr>
+        <p:style>
+          <a:lnRef idx="1">
+            <a:schemeClr val="accent1"/>
+          </a:lnRef>
+          <a:fillRef idx="3">
+            <a:schemeClr val="accent1"/>
+          </a:fillRef>
+          <a:effectRef idx="2">
+            <a:schemeClr val="accent1"/>
+          </a:effectRef>
+          <a:fontRef idx="minor">
+            <a:schemeClr val="lt1"/>
+          </a:fontRef>
+        </p:style>
+        <p:txBody>
+          <a:bodyPr rtlCol="0" anchor="ctr"/>
+          <a:lstStyle/>
+          <a:p>
+            <a:pPr algn="ctr"/>
+          </a:p>
+        </p:txBody>
+      </p:sp>
+      <p:sp>
+        <p:nvSpPr>
+          <p:cNvPr id="7" name="TextBox 6"/>
+          <p:cNvSpPr txBox="1"/>
+          <p:nvPr/>
+        </p:nvSpPr>
+        <p:spPr>
+          <a:xfrm>
+            <a:off x="411480" y="868680"/>
+            <a:ext cx="10515600" cy="274320"/>
+          </a:xfrm>
+          <a:prstGeom prst="rect">
+            <a:avLst/>
+          </a:prstGeom>
+          <a:noFill/>
+        </p:spPr>
+        <p:txBody>
+          <a:bodyPr wrap="square" anchor="t" lIns="0" rIns="0" tIns="0" bIns="0">
+            <a:spAutoFit/>
+          </a:bodyPr>
+          <a:lstStyle/>
+          <a:p>
+            <a:pPr algn="l">
+              <a:lnSpc>
+                <a:spcPct val="100000"/>
+              </a:lnSpc>
+              <a:spcAft>
+                <a:spcPts val="400"/>
+              </a:spcAft>
+            </a:pPr>
+            <a:r>
+              <a:rPr sz="1100" b="1" i="0">
+                <a:solidFill>
+                  <a:srgbClr val="2563EB"/>
+                </a:solidFill>
+                <a:latin typeface="Calibri"/>
+              </a:rPr>
+              <a:t>BACKUP · COMPANY COST DATABASE</a:t>
+            </a:r>
+          </a:p>
+        </p:txBody>
+      </p:sp>
+      <p:sp>
+        <p:nvSpPr>
+          <p:cNvPr id="8" name="TextBox 7"/>
+          <p:cNvSpPr txBox="1"/>
+          <p:nvPr/>
+        </p:nvSpPr>
+        <p:spPr>
+          <a:xfrm>
+            <a:off x="411480" y="1115568"/>
+            <a:ext cx="11338560" cy="548640"/>
+          </a:xfrm>
+          <a:prstGeom prst="rect">
+            <a:avLst/>
+          </a:prstGeom>
+          <a:noFill/>
+        </p:spPr>
+        <p:txBody>
+          <a:bodyPr wrap="square" anchor="t" lIns="0" rIns="0" tIns="0" bIns="0">
+            <a:spAutoFit/>
+          </a:bodyPr>
+          <a:lstStyle/>
+          <a:p>
+            <a:pPr algn="l">
+              <a:lnSpc>
+                <a:spcPct val="100000"/>
+              </a:lnSpc>
+              <a:spcAft>
+                <a:spcPts val="400"/>
+              </a:spcAft>
+            </a:pPr>
+            <a:r>
+              <a:rPr sz="2700" b="1" i="0">
+                <a:solidFill>
+                  <a:srgbClr val="0F172A"/>
+                </a:solidFill>
+                <a:latin typeface="Calibri"/>
+              </a:rPr>
+              <a:t>Your rates, not vendor rates — already built</a:t>
+            </a:r>
+          </a:p>
+        </p:txBody>
+      </p:sp>
+      <p:pic>
+        <p:nvPicPr>
+          <p:cNvPr id="9" name="Picture 8" descr="rate-library-upload-proof.png"/>
+          <p:cNvPicPr>
+            <a:picLocks noChangeAspect="1"/>
+          </p:cNvPicPr>
+          <p:nvPr/>
+        </p:nvPicPr>
+        <p:blipFill>
+          <a:blip r:embed="rId2"/>
+          <a:stretch>
+            <a:fillRect/>
+          </a:stretch>
+        </p:blipFill>
+        <p:spPr>
+          <a:xfrm>
+            <a:off x="411480" y="1828800"/>
+            <a:ext cx="6309360" cy="4234893"/>
+          </a:xfrm>
+          <a:prstGeom prst="rect">
+            <a:avLst/>
+          </a:prstGeom>
+          <a:ln w="12700">
+            <a:solidFill>
+              <a:srgbClr val="E2E8F0"/>
+            </a:solidFill>
+          </a:ln>
+        </p:spPr>
+      </p:pic>
+      <p:sp>
+        <p:nvSpPr>
+          <p:cNvPr id="10" name="TextBox 9"/>
+          <p:cNvSpPr txBox="1"/>
+          <p:nvPr/>
+        </p:nvSpPr>
+        <p:spPr>
+          <a:xfrm>
+            <a:off x="411480" y="6144768"/>
+            <a:ext cx="6309360" cy="457200"/>
+          </a:xfrm>
+          <a:prstGeom prst="rect">
+            <a:avLst/>
+          </a:prstGeom>
+          <a:noFill/>
+        </p:spPr>
+        <p:txBody>
+          <a:bodyPr wrap="square" anchor="t" lIns="0" rIns="0" tIns="0" bIns="0">
+            <a:spAutoFit/>
+          </a:bodyPr>
+          <a:lstStyle/>
+          <a:p>
+            <a:pPr algn="l">
+              <a:lnSpc>
+                <a:spcPct val="110000"/>
+              </a:lnSpc>
+              <a:spcAft>
+                <a:spcPts val="400"/>
+              </a:spcAft>
+            </a:pPr>
+            <a:r>
+              <a:rPr sz="950" b="0" i="1">
+                <a:solidFill>
+                  <a:srgbClr val="64748B"/>
+                </a:solidFill>
+                <a:latin typeface="Calibri"/>
+              </a:rPr>
+              <a:t>Live screenshot (July 2026): Rate Library screen after a company workbook upload — badge shows "Company rates active".</a:t>
+            </a:r>
+          </a:p>
+        </p:txBody>
+      </p:sp>
+      <p:sp>
+        <p:nvSpPr>
+          <p:cNvPr id="11" name="TextBox 10"/>
+          <p:cNvSpPr txBox="1"/>
+          <p:nvPr/>
+        </p:nvSpPr>
+        <p:spPr>
+          <a:xfrm>
+            <a:off x="6949440" y="1828800"/>
+            <a:ext cx="4846320" cy="2194560"/>
+          </a:xfrm>
+          <a:prstGeom prst="rect">
+            <a:avLst/>
+          </a:prstGeom>
+          <a:noFill/>
+        </p:spPr>
+        <p:txBody>
+          <a:bodyPr wrap="square" anchor="t" lIns="0" rIns="0" tIns="0" bIns="0">
+            <a:spAutoFit/>
+          </a:bodyPr>
+          <a:lstStyle/>
+          <a:p>
+            <a:pPr algn="l">
+              <a:lnSpc>
+                <a:spcPct val="115000"/>
+              </a:lnSpc>
+              <a:spcAft>
+                <a:spcPts val="700"/>
+              </a:spcAft>
+            </a:pPr>
+            <a:r>
+              <a:rPr sz="1400" b="1" i="0">
+                <a:solidFill>
+                  <a:srgbClr val="2563EB"/>
+                </a:solidFill>
+                <a:latin typeface="Calibri"/>
+              </a:rPr>
+              <a:t>How admins load company data</a:t>
+            </a:r>
+          </a:p>
+          <a:p>
+            <a:pPr algn="l">
+              <a:lnSpc>
+                <a:spcPct val="115000"/>
+              </a:lnSpc>
+              <a:spcAft>
+                <a:spcPts val="700"/>
+              </a:spcAft>
+            </a:pPr>
+            <a:r>
+              <a:rPr sz="1150" b="0" i="0">
+                <a:solidFill>
+                  <a:srgbClr val="334155"/>
+                </a:solidFill>
+                <a:latin typeface="Calibri"/>
+              </a:rPr>
+              <a:t>1.  Download the Excel template — six sheets: Materials · Machines · Labour · Energy · FX · Overhead.</a:t>
+            </a:r>
+          </a:p>
+          <a:p>
+            <a:pPr algn="l">
+              <a:lnSpc>
+                <a:spcPct val="115000"/>
+              </a:lnSpc>
+              <a:spcAft>
+                <a:spcPts val="700"/>
+              </a:spcAft>
+            </a:pPr>
+            <a:r>
+              <a:rPr sz="1150" b="0" i="0">
+                <a:solidFill>
+                  <a:srgbClr val="334155"/>
+                </a:solidFill>
+                <a:latin typeface="Calibri"/>
+              </a:rPr>
+              <a:t>2.  Fill in our rates and upload — every row is validated; the file becomes the active library instantly.</a:t>
+            </a:r>
+          </a:p>
+          <a:p>
+            <a:pPr algn="l">
+              <a:lnSpc>
+                <a:spcPct val="115000"/>
+              </a:lnSpc>
+              <a:spcAft>
+                <a:spcPts val="700"/>
+              </a:spcAft>
+            </a:pPr>
+            <a:r>
+              <a:rPr sz="1150" b="0" i="0">
+                <a:solidFill>
+                  <a:srgbClr val="334155"/>
+                </a:solidFill>
+                <a:latin typeface="Calibri"/>
+              </a:rPr>
+              <a:t>3.  Fine-tune any single cell in the tables — each change is logged with the user's name and a timestamp.</a:t>
+            </a:r>
+          </a:p>
+        </p:txBody>
+      </p:sp>
+      <p:sp>
+        <p:nvSpPr>
+          <p:cNvPr id="12" name="Rounded Rectangle 11"/>
+          <p:cNvSpPr/>
+          <p:nvPr/>
+        </p:nvSpPr>
+        <p:spPr>
+          <a:xfrm>
+            <a:off x="6949440" y="3977639"/>
+            <a:ext cx="4846320" cy="1051560"/>
+          </a:xfrm>
+          <a:prstGeom prst="roundRect">
+            <a:avLst>
+              <a:gd name="adj" fmla="val 10000"/>
+            </a:avLst>
+          </a:prstGeom>
+          <a:solidFill>
+            <a:srgbClr val="ECFDF5"/>
+          </a:solidFill>
+          <a:ln>
+            <a:noFill/>
+          </a:ln>
+          <a:effectLst/>
+        </p:spPr>
+        <p:style>
+          <a:lnRef idx="1">
+            <a:schemeClr val="accent1"/>
+          </a:lnRef>
+          <a:fillRef idx="3">
+            <a:schemeClr val="accent1"/>
+          </a:fillRef>
+          <a:effectRef idx="2">
+            <a:schemeClr val="accent1"/>
+          </a:effectRef>
+          <a:fontRef idx="minor">
+            <a:schemeClr val="lt1"/>
+          </a:fontRef>
+        </p:style>
+        <p:txBody>
+          <a:bodyPr rtlCol="0" anchor="ctr"/>
+          <a:lstStyle/>
+          <a:p>
+            <a:pPr algn="ctr"/>
+          </a:p>
+        </p:txBody>
+      </p:sp>
+      <p:sp>
+        <p:nvSpPr>
+          <p:cNvPr id="13" name="TextBox 12"/>
+          <p:cNvSpPr txBox="1"/>
+          <p:nvPr/>
+        </p:nvSpPr>
+        <p:spPr>
+          <a:xfrm>
+            <a:off x="7178040" y="4114800"/>
+            <a:ext cx="4434840" cy="822960"/>
+          </a:xfrm>
+          <a:prstGeom prst="rect">
+            <a:avLst/>
+          </a:prstGeom>
+          <a:noFill/>
+        </p:spPr>
+        <p:txBody>
+          <a:bodyPr wrap="square" anchor="t" lIns="0" rIns="0" tIns="0" bIns="0">
+            <a:spAutoFit/>
+          </a:bodyPr>
+          <a:lstStyle/>
+          <a:p>
+            <a:pPr algn="l">
+              <a:lnSpc>
+                <a:spcPct val="115000"/>
+              </a:lnSpc>
+              <a:spcAft>
+                <a:spcPts val="400"/>
+              </a:spcAft>
+            </a:pPr>
+            <a:r>
+              <a:rPr sz="1150" b="1" i="0">
+                <a:solidFill>
+                  <a:srgbClr val="059669"/>
+                </a:solidFill>
+                <a:latin typeface="Calibri"/>
+              </a:rPr>
+              <a:t>Proven live today:  </a:t>
+            </a:r>
+            <a:r>
+              <a:rPr sz="1100" b="0" i="0">
+                <a:solidFill>
+                  <a:srgbClr val="334155"/>
+                </a:solidFill>
+                <a:latin typeface="Calibri"/>
+              </a:rPr>
+              <a:t>a full workbook uploaded and accepted — 328 materials, 155 machines, 42 labour, 11 energy, 9 FX and 23 overhead rows — then activated.</a:t>
+            </a:r>
+          </a:p>
+        </p:txBody>
+      </p:sp>
+      <p:sp>
+        <p:nvSpPr>
+          <p:cNvPr id="14" name="TextBox 13"/>
+          <p:cNvSpPr txBox="1"/>
+          <p:nvPr/>
+        </p:nvSpPr>
+        <p:spPr>
+          <a:xfrm>
+            <a:off x="6949440" y="5212080"/>
+            <a:ext cx="4846320" cy="1280160"/>
+          </a:xfrm>
+          <a:prstGeom prst="rect">
+            <a:avLst/>
+          </a:prstGeom>
+          <a:noFill/>
+        </p:spPr>
+        <p:txBody>
+          <a:bodyPr wrap="square" anchor="t" lIns="0" rIns="0" tIns="0" bIns="0">
+            <a:spAutoFit/>
+          </a:bodyPr>
+          <a:lstStyle/>
+          <a:p>
+            <a:pPr algn="l">
+              <a:lnSpc>
+                <a:spcPct val="112000"/>
+              </a:lnSpc>
+              <a:spcAft>
+                <a:spcPts val="300"/>
+              </a:spcAft>
+            </a:pPr>
+            <a:r>
+              <a:rPr sz="1200" b="1" i="0">
+                <a:solidFill>
+                  <a:srgbClr val="0F172A"/>
+                </a:solidFill>
+                <a:latin typeface="Calibri"/>
+              </a:rPr>
+              <a:t>Also built in:</a:t>
+            </a:r>
+          </a:p>
+          <a:p>
+            <a:pPr algn="l">
+              <a:lnSpc>
+                <a:spcPct val="112000"/>
+              </a:lnSpc>
+              <a:spcAft>
+                <a:spcPts val="300"/>
+              </a:spcAft>
+            </a:pPr>
+            <a:r>
+              <a:rPr sz="1100" b="0" i="0">
+                <a:solidFill>
+                  <a:srgbClr val="334155"/>
+                </a:solidFill>
+                <a:latin typeface="Calibri"/>
+              </a:rPr>
+              <a:t>• 20 country rate sets, 8 labour categories each</a:t>
+            </a:r>
+          </a:p>
+          <a:p>
+            <a:pPr algn="l">
+              <a:lnSpc>
+                <a:spcPct val="112000"/>
+              </a:lnSpc>
+              <a:spcAft>
+                <a:spcPts val="300"/>
+              </a:spcAft>
+            </a:pPr>
+            <a:r>
+              <a:rPr sz="1100" b="0" i="0">
+                <a:solidFill>
+                  <a:srgbClr val="334155"/>
+                </a:solidFill>
+                <a:latin typeface="Calibri"/>
+              </a:rPr>
+              <a:t>• PCB country cost table — admin-editable</a:t>
+            </a:r>
+          </a:p>
+          <a:p>
+            <a:pPr algn="l">
+              <a:lnSpc>
+                <a:spcPct val="112000"/>
+              </a:lnSpc>
+              <a:spcAft>
+                <a:spcPts val="300"/>
+              </a:spcAft>
+            </a:pPr>
+            <a:r>
+              <a:rPr sz="1100" b="0" i="0">
+                <a:solidFill>
+                  <a:srgbClr val="334155"/>
+                </a:solidFill>
+                <a:latin typeface="Calibri"/>
+              </a:rPr>
+              <a:t>• Separate rate library for software costing</a:t>
+            </a:r>
+          </a:p>
+          <a:p>
+            <a:pPr algn="l">
+              <a:lnSpc>
+                <a:spcPct val="112000"/>
+              </a:lnSpc>
+              <a:spcAft>
+                <a:spcPts val="300"/>
+              </a:spcAft>
+            </a:pPr>
+            <a:r>
+              <a:rPr sz="1100" b="0" i="0">
+                <a:solidFill>
+                  <a:srgbClr val="334155"/>
+                </a:solidFill>
+                <a:latin typeface="Calibri"/>
+              </a:rPr>
+              <a:t>• One click back to built-in defaults, full audit trail</a:t>
             </a:r>
           </a:p>
         </p:txBody>

</xml_diff>

<commit_message>
Blueprint deck: business-case, evidence-chart and Q&A backup slides
Slide 19 'What it costs vs what it returns' — costs (weeks, VM, pay-per-use
AI, zero licences/own IP) vs returns (autonomous findings, avoided licence
spend, speed, leverage) with an honest-numbers caveat marking demo-derived
figures as indicative. Slide 20 'Does it actually work?' — native bar chart
of measured accuracy before/after learning (10.9->0.3%, 8.7->0.6%,
band 20.4->2.8%) plus stat tiles. Slide 21 'Questions you may be asking' —
five likely management questions with straight answers. Rollout slide 13
gains steady-state KPIs and a calendar anchor (~September 2026 pilot value).
Speaker notes on all new slides. Deck is now 21 slides.

Co-Authored-By: Claude Fable 5 <noreply@anthropic.com>
Claude-Session: https://claude.ai/code/session_0142L4rKS2AV8rxQTDWMs7dy
</commit_message>
<xml_diff>
--- a/CostVision-Implementation-Blueprint.pptx
+++ b/CostVision-Implementation-Blueprint.pptx
@@ -23,6 +23,9 @@
     <p:sldId id="271" r:id="rId23"/>
     <p:sldId id="272" r:id="rId24"/>
     <p:sldId id="273" r:id="rId25"/>
+    <p:sldId id="274" r:id="rId26"/>
+    <p:sldId id="275" r:id="rId27"/>
+    <p:sldId id="276" r:id="rId28"/>
   </p:sldIdLst>
   <p:sldSz cx="12191695" cy="6858000" type="screen4x3"/>
   <p:notesSz cx="6858000" cy="9144000"/>
@@ -122,6 +125,225 @@
     </a:lvl9pPr>
   </p:defaultTextStyle>
 </p:presentation>
+</file>
+
+<file path=ppt/charts/chart1.xml><?xml version="1.0" encoding="utf-8"?>
+<c:chartSpace xmlns:c="http://schemas.openxmlformats.org/drawingml/2006/chart" xmlns:a="http://schemas.openxmlformats.org/drawingml/2006/main" xmlns:r="http://schemas.openxmlformats.org/officeDocument/2006/relationships">
+  <c:date1904 val="0"/>
+  <c:chart>
+    <c:autoTitleDeleted val="0"/>
+    <c:plotArea>
+      <c:barChart>
+        <c:barDir val="col"/>
+        <c:grouping val="clustered"/>
+        <c:ser>
+          <c:idx val="0"/>
+          <c:order val="0"/>
+          <c:tx>
+            <c:strRef>
+              <c:f>Sheet1!$B$1</c:f>
+              <c:strCache>
+                <c:ptCount val="1"/>
+                <c:pt idx="0">
+                  <c:v>Before learning</c:v>
+                </c:pt>
+              </c:strCache>
+            </c:strRef>
+          </c:tx>
+          <c:spPr>
+            <a:solidFill>
+              <a:srgbClr val="64748B"/>
+            </a:solidFill>
+          </c:spPr>
+          <c:cat>
+            <c:strRef>
+              <c:f>Sheet1!$A$2:$A$4</c:f>
+              <c:strCache>
+                <c:ptCount val="3"/>
+                <c:pt idx="0">
+                  <c:v>Machining error %</c:v>
+                </c:pt>
+                <c:pt idx="1">
+                  <c:v>Casting error %</c:v>
+                </c:pt>
+                <c:pt idx="2">
+                  <c:v>Uncertainty band ±%</c:v>
+                </c:pt>
+              </c:strCache>
+            </c:strRef>
+          </c:cat>
+          <c:val>
+            <c:numRef>
+              <c:f>Sheet1!$B$2:$B$4</c:f>
+              <c:numCache>
+                <c:formatCode>General</c:formatCode>
+                <c:ptCount val="3"/>
+                <c:pt idx="0">
+                  <c:v>10.9</c:v>
+                </c:pt>
+                <c:pt idx="1">
+                  <c:v>8.7</c:v>
+                </c:pt>
+                <c:pt idx="2">
+                  <c:v>20.4</c:v>
+                </c:pt>
+              </c:numCache>
+            </c:numRef>
+          </c:val>
+        </c:ser>
+        <c:ser>
+          <c:idx val="1"/>
+          <c:order val="1"/>
+          <c:tx>
+            <c:strRef>
+              <c:f>Sheet1!$C$1</c:f>
+              <c:strCache>
+                <c:ptCount val="1"/>
+                <c:pt idx="0">
+                  <c:v>After 3 real quotes</c:v>
+                </c:pt>
+              </c:strCache>
+            </c:strRef>
+          </c:tx>
+          <c:spPr>
+            <a:solidFill>
+              <a:srgbClr val="059669"/>
+            </a:solidFill>
+          </c:spPr>
+          <c:cat>
+            <c:strRef>
+              <c:f>Sheet1!$A$2:$A$4</c:f>
+              <c:strCache>
+                <c:ptCount val="3"/>
+                <c:pt idx="0">
+                  <c:v>Machining error %</c:v>
+                </c:pt>
+                <c:pt idx="1">
+                  <c:v>Casting error %</c:v>
+                </c:pt>
+                <c:pt idx="2">
+                  <c:v>Uncertainty band ±%</c:v>
+                </c:pt>
+              </c:strCache>
+            </c:strRef>
+          </c:cat>
+          <c:val>
+            <c:numRef>
+              <c:f>Sheet1!$C$2:$C$4</c:f>
+              <c:numCache>
+                <c:formatCode>General</c:formatCode>
+                <c:ptCount val="3"/>
+                <c:pt idx="0">
+                  <c:v>0.3</c:v>
+                </c:pt>
+                <c:pt idx="1">
+                  <c:v>0.6</c:v>
+                </c:pt>
+                <c:pt idx="2">
+                  <c:v>2.8</c:v>
+                </c:pt>
+              </c:numCache>
+            </c:numRef>
+          </c:val>
+        </c:ser>
+        <c:dLbls>
+          <c:txPr>
+            <a:bodyPr/>
+            <a:lstStyle/>
+            <a:p>
+              <a:pPr>
+                <a:defRPr sz="950" b="1"/>
+              </a:pPr>
+            </a:p>
+          </c:txPr>
+          <c:showLegendKey val="0"/>
+          <c:showVal val="1"/>
+          <c:showCatName val="0"/>
+          <c:showSerName val="0"/>
+          <c:showPercent val="0"/>
+          <c:showBubbleSize val="0"/>
+          <c:showLeaderLines val="1"/>
+        </c:dLbls>
+        <c:axId val="-2068027336"/>
+        <c:axId val="-2113994440"/>
+      </c:barChart>
+      <c:catAx>
+        <c:axId val="-2068027336"/>
+        <c:scaling>
+          <c:orientation val="minMax"/>
+        </c:scaling>
+        <c:delete val="0"/>
+        <c:axPos val="b"/>
+        <c:majorTickMark val="out"/>
+        <c:minorTickMark val="none"/>
+        <c:tickLblPos val="nextTo"/>
+        <c:txPr>
+          <a:bodyPr/>
+          <a:lstStyle/>
+          <a:p>
+            <a:pPr>
+              <a:defRPr sz="950"/>
+            </a:pPr>
+          </a:p>
+        </c:txPr>
+        <c:crossAx val="-2113994440"/>
+        <c:crosses val="autoZero"/>
+        <c:auto val="1"/>
+        <c:lblAlgn val="ctr"/>
+        <c:lblOffset val="100"/>
+        <c:noMultiLvlLbl val="0"/>
+      </c:catAx>
+      <c:valAx>
+        <c:axId val="-2113994440"/>
+        <c:scaling/>
+        <c:delete val="0"/>
+        <c:axPos val="l"/>
+        <c:majorGridlines/>
+        <c:majorTickMark val="out"/>
+        <c:minorTickMark val="none"/>
+        <c:tickLblPos val="nextTo"/>
+        <c:txPr>
+          <a:bodyPr/>
+          <a:lstStyle/>
+          <a:p>
+            <a:pPr>
+              <a:defRPr sz="900"/>
+            </a:pPr>
+          </a:p>
+        </c:txPr>
+        <c:crossAx val="-2068027336"/>
+        <c:crosses val="autoZero"/>
+      </c:valAx>
+    </c:plotArea>
+    <c:legend>
+      <c:legendPos val="b"/>
+      <c:overlay val="0"/>
+      <c:txPr>
+        <a:bodyPr/>
+        <a:lstStyle/>
+        <a:p>
+          <a:pPr>
+            <a:defRPr sz="1000"/>
+          </a:pPr>
+        </a:p>
+      </c:txPr>
+    </c:legend>
+    <c:dispBlanksAs val="gap"/>
+  </c:chart>
+  <c:txPr>
+    <a:bodyPr/>
+    <a:lstStyle/>
+    <a:p>
+      <a:pPr>
+        <a:defRPr sz="1800"/>
+      </a:pPr>
+      <a:endParaRPr lang="en-US"/>
+    </a:p>
+  </c:txPr>
+  <c:externalData r:id="rId1">
+    <c:autoUpdate val="0"/>
+  </c:externalData>
+</c:chartSpace>
 </file>
 
 <file path=ppt/notesMasters/notesMaster1.xml><?xml version="1.0" encoding="utf-8"?>
@@ -1174,6 +1396,76 @@
 </p:notes>
 </file>
 
+<file path=ppt/notesSlides/notesSlide19.xml><?xml version="1.0" encoding="utf-8"?>
+<p:notes xmlns:a="http://schemas.openxmlformats.org/drawingml/2006/main" xmlns:p="http://schemas.openxmlformats.org/presentationml/2006/main" xmlns:r="http://schemas.openxmlformats.org/officeDocument/2006/relationships">
+  <p:cSld>
+    <p:spTree>
+      <p:nvGrpSpPr>
+        <p:cNvPr id="1" name=""/>
+        <p:cNvGrpSpPr/>
+        <p:nvPr/>
+      </p:nvGrpSpPr>
+      <p:grpSpPr>
+        <a:xfrm>
+          <a:off x="0" y="0"/>
+          <a:ext cx="0" cy="0"/>
+          <a:chOff x="0" y="0"/>
+          <a:chExt cx="0" cy="0"/>
+        </a:xfrm>
+      </p:grpSpPr>
+      <p:sp>
+        <p:nvSpPr>
+          <p:cNvPr id="2" name="Slide Image Placeholder 1"/>
+          <p:cNvSpPr>
+            <a:spLocks noGrp="1"/>
+          </p:cNvSpPr>
+          <p:nvPr>
+            <p:ph type="sldImg" idx="2"/>
+          </p:nvPr>
+        </p:nvSpPr>
+        <p:spPr/>
+      </p:sp>
+      <p:sp>
+        <p:nvSpPr>
+          <p:cNvPr id="3" name="Notes Placeholder 2"/>
+          <p:cNvSpPr>
+            <a:spLocks noGrp="1"/>
+          </p:cNvSpPr>
+          <p:nvPr>
+            <p:ph type="body" idx="3" sz="quarter"/>
+          </p:nvPr>
+        </p:nvSpPr>
+        <p:spPr/>
+        <p:txBody>
+          <a:bodyPr/>
+          <a:lstStyle/>
+          <a:p>
+            <a:r>
+              <a:t>The business case in one view. Costs, left: three to five engineering weeks remaining plus small additive changes in CAPEE, all with existing teams; infrastructure is one virtual machine and our standard corporate database; AI usage is pay-per-use in our own tenancy with no per-seat fees; and licence spend is zero — this was built in-house, so the code, the rate library and the knowledge base are our intellectual property. Returns, right: the autonomous agent surfaced half a million pounds a year of pricing findings in the demonstration; a commercial should-cost suite would cost six figures every year, recurring; quotes get a defensible counter-number in minutes; and negotiations start from bottom-up figures built on our own rates. And the amber bar is deliberate honesty: the savings figure is from demo data — we validate it in the pilot before it goes into any business case. That candour is what makes the rest of this slide believable.</a:t>
+            </a:r>
+          </a:p>
+        </p:txBody>
+      </p:sp>
+      <p:sp>
+        <p:nvSpPr>
+          <p:cNvPr id="4" name="Slide Number Placeholder 3"/>
+          <p:cNvSpPr>
+            <a:spLocks noGrp="1"/>
+          </p:cNvSpPr>
+          <p:nvPr>
+            <p:ph type="sldNum" idx="5" sz="quarter"/>
+          </p:nvPr>
+        </p:nvSpPr>
+        <p:spPr/>
+      </p:sp>
+    </p:spTree>
+  </p:cSld>
+  <p:clrMapOvr>
+    <a:masterClrMapping/>
+  </p:clrMapOvr>
+</p:notes>
+</file>
+
 <file path=ppt/notesSlides/notesSlide2.xml><?xml version="1.0" encoding="utf-8"?>
 <p:notes xmlns:a="http://schemas.openxmlformats.org/drawingml/2006/main" xmlns:p="http://schemas.openxmlformats.org/presentationml/2006/main" xmlns:r="http://schemas.openxmlformats.org/officeDocument/2006/relationships">
   <p:cSld>
@@ -1220,6 +1512,146 @@
           <a:p>
             <a:r>
               <a:t>One clear ask: approve the first two phases — the security assessment and the architecture design. That's five to seven weeks with existing teams and no new licence spend. Why now? Because the tool itself is finished and proven; what remains is deployment. Why is it safe? Because CAD processing already happens entirely inside the server — we verified this in the code — and the two security controls this plan called for, private AI routing and the air-gapped switch, are now built into the platform and tested live. And why does CAPEE win? Because we are not replacing CAPEE — we're giving it an AI engine and a memory.</a:t>
+            </a:r>
+          </a:p>
+        </p:txBody>
+      </p:sp>
+      <p:sp>
+        <p:nvSpPr>
+          <p:cNvPr id="4" name="Slide Number Placeholder 3"/>
+          <p:cNvSpPr>
+            <a:spLocks noGrp="1"/>
+          </p:cNvSpPr>
+          <p:nvPr>
+            <p:ph type="sldNum" idx="5" sz="quarter"/>
+          </p:nvPr>
+        </p:nvSpPr>
+        <p:spPr/>
+      </p:sp>
+    </p:spTree>
+  </p:cSld>
+  <p:clrMapOvr>
+    <a:masterClrMapping/>
+  </p:clrMapOvr>
+</p:notes>
+</file>
+
+<file path=ppt/notesSlides/notesSlide20.xml><?xml version="1.0" encoding="utf-8"?>
+<p:notes xmlns:a="http://schemas.openxmlformats.org/drawingml/2006/main" xmlns:p="http://schemas.openxmlformats.org/presentationml/2006/main" xmlns:r="http://schemas.openxmlformats.org/officeDocument/2006/relationships">
+  <p:cSld>
+    <p:spTree>
+      <p:nvGrpSpPr>
+        <p:cNvPr id="1" name=""/>
+        <p:cNvGrpSpPr/>
+        <p:nvPr/>
+      </p:nvGrpSpPr>
+      <p:grpSpPr>
+        <a:xfrm>
+          <a:off x="0" y="0"/>
+          <a:ext cx="0" cy="0"/>
+          <a:chOff x="0" y="0"/>
+          <a:chExt cx="0" cy="0"/>
+        </a:xfrm>
+      </p:grpSpPr>
+      <p:sp>
+        <p:nvSpPr>
+          <p:cNvPr id="2" name="Slide Image Placeholder 1"/>
+          <p:cNvSpPr>
+            <a:spLocks noGrp="1"/>
+          </p:cNvSpPr>
+          <p:nvPr>
+            <p:ph type="sldImg" idx="2"/>
+          </p:nvPr>
+        </p:nvSpPr>
+        <p:spPr/>
+      </p:sp>
+      <p:sp>
+        <p:nvSpPr>
+          <p:cNvPr id="3" name="Notes Placeholder 2"/>
+          <p:cNvSpPr>
+            <a:spLocks noGrp="1"/>
+          </p:cNvSpPr>
+          <p:nvPr>
+            <p:ph type="body" idx="3" sz="quarter"/>
+          </p:nvPr>
+        </p:nvSpPr>
+        <p:spPr/>
+        <p:txBody>
+          <a:bodyPr/>
+          <a:lstStyle/>
+          <a:p>
+            <a:r>
+              <a:t>The evidence slide, for when someone asks 'does it actually work?' The chart shows measured accuracy from live test runs. Grey bars are the engine before learning: machining estimates were off by about eleven percent, casting by about nine, and the honest uncertainty band was around plus-or-minus twenty percent. Green bars are after the engine learned from just three real supplier quotes per commodity: errors drop below one percent and the band tightens to under three. That is the self-learning loop working — and it is why CAPEE's PO prices matter so much, because they are exactly the fuel this loop runs on. On the right: the part-matching memory finds the right historical part ninety-nine percent of the time; seven hundred and ninety-three automated tests protect the platform on every change; and the autonomous agent found half a million pounds a year of pricing issues in the demo without anyone asking it to.</a:t>
+            </a:r>
+          </a:p>
+        </p:txBody>
+      </p:sp>
+      <p:sp>
+        <p:nvSpPr>
+          <p:cNvPr id="4" name="Slide Number Placeholder 3"/>
+          <p:cNvSpPr>
+            <a:spLocks noGrp="1"/>
+          </p:cNvSpPr>
+          <p:nvPr>
+            <p:ph type="sldNum" idx="5" sz="quarter"/>
+          </p:nvPr>
+        </p:nvSpPr>
+        <p:spPr/>
+      </p:sp>
+    </p:spTree>
+  </p:cSld>
+  <p:clrMapOvr>
+    <a:masterClrMapping/>
+  </p:clrMapOvr>
+</p:notes>
+</file>
+
+<file path=ppt/notesSlides/notesSlide21.xml><?xml version="1.0" encoding="utf-8"?>
+<p:notes xmlns:a="http://schemas.openxmlformats.org/drawingml/2006/main" xmlns:p="http://schemas.openxmlformats.org/presentationml/2006/main" xmlns:r="http://schemas.openxmlformats.org/officeDocument/2006/relationships">
+  <p:cSld>
+    <p:spTree>
+      <p:nvGrpSpPr>
+        <p:cNvPr id="1" name=""/>
+        <p:cNvGrpSpPr/>
+        <p:nvPr/>
+      </p:nvGrpSpPr>
+      <p:grpSpPr>
+        <a:xfrm>
+          <a:off x="0" y="0"/>
+          <a:ext cx="0" cy="0"/>
+          <a:chOff x="0" y="0"/>
+          <a:chExt cx="0" cy="0"/>
+        </a:xfrm>
+      </p:grpSpPr>
+      <p:sp>
+        <p:nvSpPr>
+          <p:cNvPr id="2" name="Slide Image Placeholder 1"/>
+          <p:cNvSpPr>
+            <a:spLocks noGrp="1"/>
+          </p:cNvSpPr>
+          <p:nvPr>
+            <p:ph type="sldImg" idx="2"/>
+          </p:nvPr>
+        </p:nvSpPr>
+        <p:spPr/>
+      </p:sp>
+      <p:sp>
+        <p:nvSpPr>
+          <p:cNvPr id="3" name="Notes Placeholder 2"/>
+          <p:cNvSpPr>
+            <a:spLocks noGrp="1"/>
+          </p:cNvSpPr>
+          <p:nvPr>
+            <p:ph type="body" idx="3" sz="quarter"/>
+          </p:nvPr>
+        </p:nvSpPr>
+        <p:spPr/>
+        <p:txBody>
+          <a:bodyPr/>
+          <a:lstStyle/>
+          <a:p>
+            <a:r>
+              <a:t>Backup for the question-and-answer session — the five questions most likely to come up, with straight answers. Why not buy aPriori? Because a vendor SaaS puts our CAD and our rates in their cloud, can't learn from our quote history, and bills six figures a year forever — while CostVision is on-premise, self-learning and our own intellectual property. Is our data training a public AI? No — zero retention in our own tenancy, and the air-gapped switch makes 'no external calls' provable rather than promised. Key-person risk? Seven hundred ninety-three automated tests, written architecture docs, and a trained second maintainer from Phase 4. Running cost? A virtual machine, a standard database, pay-per-use AI — no licences. And how do we trust the numbers? Physics build-ups on our own rates, calibrated against our own purchase orders, with the error tracked openly on the accuracy dashboard.</a:t>
             </a:r>
           </a:p>
         </p:txBody>
@@ -9968,6 +10400,57 @@
           </a:p>
         </p:txBody>
       </p:sp>
+      <p:sp>
+        <p:nvSpPr>
+          <p:cNvPr id="27" name="TextBox 26"/>
+          <p:cNvSpPr txBox="1"/>
+          <p:nvPr/>
+        </p:nvSpPr>
+        <p:spPr>
+          <a:xfrm>
+            <a:off x="411480" y="6236208"/>
+            <a:ext cx="11338560" cy="457200"/>
+          </a:xfrm>
+          <a:prstGeom prst="rect">
+            <a:avLst/>
+          </a:prstGeom>
+          <a:noFill/>
+        </p:spPr>
+        <p:txBody>
+          <a:bodyPr wrap="square" anchor="t" lIns="0" rIns="0" tIns="0" bIns="0">
+            <a:spAutoFit/>
+          </a:bodyPr>
+          <a:lstStyle/>
+          <a:p>
+            <a:pPr algn="l">
+              <a:lnSpc>
+                <a:spcPct val="100000"/>
+              </a:lnSpc>
+              <a:spcAft>
+                <a:spcPts val="400"/>
+              </a:spcAft>
+            </a:pPr>
+            <a:r>
+              <a:rPr sz="1150" b="1" i="0">
+                <a:solidFill>
+                  <a:srgbClr val="0F172A"/>
+                </a:solidFill>
+                <a:latin typeface="Calibri"/>
+              </a:rPr>
+              <a:t>After go-live we track: </a:t>
+            </a:r>
+            <a:r>
+              <a:rPr sz="1150" b="0" i="0">
+                <a:solidFill>
+                  <a:srgbClr val="334155"/>
+                </a:solidFill>
+                <a:latin typeface="Calibri"/>
+              </a:rPr>
+              <a:t>accuracy vs PO prices · costings via CAPEE · £ findings actioned · adoption.   Approval today → pilot value by ~September 2026.</a:t>
+            </a:r>
+          </a:p>
+        </p:txBody>
+      </p:sp>
     </p:spTree>
   </p:cSld>
   <p:clrMapOvr>
@@ -15831,6 +16314,1016 @@
 </p:sld>
 </file>
 
+<file path=ppt/slides/slide19.xml><?xml version="1.0" encoding="utf-8"?>
+<p:sld xmlns:a="http://schemas.openxmlformats.org/drawingml/2006/main" xmlns:p="http://schemas.openxmlformats.org/presentationml/2006/main" xmlns:r="http://schemas.openxmlformats.org/officeDocument/2006/relationships">
+  <p:cSld>
+    <p:spTree>
+      <p:nvGrpSpPr>
+        <p:cNvPr id="1" name=""/>
+        <p:cNvGrpSpPr/>
+        <p:nvPr/>
+      </p:nvGrpSpPr>
+      <p:grpSpPr/>
+      <p:sp>
+        <p:nvSpPr>
+          <p:cNvPr id="2" name="Rectangle 1"/>
+          <p:cNvSpPr/>
+          <p:nvPr/>
+        </p:nvSpPr>
+        <p:spPr>
+          <a:xfrm>
+            <a:off x="0" y="0"/>
+            <a:ext cx="12191695" cy="6858000"/>
+          </a:xfrm>
+          <a:prstGeom prst="rect">
+            <a:avLst/>
+          </a:prstGeom>
+          <a:solidFill>
+            <a:srgbClr val="FFFFFF"/>
+          </a:solidFill>
+          <a:ln>
+            <a:noFill/>
+          </a:ln>
+          <a:effectLst/>
+        </p:spPr>
+        <p:style>
+          <a:lnRef idx="1">
+            <a:schemeClr val="accent1"/>
+          </a:lnRef>
+          <a:fillRef idx="3">
+            <a:schemeClr val="accent1"/>
+          </a:fillRef>
+          <a:effectRef idx="2">
+            <a:schemeClr val="accent1"/>
+          </a:effectRef>
+          <a:fontRef idx="minor">
+            <a:schemeClr val="lt1"/>
+          </a:fontRef>
+        </p:style>
+        <p:txBody>
+          <a:bodyPr rtlCol="0" anchor="ctr"/>
+          <a:lstStyle/>
+          <a:p>
+            <a:pPr algn="ctr"/>
+          </a:p>
+        </p:txBody>
+      </p:sp>
+      <p:sp>
+        <p:nvSpPr>
+          <p:cNvPr id="3" name="Rounded Rectangle 2"/>
+          <p:cNvSpPr/>
+          <p:nvPr/>
+        </p:nvSpPr>
+        <p:spPr>
+          <a:xfrm>
+            <a:off x="320040" y="201168"/>
+            <a:ext cx="384048" cy="384048"/>
+          </a:xfrm>
+          <a:prstGeom prst="roundRect">
+            <a:avLst>
+              <a:gd name="adj" fmla="val 28000"/>
+            </a:avLst>
+          </a:prstGeom>
+          <a:solidFill>
+            <a:srgbClr val="4F46E5"/>
+          </a:solidFill>
+          <a:ln>
+            <a:noFill/>
+          </a:ln>
+          <a:effectLst/>
+        </p:spPr>
+        <p:style>
+          <a:lnRef idx="1">
+            <a:schemeClr val="accent1"/>
+          </a:lnRef>
+          <a:fillRef idx="3">
+            <a:schemeClr val="accent1"/>
+          </a:fillRef>
+          <a:effectRef idx="2">
+            <a:schemeClr val="accent1"/>
+          </a:effectRef>
+          <a:fontRef idx="minor">
+            <a:schemeClr val="lt1"/>
+          </a:fontRef>
+        </p:style>
+        <p:txBody>
+          <a:bodyPr rtlCol="0" anchor="ctr" lIns="0" rIns="0" tIns="0" bIns="0"/>
+          <a:lstStyle/>
+          <a:p>
+            <a:pPr algn="ctr"/>
+            <a:r>
+              <a:rPr sz="1700" b="1">
+                <a:solidFill>
+                  <a:srgbClr val="FFFFFF"/>
+                </a:solidFill>
+                <a:latin typeface="Calibri"/>
+              </a:rPr>
+              <a:t>cv</a:t>
+            </a:r>
+          </a:p>
+        </p:txBody>
+      </p:sp>
+      <p:sp>
+        <p:nvSpPr>
+          <p:cNvPr id="4" name="TextBox 3"/>
+          <p:cNvSpPr txBox="1"/>
+          <p:nvPr/>
+        </p:nvSpPr>
+        <p:spPr>
+          <a:xfrm>
+            <a:off x="795528" y="173736"/>
+            <a:ext cx="2377440" cy="292608"/>
+          </a:xfrm>
+          <a:prstGeom prst="rect">
+            <a:avLst/>
+          </a:prstGeom>
+          <a:noFill/>
+        </p:spPr>
+        <p:txBody>
+          <a:bodyPr wrap="square" anchor="t" lIns="0" rIns="0" tIns="0" bIns="0">
+            <a:spAutoFit/>
+          </a:bodyPr>
+          <a:lstStyle/>
+          <a:p>
+            <a:pPr algn="l">
+              <a:lnSpc>
+                <a:spcPct val="100000"/>
+              </a:lnSpc>
+              <a:spcAft>
+                <a:spcPts val="400"/>
+              </a:spcAft>
+            </a:pPr>
+            <a:r>
+              <a:rPr sz="1800" b="1" i="0">
+                <a:solidFill>
+                  <a:srgbClr val="2563EB"/>
+                </a:solidFill>
+                <a:latin typeface="Calibri"/>
+              </a:rPr>
+              <a:t>CostVision</a:t>
+            </a:r>
+          </a:p>
+        </p:txBody>
+      </p:sp>
+      <p:sp>
+        <p:nvSpPr>
+          <p:cNvPr id="5" name="TextBox 4"/>
+          <p:cNvSpPr txBox="1"/>
+          <p:nvPr/>
+        </p:nvSpPr>
+        <p:spPr>
+          <a:xfrm>
+            <a:off x="795528" y="420624"/>
+            <a:ext cx="2560320" cy="201168"/>
+          </a:xfrm>
+          <a:prstGeom prst="rect">
+            <a:avLst/>
+          </a:prstGeom>
+          <a:noFill/>
+        </p:spPr>
+        <p:txBody>
+          <a:bodyPr wrap="square" anchor="t" lIns="0" rIns="0" tIns="0" bIns="0">
+            <a:spAutoFit/>
+          </a:bodyPr>
+          <a:lstStyle/>
+          <a:p>
+            <a:pPr algn="l">
+              <a:lnSpc>
+                <a:spcPct val="100000"/>
+              </a:lnSpc>
+              <a:spcAft>
+                <a:spcPts val="400"/>
+              </a:spcAft>
+            </a:pPr>
+            <a:r>
+              <a:rPr sz="750" b="0" i="0">
+                <a:solidFill>
+                  <a:srgbClr val="64748B"/>
+                </a:solidFill>
+                <a:latin typeface="Calibri"/>
+              </a:rPr>
+              <a:t>AI  COST  INTELLIGENCE</a:t>
+            </a:r>
+          </a:p>
+        </p:txBody>
+      </p:sp>
+      <p:sp>
+        <p:nvSpPr>
+          <p:cNvPr id="6" name="Rectangle 5"/>
+          <p:cNvSpPr/>
+          <p:nvPr/>
+        </p:nvSpPr>
+        <p:spPr>
+          <a:xfrm>
+            <a:off x="0" y="713232"/>
+            <a:ext cx="12191695" cy="27940"/>
+          </a:xfrm>
+          <a:prstGeom prst="rect">
+            <a:avLst/>
+          </a:prstGeom>
+          <a:solidFill>
+            <a:srgbClr val="4F46E5"/>
+          </a:solidFill>
+          <a:ln>
+            <a:noFill/>
+          </a:ln>
+          <a:effectLst/>
+        </p:spPr>
+        <p:style>
+          <a:lnRef idx="1">
+            <a:schemeClr val="accent1"/>
+          </a:lnRef>
+          <a:fillRef idx="3">
+            <a:schemeClr val="accent1"/>
+          </a:fillRef>
+          <a:effectRef idx="2">
+            <a:schemeClr val="accent1"/>
+          </a:effectRef>
+          <a:fontRef idx="minor">
+            <a:schemeClr val="lt1"/>
+          </a:fontRef>
+        </p:style>
+        <p:txBody>
+          <a:bodyPr rtlCol="0" anchor="ctr"/>
+          <a:lstStyle/>
+          <a:p>
+            <a:pPr algn="ctr"/>
+          </a:p>
+        </p:txBody>
+      </p:sp>
+      <p:sp>
+        <p:nvSpPr>
+          <p:cNvPr id="7" name="TextBox 6"/>
+          <p:cNvSpPr txBox="1"/>
+          <p:nvPr/>
+        </p:nvSpPr>
+        <p:spPr>
+          <a:xfrm>
+            <a:off x="411480" y="868680"/>
+            <a:ext cx="10515600" cy="274320"/>
+          </a:xfrm>
+          <a:prstGeom prst="rect">
+            <a:avLst/>
+          </a:prstGeom>
+          <a:noFill/>
+        </p:spPr>
+        <p:txBody>
+          <a:bodyPr wrap="square" anchor="t" lIns="0" rIns="0" tIns="0" bIns="0">
+            <a:spAutoFit/>
+          </a:bodyPr>
+          <a:lstStyle/>
+          <a:p>
+            <a:pPr algn="l">
+              <a:lnSpc>
+                <a:spcPct val="100000"/>
+              </a:lnSpc>
+              <a:spcAft>
+                <a:spcPts val="400"/>
+              </a:spcAft>
+            </a:pPr>
+            <a:r>
+              <a:rPr sz="1100" b="1" i="0">
+                <a:solidFill>
+                  <a:srgbClr val="2563EB"/>
+                </a:solidFill>
+                <a:latin typeface="Calibri"/>
+              </a:rPr>
+              <a:t>BACKUP · BUSINESS CASE</a:t>
+            </a:r>
+          </a:p>
+        </p:txBody>
+      </p:sp>
+      <p:sp>
+        <p:nvSpPr>
+          <p:cNvPr id="8" name="TextBox 7"/>
+          <p:cNvSpPr txBox="1"/>
+          <p:nvPr/>
+        </p:nvSpPr>
+        <p:spPr>
+          <a:xfrm>
+            <a:off x="411480" y="1115568"/>
+            <a:ext cx="11338560" cy="548640"/>
+          </a:xfrm>
+          <a:prstGeom prst="rect">
+            <a:avLst/>
+          </a:prstGeom>
+          <a:noFill/>
+        </p:spPr>
+        <p:txBody>
+          <a:bodyPr wrap="square" anchor="t" lIns="0" rIns="0" tIns="0" bIns="0">
+            <a:spAutoFit/>
+          </a:bodyPr>
+          <a:lstStyle/>
+          <a:p>
+            <a:pPr algn="l">
+              <a:lnSpc>
+                <a:spcPct val="100000"/>
+              </a:lnSpc>
+              <a:spcAft>
+                <a:spcPts val="400"/>
+              </a:spcAft>
+            </a:pPr>
+            <a:r>
+              <a:rPr sz="2700" b="1" i="0">
+                <a:solidFill>
+                  <a:srgbClr val="0F172A"/>
+                </a:solidFill>
+                <a:latin typeface="Calibri"/>
+              </a:rPr>
+              <a:t>What it costs vs what it returns</a:t>
+            </a:r>
+          </a:p>
+        </p:txBody>
+      </p:sp>
+      <p:sp>
+        <p:nvSpPr>
+          <p:cNvPr id="9" name="Rounded Rectangle 8"/>
+          <p:cNvSpPr/>
+          <p:nvPr/>
+        </p:nvSpPr>
+        <p:spPr>
+          <a:xfrm>
+            <a:off x="411480" y="1828800"/>
+            <a:ext cx="5486400" cy="3520440"/>
+          </a:xfrm>
+          <a:prstGeom prst="roundRect">
+            <a:avLst>
+              <a:gd name="adj" fmla="val 5000"/>
+            </a:avLst>
+          </a:prstGeom>
+          <a:solidFill>
+            <a:srgbClr val="F1F5F9"/>
+          </a:solidFill>
+          <a:ln>
+            <a:noFill/>
+          </a:ln>
+          <a:effectLst/>
+        </p:spPr>
+        <p:style>
+          <a:lnRef idx="1">
+            <a:schemeClr val="accent1"/>
+          </a:lnRef>
+          <a:fillRef idx="3">
+            <a:schemeClr val="accent1"/>
+          </a:fillRef>
+          <a:effectRef idx="2">
+            <a:schemeClr val="accent1"/>
+          </a:effectRef>
+          <a:fontRef idx="minor">
+            <a:schemeClr val="lt1"/>
+          </a:fontRef>
+        </p:style>
+        <p:txBody>
+          <a:bodyPr rtlCol="0" anchor="ctr"/>
+          <a:lstStyle/>
+          <a:p>
+            <a:pPr algn="ctr"/>
+          </a:p>
+        </p:txBody>
+      </p:sp>
+      <p:sp>
+        <p:nvSpPr>
+          <p:cNvPr id="10" name="TextBox 9"/>
+          <p:cNvSpPr txBox="1"/>
+          <p:nvPr/>
+        </p:nvSpPr>
+        <p:spPr>
+          <a:xfrm>
+            <a:off x="685800" y="2011680"/>
+            <a:ext cx="4937760" cy="365760"/>
+          </a:xfrm>
+          <a:prstGeom prst="rect">
+            <a:avLst/>
+          </a:prstGeom>
+          <a:noFill/>
+        </p:spPr>
+        <p:txBody>
+          <a:bodyPr wrap="square" anchor="t" lIns="0" rIns="0" tIns="0" bIns="0">
+            <a:spAutoFit/>
+          </a:bodyPr>
+          <a:lstStyle/>
+          <a:p>
+            <a:pPr algn="l">
+              <a:lnSpc>
+                <a:spcPct val="100000"/>
+              </a:lnSpc>
+              <a:spcAft>
+                <a:spcPts val="400"/>
+              </a:spcAft>
+            </a:pPr>
+            <a:r>
+              <a:rPr sz="1500" b="1" i="0">
+                <a:solidFill>
+                  <a:srgbClr val="0F172A"/>
+                </a:solidFill>
+                <a:latin typeface="Calibri"/>
+              </a:rPr>
+              <a:t>What it costs</a:t>
+            </a:r>
+          </a:p>
+        </p:txBody>
+      </p:sp>
+      <p:sp>
+        <p:nvSpPr>
+          <p:cNvPr id="11" name="TextBox 10"/>
+          <p:cNvSpPr txBox="1"/>
+          <p:nvPr/>
+        </p:nvSpPr>
+        <p:spPr>
+          <a:xfrm>
+            <a:off x="685800" y="2487168"/>
+            <a:ext cx="5029200" cy="685800"/>
+          </a:xfrm>
+          <a:prstGeom prst="rect">
+            <a:avLst/>
+          </a:prstGeom>
+          <a:noFill/>
+        </p:spPr>
+        <p:txBody>
+          <a:bodyPr wrap="square" anchor="t" lIns="0" rIns="0" tIns="0" bIns="0">
+            <a:spAutoFit/>
+          </a:bodyPr>
+          <a:lstStyle/>
+          <a:p>
+            <a:pPr algn="l">
+              <a:lnSpc>
+                <a:spcPct val="110000"/>
+              </a:lnSpc>
+              <a:spcAft>
+                <a:spcPts val="400"/>
+              </a:spcAft>
+            </a:pPr>
+            <a:r>
+              <a:rPr sz="1200" b="1" i="0">
+                <a:solidFill>
+                  <a:srgbClr val="0F172A"/>
+                </a:solidFill>
+                <a:latin typeface="Calibri"/>
+              </a:rPr>
+              <a:t>Engineering — </a:t>
+            </a:r>
+            <a:r>
+              <a:rPr sz="1100" b="0" i="0">
+                <a:solidFill>
+                  <a:srgbClr val="334155"/>
+                </a:solidFill>
+                <a:latin typeface="Calibri"/>
+              </a:rPr>
+              <a:t>~3–5 weeks remaining on CostVision + small additive CAPEE changes — existing teams</a:t>
+            </a:r>
+          </a:p>
+        </p:txBody>
+      </p:sp>
+      <p:sp>
+        <p:nvSpPr>
+          <p:cNvPr id="12" name="TextBox 11"/>
+          <p:cNvSpPr txBox="1"/>
+          <p:nvPr/>
+        </p:nvSpPr>
+        <p:spPr>
+          <a:xfrm>
+            <a:off x="685800" y="3200400"/>
+            <a:ext cx="5029200" cy="685800"/>
+          </a:xfrm>
+          <a:prstGeom prst="rect">
+            <a:avLst/>
+          </a:prstGeom>
+          <a:noFill/>
+        </p:spPr>
+        <p:txBody>
+          <a:bodyPr wrap="square" anchor="t" lIns="0" rIns="0" tIns="0" bIns="0">
+            <a:spAutoFit/>
+          </a:bodyPr>
+          <a:lstStyle/>
+          <a:p>
+            <a:pPr algn="l">
+              <a:lnSpc>
+                <a:spcPct val="110000"/>
+              </a:lnSpc>
+              <a:spcAft>
+                <a:spcPts val="400"/>
+              </a:spcAft>
+            </a:pPr>
+            <a:r>
+              <a:rPr sz="1200" b="1" i="0">
+                <a:solidFill>
+                  <a:srgbClr val="0F172A"/>
+                </a:solidFill>
+                <a:latin typeface="Calibri"/>
+              </a:rPr>
+              <a:t>Infrastructure — </a:t>
+            </a:r>
+            <a:r>
+              <a:rPr sz="1100" b="0" i="0">
+                <a:solidFill>
+                  <a:srgbClr val="334155"/>
+                </a:solidFill>
+                <a:latin typeface="Calibri"/>
+              </a:rPr>
+              <a:t>one VM + corporate PostgreSQL — standard IT estate our teams already run</a:t>
+            </a:r>
+          </a:p>
+        </p:txBody>
+      </p:sp>
+      <p:sp>
+        <p:nvSpPr>
+          <p:cNvPr id="13" name="TextBox 12"/>
+          <p:cNvSpPr txBox="1"/>
+          <p:nvPr/>
+        </p:nvSpPr>
+        <p:spPr>
+          <a:xfrm>
+            <a:off x="685800" y="3913632"/>
+            <a:ext cx="5029200" cy="685800"/>
+          </a:xfrm>
+          <a:prstGeom prst="rect">
+            <a:avLst/>
+          </a:prstGeom>
+          <a:noFill/>
+        </p:spPr>
+        <p:txBody>
+          <a:bodyPr wrap="square" anchor="t" lIns="0" rIns="0" tIns="0" bIns="0">
+            <a:spAutoFit/>
+          </a:bodyPr>
+          <a:lstStyle/>
+          <a:p>
+            <a:pPr algn="l">
+              <a:lnSpc>
+                <a:spcPct val="110000"/>
+              </a:lnSpc>
+              <a:spcAft>
+                <a:spcPts val="400"/>
+              </a:spcAft>
+            </a:pPr>
+            <a:r>
+              <a:rPr sz="1200" b="1" i="0">
+                <a:solidFill>
+                  <a:srgbClr val="0F172A"/>
+                </a:solidFill>
+                <a:latin typeface="Calibri"/>
+              </a:rPr>
+              <a:t>AI usage — </a:t>
+            </a:r>
+            <a:r>
+              <a:rPr sz="1100" b="0" i="0">
+                <a:solidFill>
+                  <a:srgbClr val="334155"/>
+                </a:solidFill>
+                <a:latin typeface="Calibri"/>
+              </a:rPr>
+              <a:t>pay-per-use in our own cloud tenancy — no per-seat fees, off in air-gap mode</a:t>
+            </a:r>
+          </a:p>
+        </p:txBody>
+      </p:sp>
+      <p:sp>
+        <p:nvSpPr>
+          <p:cNvPr id="14" name="TextBox 13"/>
+          <p:cNvSpPr txBox="1"/>
+          <p:nvPr/>
+        </p:nvSpPr>
+        <p:spPr>
+          <a:xfrm>
+            <a:off x="685800" y="4626864"/>
+            <a:ext cx="5029200" cy="685800"/>
+          </a:xfrm>
+          <a:prstGeom prst="rect">
+            <a:avLst/>
+          </a:prstGeom>
+          <a:noFill/>
+        </p:spPr>
+        <p:txBody>
+          <a:bodyPr wrap="square" anchor="t" lIns="0" rIns="0" tIns="0" bIns="0">
+            <a:spAutoFit/>
+          </a:bodyPr>
+          <a:lstStyle/>
+          <a:p>
+            <a:pPr algn="l">
+              <a:lnSpc>
+                <a:spcPct val="110000"/>
+              </a:lnSpc>
+              <a:spcAft>
+                <a:spcPts val="400"/>
+              </a:spcAft>
+            </a:pPr>
+            <a:r>
+              <a:rPr sz="1200" b="1" i="0">
+                <a:solidFill>
+                  <a:srgbClr val="0F172A"/>
+                </a:solidFill>
+                <a:latin typeface="Calibri"/>
+              </a:rPr>
+              <a:t>Licence spend — </a:t>
+            </a:r>
+            <a:r>
+              <a:rPr sz="1100" b="0" i="0">
+                <a:solidFill>
+                  <a:srgbClr val="334155"/>
+                </a:solidFill>
+                <a:latin typeface="Calibri"/>
+              </a:rPr>
+              <a:t>£0 — built in-house. The code, rate library and knowledge base are OUR IP</a:t>
+            </a:r>
+          </a:p>
+        </p:txBody>
+      </p:sp>
+      <p:sp>
+        <p:nvSpPr>
+          <p:cNvPr id="15" name="Rounded Rectangle 14"/>
+          <p:cNvSpPr/>
+          <p:nvPr/>
+        </p:nvSpPr>
+        <p:spPr>
+          <a:xfrm>
+            <a:off x="6263640" y="1828800"/>
+            <a:ext cx="5532120" cy="3520440"/>
+          </a:xfrm>
+          <a:prstGeom prst="roundRect">
+            <a:avLst>
+              <a:gd name="adj" fmla="val 5000"/>
+            </a:avLst>
+          </a:prstGeom>
+          <a:solidFill>
+            <a:srgbClr val="ECFDF5"/>
+          </a:solidFill>
+          <a:ln>
+            <a:noFill/>
+          </a:ln>
+          <a:effectLst/>
+        </p:spPr>
+        <p:style>
+          <a:lnRef idx="1">
+            <a:schemeClr val="accent1"/>
+          </a:lnRef>
+          <a:fillRef idx="3">
+            <a:schemeClr val="accent1"/>
+          </a:fillRef>
+          <a:effectRef idx="2">
+            <a:schemeClr val="accent1"/>
+          </a:effectRef>
+          <a:fontRef idx="minor">
+            <a:schemeClr val="lt1"/>
+          </a:fontRef>
+        </p:style>
+        <p:txBody>
+          <a:bodyPr rtlCol="0" anchor="ctr"/>
+          <a:lstStyle/>
+          <a:p>
+            <a:pPr algn="ctr"/>
+          </a:p>
+        </p:txBody>
+      </p:sp>
+      <p:sp>
+        <p:nvSpPr>
+          <p:cNvPr id="16" name="TextBox 15"/>
+          <p:cNvSpPr txBox="1"/>
+          <p:nvPr/>
+        </p:nvSpPr>
+        <p:spPr>
+          <a:xfrm>
+            <a:off x="6537960" y="2011680"/>
+            <a:ext cx="4937760" cy="365760"/>
+          </a:xfrm>
+          <a:prstGeom prst="rect">
+            <a:avLst/>
+          </a:prstGeom>
+          <a:noFill/>
+        </p:spPr>
+        <p:txBody>
+          <a:bodyPr wrap="square" anchor="t" lIns="0" rIns="0" tIns="0" bIns="0">
+            <a:spAutoFit/>
+          </a:bodyPr>
+          <a:lstStyle/>
+          <a:p>
+            <a:pPr algn="l">
+              <a:lnSpc>
+                <a:spcPct val="100000"/>
+              </a:lnSpc>
+              <a:spcAft>
+                <a:spcPts val="400"/>
+              </a:spcAft>
+            </a:pPr>
+            <a:r>
+              <a:rPr sz="1500" b="1" i="0">
+                <a:solidFill>
+                  <a:srgbClr val="059669"/>
+                </a:solidFill>
+                <a:latin typeface="Calibri"/>
+              </a:rPr>
+              <a:t>What it returns</a:t>
+            </a:r>
+          </a:p>
+        </p:txBody>
+      </p:sp>
+      <p:sp>
+        <p:nvSpPr>
+          <p:cNvPr id="17" name="TextBox 16"/>
+          <p:cNvSpPr txBox="1"/>
+          <p:nvPr/>
+        </p:nvSpPr>
+        <p:spPr>
+          <a:xfrm>
+            <a:off x="6537960" y="2487168"/>
+            <a:ext cx="5029200" cy="685800"/>
+          </a:xfrm>
+          <a:prstGeom prst="rect">
+            <a:avLst/>
+          </a:prstGeom>
+          <a:noFill/>
+        </p:spPr>
+        <p:txBody>
+          <a:bodyPr wrap="square" anchor="t" lIns="0" rIns="0" tIns="0" bIns="0">
+            <a:spAutoFit/>
+          </a:bodyPr>
+          <a:lstStyle/>
+          <a:p>
+            <a:pPr algn="l">
+              <a:lnSpc>
+                <a:spcPct val="110000"/>
+              </a:lnSpc>
+              <a:spcAft>
+                <a:spcPts val="400"/>
+              </a:spcAft>
+            </a:pPr>
+            <a:r>
+              <a:rPr sz="1200" b="1" i="0">
+                <a:solidFill>
+                  <a:srgbClr val="059669"/>
+                </a:solidFill>
+                <a:latin typeface="Calibri"/>
+              </a:rPr>
+              <a:t>Savings found — </a:t>
+            </a:r>
+            <a:r>
+              <a:rPr sz="1100" b="0" i="0">
+                <a:solidFill>
+                  <a:srgbClr val="334155"/>
+                </a:solidFill>
+                <a:latin typeface="Calibri"/>
+              </a:rPr>
+              <a:t>£512k/yr of pricing issues surfaced autonomously in the live demo (indicative)</a:t>
+            </a:r>
+          </a:p>
+        </p:txBody>
+      </p:sp>
+      <p:sp>
+        <p:nvSpPr>
+          <p:cNvPr id="18" name="TextBox 17"/>
+          <p:cNvSpPr txBox="1"/>
+          <p:nvPr/>
+        </p:nvSpPr>
+        <p:spPr>
+          <a:xfrm>
+            <a:off x="6537960" y="3200400"/>
+            <a:ext cx="5029200" cy="685800"/>
+          </a:xfrm>
+          <a:prstGeom prst="rect">
+            <a:avLst/>
+          </a:prstGeom>
+          <a:noFill/>
+        </p:spPr>
+        <p:txBody>
+          <a:bodyPr wrap="square" anchor="t" lIns="0" rIns="0" tIns="0" bIns="0">
+            <a:spAutoFit/>
+          </a:bodyPr>
+          <a:lstStyle/>
+          <a:p>
+            <a:pPr algn="l">
+              <a:lnSpc>
+                <a:spcPct val="110000"/>
+              </a:lnSpc>
+              <a:spcAft>
+                <a:spcPts val="400"/>
+              </a:spcAft>
+            </a:pPr>
+            <a:r>
+              <a:rPr sz="1200" b="1" i="0">
+                <a:solidFill>
+                  <a:srgbClr val="059669"/>
+                </a:solidFill>
+                <a:latin typeface="Calibri"/>
+              </a:rPr>
+              <a:t>Licence avoided — </a:t>
+            </a:r>
+            <a:r>
+              <a:rPr sz="1100" b="0" i="0">
+                <a:solidFill>
+                  <a:srgbClr val="334155"/>
+                </a:solidFill>
+                <a:latin typeface="Calibri"/>
+              </a:rPr>
+              <a:t>commercial should-cost suites run six figures per year, recurring</a:t>
+            </a:r>
+          </a:p>
+        </p:txBody>
+      </p:sp>
+      <p:sp>
+        <p:nvSpPr>
+          <p:cNvPr id="19" name="TextBox 18"/>
+          <p:cNvSpPr txBox="1"/>
+          <p:nvPr/>
+        </p:nvSpPr>
+        <p:spPr>
+          <a:xfrm>
+            <a:off x="6537960" y="3913632"/>
+            <a:ext cx="5029200" cy="685800"/>
+          </a:xfrm>
+          <a:prstGeom prst="rect">
+            <a:avLst/>
+          </a:prstGeom>
+          <a:noFill/>
+        </p:spPr>
+        <p:txBody>
+          <a:bodyPr wrap="square" anchor="t" lIns="0" rIns="0" tIns="0" bIns="0">
+            <a:spAutoFit/>
+          </a:bodyPr>
+          <a:lstStyle/>
+          <a:p>
+            <a:pPr algn="l">
+              <a:lnSpc>
+                <a:spcPct val="110000"/>
+              </a:lnSpc>
+              <a:spcAft>
+                <a:spcPts val="400"/>
+              </a:spcAft>
+            </a:pPr>
+            <a:r>
+              <a:rPr sz="1200" b="1" i="0">
+                <a:solidFill>
+                  <a:srgbClr val="059669"/>
+                </a:solidFill>
+                <a:latin typeface="Calibri"/>
+              </a:rPr>
+              <a:t>Speed — </a:t>
+            </a:r>
+            <a:r>
+              <a:rPr sz="1100" b="0" i="0">
+                <a:solidFill>
+                  <a:srgbClr val="334155"/>
+                </a:solidFill>
+                <a:latin typeface="Calibri"/>
+              </a:rPr>
+              <a:t>first defensible should-cost in minutes, not days — every quote challengeable</a:t>
+            </a:r>
+          </a:p>
+        </p:txBody>
+      </p:sp>
+      <p:sp>
+        <p:nvSpPr>
+          <p:cNvPr id="20" name="TextBox 19"/>
+          <p:cNvSpPr txBox="1"/>
+          <p:nvPr/>
+        </p:nvSpPr>
+        <p:spPr>
+          <a:xfrm>
+            <a:off x="6537960" y="4626864"/>
+            <a:ext cx="5029200" cy="685800"/>
+          </a:xfrm>
+          <a:prstGeom prst="rect">
+            <a:avLst/>
+          </a:prstGeom>
+          <a:noFill/>
+        </p:spPr>
+        <p:txBody>
+          <a:bodyPr wrap="square" anchor="t" lIns="0" rIns="0" tIns="0" bIns="0">
+            <a:spAutoFit/>
+          </a:bodyPr>
+          <a:lstStyle/>
+          <a:p>
+            <a:pPr algn="l">
+              <a:lnSpc>
+                <a:spcPct val="110000"/>
+              </a:lnSpc>
+              <a:spcAft>
+                <a:spcPts val="400"/>
+              </a:spcAft>
+            </a:pPr>
+            <a:r>
+              <a:rPr sz="1200" b="1" i="0">
+                <a:solidFill>
+                  <a:srgbClr val="059669"/>
+                </a:solidFill>
+                <a:latin typeface="Calibri"/>
+              </a:rPr>
+              <a:t>Leverage — </a:t>
+            </a:r>
+            <a:r>
+              <a:rPr sz="1100" b="0" i="0">
+                <a:solidFill>
+                  <a:srgbClr val="334155"/>
+                </a:solidFill>
+                <a:latin typeface="Calibri"/>
+              </a:rPr>
+              <a:t>bottom-up numbers on OUR rates that suppliers cannot wave away</a:t>
+            </a:r>
+          </a:p>
+        </p:txBody>
+      </p:sp>
+      <p:sp>
+        <p:nvSpPr>
+          <p:cNvPr id="21" name="Rounded Rectangle 20"/>
+          <p:cNvSpPr/>
+          <p:nvPr/>
+        </p:nvSpPr>
+        <p:spPr>
+          <a:xfrm>
+            <a:off x="411480" y="5577840"/>
+            <a:ext cx="11384280" cy="868680"/>
+          </a:xfrm>
+          <a:prstGeom prst="roundRect">
+            <a:avLst>
+              <a:gd name="adj" fmla="val 8000"/>
+            </a:avLst>
+          </a:prstGeom>
+          <a:solidFill>
+            <a:srgbClr val="FFFBEB"/>
+          </a:solidFill>
+          <a:ln>
+            <a:noFill/>
+          </a:ln>
+          <a:effectLst/>
+        </p:spPr>
+        <p:style>
+          <a:lnRef idx="1">
+            <a:schemeClr val="accent1"/>
+          </a:lnRef>
+          <a:fillRef idx="3">
+            <a:schemeClr val="accent1"/>
+          </a:fillRef>
+          <a:effectRef idx="2">
+            <a:schemeClr val="accent1"/>
+          </a:effectRef>
+          <a:fontRef idx="minor">
+            <a:schemeClr val="lt1"/>
+          </a:fontRef>
+        </p:style>
+        <p:txBody>
+          <a:bodyPr rtlCol="0" anchor="ctr"/>
+          <a:lstStyle/>
+          <a:p>
+            <a:pPr algn="ctr"/>
+          </a:p>
+        </p:txBody>
+      </p:sp>
+      <p:sp>
+        <p:nvSpPr>
+          <p:cNvPr id="22" name="TextBox 21"/>
+          <p:cNvSpPr txBox="1"/>
+          <p:nvPr/>
+        </p:nvSpPr>
+        <p:spPr>
+          <a:xfrm>
+            <a:off x="685800" y="5705856"/>
+            <a:ext cx="10881360" cy="640080"/>
+          </a:xfrm>
+          <a:prstGeom prst="rect">
+            <a:avLst/>
+          </a:prstGeom>
+          <a:noFill/>
+        </p:spPr>
+        <p:txBody>
+          <a:bodyPr wrap="square" anchor="t" lIns="0" rIns="0" tIns="0" bIns="0">
+            <a:spAutoFit/>
+          </a:bodyPr>
+          <a:lstStyle/>
+          <a:p>
+            <a:pPr algn="l">
+              <a:lnSpc>
+                <a:spcPct val="115000"/>
+              </a:lnSpc>
+              <a:spcAft>
+                <a:spcPts val="400"/>
+              </a:spcAft>
+            </a:pPr>
+            <a:r>
+              <a:rPr sz="1200" b="1" i="0">
+                <a:solidFill>
+                  <a:srgbClr val="D97706"/>
+                </a:solidFill>
+                <a:latin typeface="Calibri"/>
+              </a:rPr>
+              <a:t>Honest numbers: </a:t>
+            </a:r>
+            <a:r>
+              <a:rPr sz="1150" b="0" i="0">
+                <a:solidFill>
+                  <a:srgbClr val="334155"/>
+                </a:solidFill>
+                <a:latin typeface="Calibri"/>
+              </a:rPr>
+              <a:t>the £512k/yr figure comes from demonstration data — we treat it as indicative and validate it against real programmes during the Phase 3–4 pilot before claiming it in any business case.</a:t>
+            </a:r>
+          </a:p>
+        </p:txBody>
+      </p:sp>
+    </p:spTree>
+  </p:cSld>
+  <p:clrMapOvr>
+    <a:masterClrMapping/>
+  </p:clrMapOvr>
+</p:sld>
+</file>
+
 <file path=ppt/slides/slide2.xml><?xml version="1.0" encoding="utf-8"?>
 <p:sld xmlns:a="http://schemas.openxmlformats.org/drawingml/2006/main" xmlns:p="http://schemas.openxmlformats.org/presentationml/2006/main" xmlns:r="http://schemas.openxmlformats.org/officeDocument/2006/relationships">
   <p:cSld>
@@ -16767,6 +18260,2070 @@
                 <a:latin typeface="Calibri"/>
               </a:rPr>
               <a:t>CAPEE keeps the workflow; CostVision adds the AI, physics and organisational memory behind it. No tool replacement.</a:t>
+            </a:r>
+          </a:p>
+        </p:txBody>
+      </p:sp>
+    </p:spTree>
+  </p:cSld>
+  <p:clrMapOvr>
+    <a:masterClrMapping/>
+  </p:clrMapOvr>
+</p:sld>
+</file>
+
+<file path=ppt/slides/slide20.xml><?xml version="1.0" encoding="utf-8"?>
+<p:sld xmlns:a="http://schemas.openxmlformats.org/drawingml/2006/main" xmlns:p="http://schemas.openxmlformats.org/presentationml/2006/main" xmlns:r="http://schemas.openxmlformats.org/officeDocument/2006/relationships">
+  <p:cSld>
+    <p:spTree>
+      <p:nvGrpSpPr>
+        <p:cNvPr id="1" name=""/>
+        <p:cNvGrpSpPr/>
+        <p:nvPr/>
+      </p:nvGrpSpPr>
+      <p:grpSpPr/>
+      <p:sp>
+        <p:nvSpPr>
+          <p:cNvPr id="2" name="Rectangle 1"/>
+          <p:cNvSpPr/>
+          <p:nvPr/>
+        </p:nvSpPr>
+        <p:spPr>
+          <a:xfrm>
+            <a:off x="0" y="0"/>
+            <a:ext cx="12191695" cy="6858000"/>
+          </a:xfrm>
+          <a:prstGeom prst="rect">
+            <a:avLst/>
+          </a:prstGeom>
+          <a:solidFill>
+            <a:srgbClr val="FFFFFF"/>
+          </a:solidFill>
+          <a:ln>
+            <a:noFill/>
+          </a:ln>
+          <a:effectLst/>
+        </p:spPr>
+        <p:style>
+          <a:lnRef idx="1">
+            <a:schemeClr val="accent1"/>
+          </a:lnRef>
+          <a:fillRef idx="3">
+            <a:schemeClr val="accent1"/>
+          </a:fillRef>
+          <a:effectRef idx="2">
+            <a:schemeClr val="accent1"/>
+          </a:effectRef>
+          <a:fontRef idx="minor">
+            <a:schemeClr val="lt1"/>
+          </a:fontRef>
+        </p:style>
+        <p:txBody>
+          <a:bodyPr rtlCol="0" anchor="ctr"/>
+          <a:lstStyle/>
+          <a:p>
+            <a:pPr algn="ctr"/>
+          </a:p>
+        </p:txBody>
+      </p:sp>
+      <p:sp>
+        <p:nvSpPr>
+          <p:cNvPr id="3" name="Rounded Rectangle 2"/>
+          <p:cNvSpPr/>
+          <p:nvPr/>
+        </p:nvSpPr>
+        <p:spPr>
+          <a:xfrm>
+            <a:off x="320040" y="201168"/>
+            <a:ext cx="384048" cy="384048"/>
+          </a:xfrm>
+          <a:prstGeom prst="roundRect">
+            <a:avLst>
+              <a:gd name="adj" fmla="val 28000"/>
+            </a:avLst>
+          </a:prstGeom>
+          <a:solidFill>
+            <a:srgbClr val="4F46E5"/>
+          </a:solidFill>
+          <a:ln>
+            <a:noFill/>
+          </a:ln>
+          <a:effectLst/>
+        </p:spPr>
+        <p:style>
+          <a:lnRef idx="1">
+            <a:schemeClr val="accent1"/>
+          </a:lnRef>
+          <a:fillRef idx="3">
+            <a:schemeClr val="accent1"/>
+          </a:fillRef>
+          <a:effectRef idx="2">
+            <a:schemeClr val="accent1"/>
+          </a:effectRef>
+          <a:fontRef idx="minor">
+            <a:schemeClr val="lt1"/>
+          </a:fontRef>
+        </p:style>
+        <p:txBody>
+          <a:bodyPr rtlCol="0" anchor="ctr" lIns="0" rIns="0" tIns="0" bIns="0"/>
+          <a:lstStyle/>
+          <a:p>
+            <a:pPr algn="ctr"/>
+            <a:r>
+              <a:rPr sz="1700" b="1">
+                <a:solidFill>
+                  <a:srgbClr val="FFFFFF"/>
+                </a:solidFill>
+                <a:latin typeface="Calibri"/>
+              </a:rPr>
+              <a:t>cv</a:t>
+            </a:r>
+          </a:p>
+        </p:txBody>
+      </p:sp>
+      <p:sp>
+        <p:nvSpPr>
+          <p:cNvPr id="4" name="TextBox 3"/>
+          <p:cNvSpPr txBox="1"/>
+          <p:nvPr/>
+        </p:nvSpPr>
+        <p:spPr>
+          <a:xfrm>
+            <a:off x="795528" y="173736"/>
+            <a:ext cx="2377440" cy="292608"/>
+          </a:xfrm>
+          <a:prstGeom prst="rect">
+            <a:avLst/>
+          </a:prstGeom>
+          <a:noFill/>
+        </p:spPr>
+        <p:txBody>
+          <a:bodyPr wrap="square" anchor="t" lIns="0" rIns="0" tIns="0" bIns="0">
+            <a:spAutoFit/>
+          </a:bodyPr>
+          <a:lstStyle/>
+          <a:p>
+            <a:pPr algn="l">
+              <a:lnSpc>
+                <a:spcPct val="100000"/>
+              </a:lnSpc>
+              <a:spcAft>
+                <a:spcPts val="400"/>
+              </a:spcAft>
+            </a:pPr>
+            <a:r>
+              <a:rPr sz="1800" b="1" i="0">
+                <a:solidFill>
+                  <a:srgbClr val="2563EB"/>
+                </a:solidFill>
+                <a:latin typeface="Calibri"/>
+              </a:rPr>
+              <a:t>CostVision</a:t>
+            </a:r>
+          </a:p>
+        </p:txBody>
+      </p:sp>
+      <p:sp>
+        <p:nvSpPr>
+          <p:cNvPr id="5" name="TextBox 4"/>
+          <p:cNvSpPr txBox="1"/>
+          <p:nvPr/>
+        </p:nvSpPr>
+        <p:spPr>
+          <a:xfrm>
+            <a:off x="795528" y="420624"/>
+            <a:ext cx="2560320" cy="201168"/>
+          </a:xfrm>
+          <a:prstGeom prst="rect">
+            <a:avLst/>
+          </a:prstGeom>
+          <a:noFill/>
+        </p:spPr>
+        <p:txBody>
+          <a:bodyPr wrap="square" anchor="t" lIns="0" rIns="0" tIns="0" bIns="0">
+            <a:spAutoFit/>
+          </a:bodyPr>
+          <a:lstStyle/>
+          <a:p>
+            <a:pPr algn="l">
+              <a:lnSpc>
+                <a:spcPct val="100000"/>
+              </a:lnSpc>
+              <a:spcAft>
+                <a:spcPts val="400"/>
+              </a:spcAft>
+            </a:pPr>
+            <a:r>
+              <a:rPr sz="750" b="0" i="0">
+                <a:solidFill>
+                  <a:srgbClr val="64748B"/>
+                </a:solidFill>
+                <a:latin typeface="Calibri"/>
+              </a:rPr>
+              <a:t>AI  COST  INTELLIGENCE</a:t>
+            </a:r>
+          </a:p>
+        </p:txBody>
+      </p:sp>
+      <p:sp>
+        <p:nvSpPr>
+          <p:cNvPr id="6" name="Rectangle 5"/>
+          <p:cNvSpPr/>
+          <p:nvPr/>
+        </p:nvSpPr>
+        <p:spPr>
+          <a:xfrm>
+            <a:off x="0" y="713232"/>
+            <a:ext cx="12191695" cy="27940"/>
+          </a:xfrm>
+          <a:prstGeom prst="rect">
+            <a:avLst/>
+          </a:prstGeom>
+          <a:solidFill>
+            <a:srgbClr val="4F46E5"/>
+          </a:solidFill>
+          <a:ln>
+            <a:noFill/>
+          </a:ln>
+          <a:effectLst/>
+        </p:spPr>
+        <p:style>
+          <a:lnRef idx="1">
+            <a:schemeClr val="accent1"/>
+          </a:lnRef>
+          <a:fillRef idx="3">
+            <a:schemeClr val="accent1"/>
+          </a:fillRef>
+          <a:effectRef idx="2">
+            <a:schemeClr val="accent1"/>
+          </a:effectRef>
+          <a:fontRef idx="minor">
+            <a:schemeClr val="lt1"/>
+          </a:fontRef>
+        </p:style>
+        <p:txBody>
+          <a:bodyPr rtlCol="0" anchor="ctr"/>
+          <a:lstStyle/>
+          <a:p>
+            <a:pPr algn="ctr"/>
+          </a:p>
+        </p:txBody>
+      </p:sp>
+      <p:sp>
+        <p:nvSpPr>
+          <p:cNvPr id="7" name="TextBox 6"/>
+          <p:cNvSpPr txBox="1"/>
+          <p:nvPr/>
+        </p:nvSpPr>
+        <p:spPr>
+          <a:xfrm>
+            <a:off x="411480" y="868680"/>
+            <a:ext cx="10515600" cy="274320"/>
+          </a:xfrm>
+          <a:prstGeom prst="rect">
+            <a:avLst/>
+          </a:prstGeom>
+          <a:noFill/>
+        </p:spPr>
+        <p:txBody>
+          <a:bodyPr wrap="square" anchor="t" lIns="0" rIns="0" tIns="0" bIns="0">
+            <a:spAutoFit/>
+          </a:bodyPr>
+          <a:lstStyle/>
+          <a:p>
+            <a:pPr algn="l">
+              <a:lnSpc>
+                <a:spcPct val="100000"/>
+              </a:lnSpc>
+              <a:spcAft>
+                <a:spcPts val="400"/>
+              </a:spcAft>
+            </a:pPr>
+            <a:r>
+              <a:rPr sz="1100" b="1" i="0">
+                <a:solidFill>
+                  <a:srgbClr val="2563EB"/>
+                </a:solidFill>
+                <a:latin typeface="Calibri"/>
+              </a:rPr>
+              <a:t>BACKUP · EVIDENCE</a:t>
+            </a:r>
+          </a:p>
+        </p:txBody>
+      </p:sp>
+      <p:sp>
+        <p:nvSpPr>
+          <p:cNvPr id="8" name="TextBox 7"/>
+          <p:cNvSpPr txBox="1"/>
+          <p:nvPr/>
+        </p:nvSpPr>
+        <p:spPr>
+          <a:xfrm>
+            <a:off x="411480" y="1115568"/>
+            <a:ext cx="11338560" cy="548640"/>
+          </a:xfrm>
+          <a:prstGeom prst="rect">
+            <a:avLst/>
+          </a:prstGeom>
+          <a:noFill/>
+        </p:spPr>
+        <p:txBody>
+          <a:bodyPr wrap="square" anchor="t" lIns="0" rIns="0" tIns="0" bIns="0">
+            <a:spAutoFit/>
+          </a:bodyPr>
+          <a:lstStyle/>
+          <a:p>
+            <a:pPr algn="l">
+              <a:lnSpc>
+                <a:spcPct val="100000"/>
+              </a:lnSpc>
+              <a:spcAft>
+                <a:spcPts val="400"/>
+              </a:spcAft>
+            </a:pPr>
+            <a:r>
+              <a:rPr sz="2700" b="1" i="0">
+                <a:solidFill>
+                  <a:srgbClr val="0F172A"/>
+                </a:solidFill>
+                <a:latin typeface="Calibri"/>
+              </a:rPr>
+              <a:t>Does it actually work? The measured results</a:t>
+            </a:r>
+          </a:p>
+        </p:txBody>
+      </p:sp>
+      <p:graphicFrame>
+        <p:nvGraphicFramePr>
+          <p:cNvPr id="9" name="Chart 8"/>
+          <p:cNvGraphicFramePr>
+            <a:graphicFrameLocks noGrp="1"/>
+          </p:cNvGraphicFramePr>
+          <p:nvPr/>
+        </p:nvGraphicFramePr>
+        <p:xfrm>
+          <a:off x="411480" y="1828800"/>
+          <a:ext cx="6675120" cy="4023360"/>
+        </p:xfrm>
+        <a:graphic>
+          <a:graphicData uri="http://schemas.openxmlformats.org/drawingml/2006/chart">
+            <c:chart xmlns:c="http://schemas.openxmlformats.org/drawingml/2006/chart" r:id="rId2"/>
+          </a:graphicData>
+        </a:graphic>
+      </p:graphicFrame>
+      <p:sp>
+        <p:nvSpPr>
+          <p:cNvPr id="10" name="TextBox 9"/>
+          <p:cNvSpPr txBox="1"/>
+          <p:nvPr/>
+        </p:nvSpPr>
+        <p:spPr>
+          <a:xfrm>
+            <a:off x="411480" y="5943600"/>
+            <a:ext cx="6675120" cy="548640"/>
+          </a:xfrm>
+          <a:prstGeom prst="rect">
+            <a:avLst/>
+          </a:prstGeom>
+          <a:noFill/>
+        </p:spPr>
+        <p:txBody>
+          <a:bodyPr wrap="square" anchor="t" lIns="0" rIns="0" tIns="0" bIns="0">
+            <a:spAutoFit/>
+          </a:bodyPr>
+          <a:lstStyle/>
+          <a:p>
+            <a:pPr algn="l">
+              <a:lnSpc>
+                <a:spcPct val="110000"/>
+              </a:lnSpc>
+              <a:spcAft>
+                <a:spcPts val="400"/>
+              </a:spcAft>
+            </a:pPr>
+            <a:r>
+              <a:rPr sz="1000" b="0" i="1">
+                <a:solidFill>
+                  <a:srgbClr val="64748B"/>
+                </a:solidFill>
+                <a:latin typeface="Calibri"/>
+              </a:rPr>
+              <a:t>Live test runs, July 2026 — after the engine learned from just 3 real supplier quotes per commodity.</a:t>
+            </a:r>
+          </a:p>
+        </p:txBody>
+      </p:sp>
+      <p:sp>
+        <p:nvSpPr>
+          <p:cNvPr id="11" name="Rounded Rectangle 10"/>
+          <p:cNvSpPr/>
+          <p:nvPr/>
+        </p:nvSpPr>
+        <p:spPr>
+          <a:xfrm>
+            <a:off x="7406640" y="1828800"/>
+            <a:ext cx="4389120" cy="987552"/>
+          </a:xfrm>
+          <a:prstGeom prst="roundRect">
+            <a:avLst>
+              <a:gd name="adj" fmla="val 10000"/>
+            </a:avLst>
+          </a:prstGeom>
+          <a:solidFill>
+            <a:srgbClr val="F1F5F9"/>
+          </a:solidFill>
+          <a:ln>
+            <a:noFill/>
+          </a:ln>
+          <a:effectLst/>
+        </p:spPr>
+        <p:style>
+          <a:lnRef idx="1">
+            <a:schemeClr val="accent1"/>
+          </a:lnRef>
+          <a:fillRef idx="3">
+            <a:schemeClr val="accent1"/>
+          </a:fillRef>
+          <a:effectRef idx="2">
+            <a:schemeClr val="accent1"/>
+          </a:effectRef>
+          <a:fontRef idx="minor">
+            <a:schemeClr val="lt1"/>
+          </a:fontRef>
+        </p:style>
+        <p:txBody>
+          <a:bodyPr rtlCol="0" anchor="ctr"/>
+          <a:lstStyle/>
+          <a:p>
+            <a:pPr algn="ctr"/>
+          </a:p>
+        </p:txBody>
+      </p:sp>
+      <p:sp>
+        <p:nvSpPr>
+          <p:cNvPr id="12" name="Rectangle 11"/>
+          <p:cNvSpPr/>
+          <p:nvPr/>
+        </p:nvSpPr>
+        <p:spPr>
+          <a:xfrm>
+            <a:off x="7406640" y="1828800"/>
+            <a:ext cx="82296" cy="987552"/>
+          </a:xfrm>
+          <a:prstGeom prst="rect">
+            <a:avLst/>
+          </a:prstGeom>
+          <a:solidFill>
+            <a:srgbClr val="2563EB"/>
+          </a:solidFill>
+          <a:ln>
+            <a:noFill/>
+          </a:ln>
+          <a:effectLst/>
+        </p:spPr>
+        <p:style>
+          <a:lnRef idx="1">
+            <a:schemeClr val="accent1"/>
+          </a:lnRef>
+          <a:fillRef idx="3">
+            <a:schemeClr val="accent1"/>
+          </a:fillRef>
+          <a:effectRef idx="2">
+            <a:schemeClr val="accent1"/>
+          </a:effectRef>
+          <a:fontRef idx="minor">
+            <a:schemeClr val="lt1"/>
+          </a:fontRef>
+        </p:style>
+        <p:txBody>
+          <a:bodyPr rtlCol="0" anchor="ctr"/>
+          <a:lstStyle/>
+          <a:p>
+            <a:pPr algn="ctr"/>
+          </a:p>
+        </p:txBody>
+      </p:sp>
+      <p:sp>
+        <p:nvSpPr>
+          <p:cNvPr id="13" name="TextBox 12"/>
+          <p:cNvSpPr txBox="1"/>
+          <p:nvPr/>
+        </p:nvSpPr>
+        <p:spPr>
+          <a:xfrm>
+            <a:off x="7680960" y="1938528"/>
+            <a:ext cx="1554480" cy="457200"/>
+          </a:xfrm>
+          <a:prstGeom prst="rect">
+            <a:avLst/>
+          </a:prstGeom>
+          <a:noFill/>
+        </p:spPr>
+        <p:txBody>
+          <a:bodyPr wrap="square" anchor="t" lIns="0" rIns="0" tIns="0" bIns="0">
+            <a:spAutoFit/>
+          </a:bodyPr>
+          <a:lstStyle/>
+          <a:p>
+            <a:pPr algn="l">
+              <a:lnSpc>
+                <a:spcPct val="100000"/>
+              </a:lnSpc>
+              <a:spcAft>
+                <a:spcPts val="400"/>
+              </a:spcAft>
+            </a:pPr>
+            <a:r>
+              <a:rPr sz="1900" b="1" i="0">
+                <a:solidFill>
+                  <a:srgbClr val="2563EB"/>
+                </a:solidFill>
+                <a:latin typeface="Calibri"/>
+              </a:rPr>
+              <a:t>99%</a:t>
+            </a:r>
+          </a:p>
+        </p:txBody>
+      </p:sp>
+      <p:sp>
+        <p:nvSpPr>
+          <p:cNvPr id="14" name="TextBox 13"/>
+          <p:cNvSpPr txBox="1"/>
+          <p:nvPr/>
+        </p:nvSpPr>
+        <p:spPr>
+          <a:xfrm>
+            <a:off x="9189720" y="1956816"/>
+            <a:ext cx="2514600" cy="777240"/>
+          </a:xfrm>
+          <a:prstGeom prst="rect">
+            <a:avLst/>
+          </a:prstGeom>
+          <a:noFill/>
+        </p:spPr>
+        <p:txBody>
+          <a:bodyPr wrap="square" anchor="t" lIns="0" rIns="0" tIns="0" bIns="0">
+            <a:spAutoFit/>
+          </a:bodyPr>
+          <a:lstStyle/>
+          <a:p>
+            <a:pPr algn="l">
+              <a:lnSpc>
+                <a:spcPct val="110000"/>
+              </a:lnSpc>
+              <a:spcAft>
+                <a:spcPts val="400"/>
+              </a:spcAft>
+            </a:pPr>
+            <a:r>
+              <a:rPr sz="1000" b="0" i="0">
+                <a:solidFill>
+                  <a:srgbClr val="334155"/>
+                </a:solidFill>
+                <a:latin typeface="Calibri"/>
+              </a:rPr>
+              <a:t>part-match accuracy — the AI memory finds the right similar past part</a:t>
+            </a:r>
+          </a:p>
+        </p:txBody>
+      </p:sp>
+      <p:sp>
+        <p:nvSpPr>
+          <p:cNvPr id="15" name="Rounded Rectangle 14"/>
+          <p:cNvSpPr/>
+          <p:nvPr/>
+        </p:nvSpPr>
+        <p:spPr>
+          <a:xfrm>
+            <a:off x="7406640" y="2953512"/>
+            <a:ext cx="4389120" cy="987552"/>
+          </a:xfrm>
+          <a:prstGeom prst="roundRect">
+            <a:avLst>
+              <a:gd name="adj" fmla="val 10000"/>
+            </a:avLst>
+          </a:prstGeom>
+          <a:solidFill>
+            <a:srgbClr val="F1F5F9"/>
+          </a:solidFill>
+          <a:ln>
+            <a:noFill/>
+          </a:ln>
+          <a:effectLst/>
+        </p:spPr>
+        <p:style>
+          <a:lnRef idx="1">
+            <a:schemeClr val="accent1"/>
+          </a:lnRef>
+          <a:fillRef idx="3">
+            <a:schemeClr val="accent1"/>
+          </a:fillRef>
+          <a:effectRef idx="2">
+            <a:schemeClr val="accent1"/>
+          </a:effectRef>
+          <a:fontRef idx="minor">
+            <a:schemeClr val="lt1"/>
+          </a:fontRef>
+        </p:style>
+        <p:txBody>
+          <a:bodyPr rtlCol="0" anchor="ctr"/>
+          <a:lstStyle/>
+          <a:p>
+            <a:pPr algn="ctr"/>
+          </a:p>
+        </p:txBody>
+      </p:sp>
+      <p:sp>
+        <p:nvSpPr>
+          <p:cNvPr id="16" name="Rectangle 15"/>
+          <p:cNvSpPr/>
+          <p:nvPr/>
+        </p:nvSpPr>
+        <p:spPr>
+          <a:xfrm>
+            <a:off x="7406640" y="2953512"/>
+            <a:ext cx="82296" cy="987552"/>
+          </a:xfrm>
+          <a:prstGeom prst="rect">
+            <a:avLst/>
+          </a:prstGeom>
+          <a:solidFill>
+            <a:srgbClr val="7C3AED"/>
+          </a:solidFill>
+          <a:ln>
+            <a:noFill/>
+          </a:ln>
+          <a:effectLst/>
+        </p:spPr>
+        <p:style>
+          <a:lnRef idx="1">
+            <a:schemeClr val="accent1"/>
+          </a:lnRef>
+          <a:fillRef idx="3">
+            <a:schemeClr val="accent1"/>
+          </a:fillRef>
+          <a:effectRef idx="2">
+            <a:schemeClr val="accent1"/>
+          </a:effectRef>
+          <a:fontRef idx="minor">
+            <a:schemeClr val="lt1"/>
+          </a:fontRef>
+        </p:style>
+        <p:txBody>
+          <a:bodyPr rtlCol="0" anchor="ctr"/>
+          <a:lstStyle/>
+          <a:p>
+            <a:pPr algn="ctr"/>
+          </a:p>
+        </p:txBody>
+      </p:sp>
+      <p:sp>
+        <p:nvSpPr>
+          <p:cNvPr id="17" name="TextBox 16"/>
+          <p:cNvSpPr txBox="1"/>
+          <p:nvPr/>
+        </p:nvSpPr>
+        <p:spPr>
+          <a:xfrm>
+            <a:off x="7680960" y="3063240"/>
+            <a:ext cx="1554480" cy="457200"/>
+          </a:xfrm>
+          <a:prstGeom prst="rect">
+            <a:avLst/>
+          </a:prstGeom>
+          <a:noFill/>
+        </p:spPr>
+        <p:txBody>
+          <a:bodyPr wrap="square" anchor="t" lIns="0" rIns="0" tIns="0" bIns="0">
+            <a:spAutoFit/>
+          </a:bodyPr>
+          <a:lstStyle/>
+          <a:p>
+            <a:pPr algn="l">
+              <a:lnSpc>
+                <a:spcPct val="100000"/>
+              </a:lnSpc>
+              <a:spcAft>
+                <a:spcPts val="400"/>
+              </a:spcAft>
+            </a:pPr>
+            <a:r>
+              <a:rPr sz="1900" b="1" i="0">
+                <a:solidFill>
+                  <a:srgbClr val="7C3AED"/>
+                </a:solidFill>
+                <a:latin typeface="Calibri"/>
+              </a:rPr>
+              <a:t>793</a:t>
+            </a:r>
+          </a:p>
+        </p:txBody>
+      </p:sp>
+      <p:sp>
+        <p:nvSpPr>
+          <p:cNvPr id="18" name="TextBox 17"/>
+          <p:cNvSpPr txBox="1"/>
+          <p:nvPr/>
+        </p:nvSpPr>
+        <p:spPr>
+          <a:xfrm>
+            <a:off x="9189720" y="3081528"/>
+            <a:ext cx="2514600" cy="777240"/>
+          </a:xfrm>
+          <a:prstGeom prst="rect">
+            <a:avLst/>
+          </a:prstGeom>
+          <a:noFill/>
+        </p:spPr>
+        <p:txBody>
+          <a:bodyPr wrap="square" anchor="t" lIns="0" rIns="0" tIns="0" bIns="0">
+            <a:spAutoFit/>
+          </a:bodyPr>
+          <a:lstStyle/>
+          <a:p>
+            <a:pPr algn="l">
+              <a:lnSpc>
+                <a:spcPct val="110000"/>
+              </a:lnSpc>
+              <a:spcAft>
+                <a:spcPts val="400"/>
+              </a:spcAft>
+            </a:pPr>
+            <a:r>
+              <a:rPr sz="1000" b="0" i="0">
+                <a:solidFill>
+                  <a:srgbClr val="334155"/>
+                </a:solidFill>
+                <a:latin typeface="Calibri"/>
+              </a:rPr>
+              <a:t>automated tests protect every engine and feature on each change</a:t>
+            </a:r>
+          </a:p>
+        </p:txBody>
+      </p:sp>
+      <p:sp>
+        <p:nvSpPr>
+          <p:cNvPr id="19" name="Rounded Rectangle 18"/>
+          <p:cNvSpPr/>
+          <p:nvPr/>
+        </p:nvSpPr>
+        <p:spPr>
+          <a:xfrm>
+            <a:off x="7406640" y="4078224"/>
+            <a:ext cx="4389120" cy="987552"/>
+          </a:xfrm>
+          <a:prstGeom prst="roundRect">
+            <a:avLst>
+              <a:gd name="adj" fmla="val 10000"/>
+            </a:avLst>
+          </a:prstGeom>
+          <a:solidFill>
+            <a:srgbClr val="F1F5F9"/>
+          </a:solidFill>
+          <a:ln>
+            <a:noFill/>
+          </a:ln>
+          <a:effectLst/>
+        </p:spPr>
+        <p:style>
+          <a:lnRef idx="1">
+            <a:schemeClr val="accent1"/>
+          </a:lnRef>
+          <a:fillRef idx="3">
+            <a:schemeClr val="accent1"/>
+          </a:fillRef>
+          <a:effectRef idx="2">
+            <a:schemeClr val="accent1"/>
+          </a:effectRef>
+          <a:fontRef idx="minor">
+            <a:schemeClr val="lt1"/>
+          </a:fontRef>
+        </p:style>
+        <p:txBody>
+          <a:bodyPr rtlCol="0" anchor="ctr"/>
+          <a:lstStyle/>
+          <a:p>
+            <a:pPr algn="ctr"/>
+          </a:p>
+        </p:txBody>
+      </p:sp>
+      <p:sp>
+        <p:nvSpPr>
+          <p:cNvPr id="20" name="Rectangle 19"/>
+          <p:cNvSpPr/>
+          <p:nvPr/>
+        </p:nvSpPr>
+        <p:spPr>
+          <a:xfrm>
+            <a:off x="7406640" y="4078224"/>
+            <a:ext cx="82296" cy="987552"/>
+          </a:xfrm>
+          <a:prstGeom prst="rect">
+            <a:avLst/>
+          </a:prstGeom>
+          <a:solidFill>
+            <a:srgbClr val="059669"/>
+          </a:solidFill>
+          <a:ln>
+            <a:noFill/>
+          </a:ln>
+          <a:effectLst/>
+        </p:spPr>
+        <p:style>
+          <a:lnRef idx="1">
+            <a:schemeClr val="accent1"/>
+          </a:lnRef>
+          <a:fillRef idx="3">
+            <a:schemeClr val="accent1"/>
+          </a:fillRef>
+          <a:effectRef idx="2">
+            <a:schemeClr val="accent1"/>
+          </a:effectRef>
+          <a:fontRef idx="minor">
+            <a:schemeClr val="lt1"/>
+          </a:fontRef>
+        </p:style>
+        <p:txBody>
+          <a:bodyPr rtlCol="0" anchor="ctr"/>
+          <a:lstStyle/>
+          <a:p>
+            <a:pPr algn="ctr"/>
+          </a:p>
+        </p:txBody>
+      </p:sp>
+      <p:sp>
+        <p:nvSpPr>
+          <p:cNvPr id="21" name="TextBox 20"/>
+          <p:cNvSpPr txBox="1"/>
+          <p:nvPr/>
+        </p:nvSpPr>
+        <p:spPr>
+          <a:xfrm>
+            <a:off x="7680960" y="4187952"/>
+            <a:ext cx="1554480" cy="457200"/>
+          </a:xfrm>
+          <a:prstGeom prst="rect">
+            <a:avLst/>
+          </a:prstGeom>
+          <a:noFill/>
+        </p:spPr>
+        <p:txBody>
+          <a:bodyPr wrap="square" anchor="t" lIns="0" rIns="0" tIns="0" bIns="0">
+            <a:spAutoFit/>
+          </a:bodyPr>
+          <a:lstStyle/>
+          <a:p>
+            <a:pPr algn="l">
+              <a:lnSpc>
+                <a:spcPct val="100000"/>
+              </a:lnSpc>
+              <a:spcAft>
+                <a:spcPts val="400"/>
+              </a:spcAft>
+            </a:pPr>
+            <a:r>
+              <a:rPr sz="1900" b="1" i="0">
+                <a:solidFill>
+                  <a:srgbClr val="059669"/>
+                </a:solidFill>
+                <a:latin typeface="Calibri"/>
+              </a:rPr>
+              <a:t>3 quotes</a:t>
+            </a:r>
+          </a:p>
+        </p:txBody>
+      </p:sp>
+      <p:sp>
+        <p:nvSpPr>
+          <p:cNvPr id="22" name="TextBox 21"/>
+          <p:cNvSpPr txBox="1"/>
+          <p:nvPr/>
+        </p:nvSpPr>
+        <p:spPr>
+          <a:xfrm>
+            <a:off x="9189720" y="4206240"/>
+            <a:ext cx="2514600" cy="777240"/>
+          </a:xfrm>
+          <a:prstGeom prst="rect">
+            <a:avLst/>
+          </a:prstGeom>
+          <a:noFill/>
+        </p:spPr>
+        <p:txBody>
+          <a:bodyPr wrap="square" anchor="t" lIns="0" rIns="0" tIns="0" bIns="0">
+            <a:spAutoFit/>
+          </a:bodyPr>
+          <a:lstStyle/>
+          <a:p>
+            <a:pPr algn="l">
+              <a:lnSpc>
+                <a:spcPct val="110000"/>
+              </a:lnSpc>
+              <a:spcAft>
+                <a:spcPts val="400"/>
+              </a:spcAft>
+            </a:pPr>
+            <a:r>
+              <a:rPr sz="1000" b="0" i="0">
+                <a:solidFill>
+                  <a:srgbClr val="334155"/>
+                </a:solidFill>
+                <a:latin typeface="Calibri"/>
+              </a:rPr>
+              <a:t>is all the calibration needs before accuracy lands under 1%</a:t>
+            </a:r>
+          </a:p>
+        </p:txBody>
+      </p:sp>
+      <p:sp>
+        <p:nvSpPr>
+          <p:cNvPr id="23" name="Rounded Rectangle 22"/>
+          <p:cNvSpPr/>
+          <p:nvPr/>
+        </p:nvSpPr>
+        <p:spPr>
+          <a:xfrm>
+            <a:off x="7406640" y="5202936"/>
+            <a:ext cx="4389120" cy="987552"/>
+          </a:xfrm>
+          <a:prstGeom prst="roundRect">
+            <a:avLst>
+              <a:gd name="adj" fmla="val 10000"/>
+            </a:avLst>
+          </a:prstGeom>
+          <a:solidFill>
+            <a:srgbClr val="F1F5F9"/>
+          </a:solidFill>
+          <a:ln>
+            <a:noFill/>
+          </a:ln>
+          <a:effectLst/>
+        </p:spPr>
+        <p:style>
+          <a:lnRef idx="1">
+            <a:schemeClr val="accent1"/>
+          </a:lnRef>
+          <a:fillRef idx="3">
+            <a:schemeClr val="accent1"/>
+          </a:fillRef>
+          <a:effectRef idx="2">
+            <a:schemeClr val="accent1"/>
+          </a:effectRef>
+          <a:fontRef idx="minor">
+            <a:schemeClr val="lt1"/>
+          </a:fontRef>
+        </p:style>
+        <p:txBody>
+          <a:bodyPr rtlCol="0" anchor="ctr"/>
+          <a:lstStyle/>
+          <a:p>
+            <a:pPr algn="ctr"/>
+          </a:p>
+        </p:txBody>
+      </p:sp>
+      <p:sp>
+        <p:nvSpPr>
+          <p:cNvPr id="24" name="Rectangle 23"/>
+          <p:cNvSpPr/>
+          <p:nvPr/>
+        </p:nvSpPr>
+        <p:spPr>
+          <a:xfrm>
+            <a:off x="7406640" y="5202936"/>
+            <a:ext cx="82296" cy="987552"/>
+          </a:xfrm>
+          <a:prstGeom prst="rect">
+            <a:avLst/>
+          </a:prstGeom>
+          <a:solidFill>
+            <a:srgbClr val="0891B2"/>
+          </a:solidFill>
+          <a:ln>
+            <a:noFill/>
+          </a:ln>
+          <a:effectLst/>
+        </p:spPr>
+        <p:style>
+          <a:lnRef idx="1">
+            <a:schemeClr val="accent1"/>
+          </a:lnRef>
+          <a:fillRef idx="3">
+            <a:schemeClr val="accent1"/>
+          </a:fillRef>
+          <a:effectRef idx="2">
+            <a:schemeClr val="accent1"/>
+          </a:effectRef>
+          <a:fontRef idx="minor">
+            <a:schemeClr val="lt1"/>
+          </a:fontRef>
+        </p:style>
+        <p:txBody>
+          <a:bodyPr rtlCol="0" anchor="ctr"/>
+          <a:lstStyle/>
+          <a:p>
+            <a:pPr algn="ctr"/>
+          </a:p>
+        </p:txBody>
+      </p:sp>
+      <p:sp>
+        <p:nvSpPr>
+          <p:cNvPr id="25" name="TextBox 24"/>
+          <p:cNvSpPr txBox="1"/>
+          <p:nvPr/>
+        </p:nvSpPr>
+        <p:spPr>
+          <a:xfrm>
+            <a:off x="7680960" y="5312664"/>
+            <a:ext cx="1554480" cy="457200"/>
+          </a:xfrm>
+          <a:prstGeom prst="rect">
+            <a:avLst/>
+          </a:prstGeom>
+          <a:noFill/>
+        </p:spPr>
+        <p:txBody>
+          <a:bodyPr wrap="square" anchor="t" lIns="0" rIns="0" tIns="0" bIns="0">
+            <a:spAutoFit/>
+          </a:bodyPr>
+          <a:lstStyle/>
+          <a:p>
+            <a:pPr algn="l">
+              <a:lnSpc>
+                <a:spcPct val="100000"/>
+              </a:lnSpc>
+              <a:spcAft>
+                <a:spcPts val="400"/>
+              </a:spcAft>
+            </a:pPr>
+            <a:r>
+              <a:rPr sz="1900" b="1" i="0">
+                <a:solidFill>
+                  <a:srgbClr val="0891B2"/>
+                </a:solidFill>
+                <a:latin typeface="Calibri"/>
+              </a:rPr>
+              <a:t>£512k/yr</a:t>
+            </a:r>
+          </a:p>
+        </p:txBody>
+      </p:sp>
+      <p:sp>
+        <p:nvSpPr>
+          <p:cNvPr id="26" name="TextBox 25"/>
+          <p:cNvSpPr txBox="1"/>
+          <p:nvPr/>
+        </p:nvSpPr>
+        <p:spPr>
+          <a:xfrm>
+            <a:off x="9189720" y="5330952"/>
+            <a:ext cx="2514600" cy="777240"/>
+          </a:xfrm>
+          <a:prstGeom prst="rect">
+            <a:avLst/>
+          </a:prstGeom>
+          <a:noFill/>
+        </p:spPr>
+        <p:txBody>
+          <a:bodyPr wrap="square" anchor="t" lIns="0" rIns="0" tIns="0" bIns="0">
+            <a:spAutoFit/>
+          </a:bodyPr>
+          <a:lstStyle/>
+          <a:p>
+            <a:pPr algn="l">
+              <a:lnSpc>
+                <a:spcPct val="110000"/>
+              </a:lnSpc>
+              <a:spcAft>
+                <a:spcPts val="400"/>
+              </a:spcAft>
+            </a:pPr>
+            <a:r>
+              <a:rPr sz="1000" b="0" i="0">
+                <a:solidFill>
+                  <a:srgbClr val="334155"/>
+                </a:solidFill>
+                <a:latin typeface="Calibri"/>
+              </a:rPr>
+              <a:t>findings raised by the autonomous agent in the live demo</a:t>
+            </a:r>
+          </a:p>
+        </p:txBody>
+      </p:sp>
+    </p:spTree>
+  </p:cSld>
+  <p:clrMapOvr>
+    <a:masterClrMapping/>
+  </p:clrMapOvr>
+</p:sld>
+</file>
+
+<file path=ppt/slides/slide21.xml><?xml version="1.0" encoding="utf-8"?>
+<p:sld xmlns:a="http://schemas.openxmlformats.org/drawingml/2006/main" xmlns:p="http://schemas.openxmlformats.org/presentationml/2006/main" xmlns:r="http://schemas.openxmlformats.org/officeDocument/2006/relationships">
+  <p:cSld>
+    <p:spTree>
+      <p:nvGrpSpPr>
+        <p:cNvPr id="1" name=""/>
+        <p:cNvGrpSpPr/>
+        <p:nvPr/>
+      </p:nvGrpSpPr>
+      <p:grpSpPr/>
+      <p:sp>
+        <p:nvSpPr>
+          <p:cNvPr id="2" name="Rectangle 1"/>
+          <p:cNvSpPr/>
+          <p:nvPr/>
+        </p:nvSpPr>
+        <p:spPr>
+          <a:xfrm>
+            <a:off x="0" y="0"/>
+            <a:ext cx="12191695" cy="6858000"/>
+          </a:xfrm>
+          <a:prstGeom prst="rect">
+            <a:avLst/>
+          </a:prstGeom>
+          <a:solidFill>
+            <a:srgbClr val="FFFFFF"/>
+          </a:solidFill>
+          <a:ln>
+            <a:noFill/>
+          </a:ln>
+          <a:effectLst/>
+        </p:spPr>
+        <p:style>
+          <a:lnRef idx="1">
+            <a:schemeClr val="accent1"/>
+          </a:lnRef>
+          <a:fillRef idx="3">
+            <a:schemeClr val="accent1"/>
+          </a:fillRef>
+          <a:effectRef idx="2">
+            <a:schemeClr val="accent1"/>
+          </a:effectRef>
+          <a:fontRef idx="minor">
+            <a:schemeClr val="lt1"/>
+          </a:fontRef>
+        </p:style>
+        <p:txBody>
+          <a:bodyPr rtlCol="0" anchor="ctr"/>
+          <a:lstStyle/>
+          <a:p>
+            <a:pPr algn="ctr"/>
+          </a:p>
+        </p:txBody>
+      </p:sp>
+      <p:sp>
+        <p:nvSpPr>
+          <p:cNvPr id="3" name="Rounded Rectangle 2"/>
+          <p:cNvSpPr/>
+          <p:nvPr/>
+        </p:nvSpPr>
+        <p:spPr>
+          <a:xfrm>
+            <a:off x="320040" y="201168"/>
+            <a:ext cx="384048" cy="384048"/>
+          </a:xfrm>
+          <a:prstGeom prst="roundRect">
+            <a:avLst>
+              <a:gd name="adj" fmla="val 28000"/>
+            </a:avLst>
+          </a:prstGeom>
+          <a:solidFill>
+            <a:srgbClr val="4F46E5"/>
+          </a:solidFill>
+          <a:ln>
+            <a:noFill/>
+          </a:ln>
+          <a:effectLst/>
+        </p:spPr>
+        <p:style>
+          <a:lnRef idx="1">
+            <a:schemeClr val="accent1"/>
+          </a:lnRef>
+          <a:fillRef idx="3">
+            <a:schemeClr val="accent1"/>
+          </a:fillRef>
+          <a:effectRef idx="2">
+            <a:schemeClr val="accent1"/>
+          </a:effectRef>
+          <a:fontRef idx="minor">
+            <a:schemeClr val="lt1"/>
+          </a:fontRef>
+        </p:style>
+        <p:txBody>
+          <a:bodyPr rtlCol="0" anchor="ctr" lIns="0" rIns="0" tIns="0" bIns="0"/>
+          <a:lstStyle/>
+          <a:p>
+            <a:pPr algn="ctr"/>
+            <a:r>
+              <a:rPr sz="1700" b="1">
+                <a:solidFill>
+                  <a:srgbClr val="FFFFFF"/>
+                </a:solidFill>
+                <a:latin typeface="Calibri"/>
+              </a:rPr>
+              <a:t>cv</a:t>
+            </a:r>
+          </a:p>
+        </p:txBody>
+      </p:sp>
+      <p:sp>
+        <p:nvSpPr>
+          <p:cNvPr id="4" name="TextBox 3"/>
+          <p:cNvSpPr txBox="1"/>
+          <p:nvPr/>
+        </p:nvSpPr>
+        <p:spPr>
+          <a:xfrm>
+            <a:off x="795528" y="173736"/>
+            <a:ext cx="2377440" cy="292608"/>
+          </a:xfrm>
+          <a:prstGeom prst="rect">
+            <a:avLst/>
+          </a:prstGeom>
+          <a:noFill/>
+        </p:spPr>
+        <p:txBody>
+          <a:bodyPr wrap="square" anchor="t" lIns="0" rIns="0" tIns="0" bIns="0">
+            <a:spAutoFit/>
+          </a:bodyPr>
+          <a:lstStyle/>
+          <a:p>
+            <a:pPr algn="l">
+              <a:lnSpc>
+                <a:spcPct val="100000"/>
+              </a:lnSpc>
+              <a:spcAft>
+                <a:spcPts val="400"/>
+              </a:spcAft>
+            </a:pPr>
+            <a:r>
+              <a:rPr sz="1800" b="1" i="0">
+                <a:solidFill>
+                  <a:srgbClr val="2563EB"/>
+                </a:solidFill>
+                <a:latin typeface="Calibri"/>
+              </a:rPr>
+              <a:t>CostVision</a:t>
+            </a:r>
+          </a:p>
+        </p:txBody>
+      </p:sp>
+      <p:sp>
+        <p:nvSpPr>
+          <p:cNvPr id="5" name="TextBox 4"/>
+          <p:cNvSpPr txBox="1"/>
+          <p:nvPr/>
+        </p:nvSpPr>
+        <p:spPr>
+          <a:xfrm>
+            <a:off x="795528" y="420624"/>
+            <a:ext cx="2560320" cy="201168"/>
+          </a:xfrm>
+          <a:prstGeom prst="rect">
+            <a:avLst/>
+          </a:prstGeom>
+          <a:noFill/>
+        </p:spPr>
+        <p:txBody>
+          <a:bodyPr wrap="square" anchor="t" lIns="0" rIns="0" tIns="0" bIns="0">
+            <a:spAutoFit/>
+          </a:bodyPr>
+          <a:lstStyle/>
+          <a:p>
+            <a:pPr algn="l">
+              <a:lnSpc>
+                <a:spcPct val="100000"/>
+              </a:lnSpc>
+              <a:spcAft>
+                <a:spcPts val="400"/>
+              </a:spcAft>
+            </a:pPr>
+            <a:r>
+              <a:rPr sz="750" b="0" i="0">
+                <a:solidFill>
+                  <a:srgbClr val="64748B"/>
+                </a:solidFill>
+                <a:latin typeface="Calibri"/>
+              </a:rPr>
+              <a:t>AI  COST  INTELLIGENCE</a:t>
+            </a:r>
+          </a:p>
+        </p:txBody>
+      </p:sp>
+      <p:sp>
+        <p:nvSpPr>
+          <p:cNvPr id="6" name="Rectangle 5"/>
+          <p:cNvSpPr/>
+          <p:nvPr/>
+        </p:nvSpPr>
+        <p:spPr>
+          <a:xfrm>
+            <a:off x="0" y="713232"/>
+            <a:ext cx="12191695" cy="27940"/>
+          </a:xfrm>
+          <a:prstGeom prst="rect">
+            <a:avLst/>
+          </a:prstGeom>
+          <a:solidFill>
+            <a:srgbClr val="4F46E5"/>
+          </a:solidFill>
+          <a:ln>
+            <a:noFill/>
+          </a:ln>
+          <a:effectLst/>
+        </p:spPr>
+        <p:style>
+          <a:lnRef idx="1">
+            <a:schemeClr val="accent1"/>
+          </a:lnRef>
+          <a:fillRef idx="3">
+            <a:schemeClr val="accent1"/>
+          </a:fillRef>
+          <a:effectRef idx="2">
+            <a:schemeClr val="accent1"/>
+          </a:effectRef>
+          <a:fontRef idx="minor">
+            <a:schemeClr val="lt1"/>
+          </a:fontRef>
+        </p:style>
+        <p:txBody>
+          <a:bodyPr rtlCol="0" anchor="ctr"/>
+          <a:lstStyle/>
+          <a:p>
+            <a:pPr algn="ctr"/>
+          </a:p>
+        </p:txBody>
+      </p:sp>
+      <p:sp>
+        <p:nvSpPr>
+          <p:cNvPr id="7" name="TextBox 6"/>
+          <p:cNvSpPr txBox="1"/>
+          <p:nvPr/>
+        </p:nvSpPr>
+        <p:spPr>
+          <a:xfrm>
+            <a:off x="411480" y="868680"/>
+            <a:ext cx="10515600" cy="274320"/>
+          </a:xfrm>
+          <a:prstGeom prst="rect">
+            <a:avLst/>
+          </a:prstGeom>
+          <a:noFill/>
+        </p:spPr>
+        <p:txBody>
+          <a:bodyPr wrap="square" anchor="t" lIns="0" rIns="0" tIns="0" bIns="0">
+            <a:spAutoFit/>
+          </a:bodyPr>
+          <a:lstStyle/>
+          <a:p>
+            <a:pPr algn="l">
+              <a:lnSpc>
+                <a:spcPct val="100000"/>
+              </a:lnSpc>
+              <a:spcAft>
+                <a:spcPts val="400"/>
+              </a:spcAft>
+            </a:pPr>
+            <a:r>
+              <a:rPr sz="1100" b="1" i="0">
+                <a:solidFill>
+                  <a:srgbClr val="2563EB"/>
+                </a:solidFill>
+                <a:latin typeface="Calibri"/>
+              </a:rPr>
+              <a:t>BACKUP · STRAIGHT ANSWERS</a:t>
+            </a:r>
+          </a:p>
+        </p:txBody>
+      </p:sp>
+      <p:sp>
+        <p:nvSpPr>
+          <p:cNvPr id="8" name="TextBox 7"/>
+          <p:cNvSpPr txBox="1"/>
+          <p:nvPr/>
+        </p:nvSpPr>
+        <p:spPr>
+          <a:xfrm>
+            <a:off x="411480" y="1115568"/>
+            <a:ext cx="11338560" cy="548640"/>
+          </a:xfrm>
+          <a:prstGeom prst="rect">
+            <a:avLst/>
+          </a:prstGeom>
+          <a:noFill/>
+        </p:spPr>
+        <p:txBody>
+          <a:bodyPr wrap="square" anchor="t" lIns="0" rIns="0" tIns="0" bIns="0">
+            <a:spAutoFit/>
+          </a:bodyPr>
+          <a:lstStyle/>
+          <a:p>
+            <a:pPr algn="l">
+              <a:lnSpc>
+                <a:spcPct val="100000"/>
+              </a:lnSpc>
+              <a:spcAft>
+                <a:spcPts val="400"/>
+              </a:spcAft>
+            </a:pPr>
+            <a:r>
+              <a:rPr sz="2700" b="1" i="0">
+                <a:solidFill>
+                  <a:srgbClr val="0F172A"/>
+                </a:solidFill>
+                <a:latin typeface="Calibri"/>
+              </a:rPr>
+              <a:t>Questions you may be asking</a:t>
+            </a:r>
+          </a:p>
+        </p:txBody>
+      </p:sp>
+      <p:sp>
+        <p:nvSpPr>
+          <p:cNvPr id="9" name="Rounded Rectangle 8"/>
+          <p:cNvSpPr/>
+          <p:nvPr/>
+        </p:nvSpPr>
+        <p:spPr>
+          <a:xfrm>
+            <a:off x="411480" y="1828800"/>
+            <a:ext cx="11384280" cy="786384"/>
+          </a:xfrm>
+          <a:prstGeom prst="roundRect">
+            <a:avLst>
+              <a:gd name="adj" fmla="val 10000"/>
+            </a:avLst>
+          </a:prstGeom>
+          <a:solidFill>
+            <a:srgbClr val="F1F5F9"/>
+          </a:solidFill>
+          <a:ln>
+            <a:noFill/>
+          </a:ln>
+          <a:effectLst/>
+        </p:spPr>
+        <p:style>
+          <a:lnRef idx="1">
+            <a:schemeClr val="accent1"/>
+          </a:lnRef>
+          <a:fillRef idx="3">
+            <a:schemeClr val="accent1"/>
+          </a:fillRef>
+          <a:effectRef idx="2">
+            <a:schemeClr val="accent1"/>
+          </a:effectRef>
+          <a:fontRef idx="minor">
+            <a:schemeClr val="lt1"/>
+          </a:fontRef>
+        </p:style>
+        <p:txBody>
+          <a:bodyPr rtlCol="0" anchor="ctr"/>
+          <a:lstStyle/>
+          <a:p>
+            <a:pPr algn="ctr"/>
+          </a:p>
+        </p:txBody>
+      </p:sp>
+      <p:sp>
+        <p:nvSpPr>
+          <p:cNvPr id="10" name="TextBox 9"/>
+          <p:cNvSpPr txBox="1"/>
+          <p:nvPr/>
+        </p:nvSpPr>
+        <p:spPr>
+          <a:xfrm>
+            <a:off x="731520" y="1920240"/>
+            <a:ext cx="3566160" cy="640080"/>
+          </a:xfrm>
+          <a:prstGeom prst="rect">
+            <a:avLst/>
+          </a:prstGeom>
+          <a:noFill/>
+        </p:spPr>
+        <p:txBody>
+          <a:bodyPr wrap="square" anchor="t" lIns="0" rIns="0" tIns="0" bIns="0">
+            <a:spAutoFit/>
+          </a:bodyPr>
+          <a:lstStyle/>
+          <a:p>
+            <a:pPr algn="l">
+              <a:lnSpc>
+                <a:spcPct val="108000"/>
+              </a:lnSpc>
+              <a:spcAft>
+                <a:spcPts val="400"/>
+              </a:spcAft>
+            </a:pPr>
+            <a:r>
+              <a:rPr sz="1250" b="1" i="0">
+                <a:solidFill>
+                  <a:srgbClr val="2563EB"/>
+                </a:solidFill>
+                <a:latin typeface="Calibri"/>
+              </a:rPr>
+              <a:t>Why not just buy aPriori?</a:t>
+            </a:r>
+          </a:p>
+        </p:txBody>
+      </p:sp>
+      <p:sp>
+        <p:nvSpPr>
+          <p:cNvPr id="11" name="TextBox 10"/>
+          <p:cNvSpPr txBox="1"/>
+          <p:nvPr/>
+        </p:nvSpPr>
+        <p:spPr>
+          <a:xfrm>
+            <a:off x="4480560" y="1920240"/>
+            <a:ext cx="7132320" cy="640080"/>
+          </a:xfrm>
+          <a:prstGeom prst="rect">
+            <a:avLst/>
+          </a:prstGeom>
+          <a:noFill/>
+        </p:spPr>
+        <p:txBody>
+          <a:bodyPr wrap="square" anchor="t" lIns="0" rIns="0" tIns="0" bIns="0">
+            <a:spAutoFit/>
+          </a:bodyPr>
+          <a:lstStyle/>
+          <a:p>
+            <a:pPr algn="l">
+              <a:lnSpc>
+                <a:spcPct val="110000"/>
+              </a:lnSpc>
+              <a:spcAft>
+                <a:spcPts val="400"/>
+              </a:spcAft>
+            </a:pPr>
+            <a:r>
+              <a:rPr sz="1100" b="0" i="0">
+                <a:solidFill>
+                  <a:srgbClr val="334155"/>
+                </a:solidFill>
+                <a:latin typeface="Calibri"/>
+              </a:rPr>
+              <a:t>A SaaS suite means our CAD and rates live in a vendor cloud, it cannot learn from our quote history, and it costs six figures every year. CostVision is on-prem, self-learning, and our IP.</a:t>
+            </a:r>
+          </a:p>
+        </p:txBody>
+      </p:sp>
+      <p:sp>
+        <p:nvSpPr>
+          <p:cNvPr id="12" name="Rounded Rectangle 11"/>
+          <p:cNvSpPr/>
+          <p:nvPr/>
+        </p:nvSpPr>
+        <p:spPr>
+          <a:xfrm>
+            <a:off x="411480" y="2724912"/>
+            <a:ext cx="11384280" cy="786384"/>
+          </a:xfrm>
+          <a:prstGeom prst="roundRect">
+            <a:avLst>
+              <a:gd name="adj" fmla="val 10000"/>
+            </a:avLst>
+          </a:prstGeom>
+          <a:solidFill>
+            <a:srgbClr val="FFFFFF"/>
+          </a:solidFill>
+          <a:ln>
+            <a:noFill/>
+          </a:ln>
+          <a:effectLst/>
+        </p:spPr>
+        <p:style>
+          <a:lnRef idx="1">
+            <a:schemeClr val="accent1"/>
+          </a:lnRef>
+          <a:fillRef idx="3">
+            <a:schemeClr val="accent1"/>
+          </a:fillRef>
+          <a:effectRef idx="2">
+            <a:schemeClr val="accent1"/>
+          </a:effectRef>
+          <a:fontRef idx="minor">
+            <a:schemeClr val="lt1"/>
+          </a:fontRef>
+        </p:style>
+        <p:txBody>
+          <a:bodyPr rtlCol="0" anchor="ctr"/>
+          <a:lstStyle/>
+          <a:p>
+            <a:pPr algn="ctr"/>
+          </a:p>
+        </p:txBody>
+      </p:sp>
+      <p:sp>
+        <p:nvSpPr>
+          <p:cNvPr id="13" name="TextBox 12"/>
+          <p:cNvSpPr txBox="1"/>
+          <p:nvPr/>
+        </p:nvSpPr>
+        <p:spPr>
+          <a:xfrm>
+            <a:off x="731520" y="2816352"/>
+            <a:ext cx="3566160" cy="640080"/>
+          </a:xfrm>
+          <a:prstGeom prst="rect">
+            <a:avLst/>
+          </a:prstGeom>
+          <a:noFill/>
+        </p:spPr>
+        <p:txBody>
+          <a:bodyPr wrap="square" anchor="t" lIns="0" rIns="0" tIns="0" bIns="0">
+            <a:spAutoFit/>
+          </a:bodyPr>
+          <a:lstStyle/>
+          <a:p>
+            <a:pPr algn="l">
+              <a:lnSpc>
+                <a:spcPct val="108000"/>
+              </a:lnSpc>
+              <a:spcAft>
+                <a:spcPts val="400"/>
+              </a:spcAft>
+            </a:pPr>
+            <a:r>
+              <a:rPr sz="1250" b="1" i="0">
+                <a:solidFill>
+                  <a:srgbClr val="2563EB"/>
+                </a:solidFill>
+                <a:latin typeface="Calibri"/>
+              </a:rPr>
+              <a:t>Is our data training a public AI?</a:t>
+            </a:r>
+          </a:p>
+        </p:txBody>
+      </p:sp>
+      <p:sp>
+        <p:nvSpPr>
+          <p:cNvPr id="14" name="TextBox 13"/>
+          <p:cNvSpPr txBox="1"/>
+          <p:nvPr/>
+        </p:nvSpPr>
+        <p:spPr>
+          <a:xfrm>
+            <a:off x="4480560" y="2816352"/>
+            <a:ext cx="7132320" cy="640080"/>
+          </a:xfrm>
+          <a:prstGeom prst="rect">
+            <a:avLst/>
+          </a:prstGeom>
+          <a:noFill/>
+        </p:spPr>
+        <p:txBody>
+          <a:bodyPr wrap="square" anchor="t" lIns="0" rIns="0" tIns="0" bIns="0">
+            <a:spAutoFit/>
+          </a:bodyPr>
+          <a:lstStyle/>
+          <a:p>
+            <a:pPr algn="l">
+              <a:lnSpc>
+                <a:spcPct val="110000"/>
+              </a:lnSpc>
+              <a:spcAft>
+                <a:spcPts val="400"/>
+              </a:spcAft>
+            </a:pPr>
+            <a:r>
+              <a:rPr sz="1100" b="0" i="0">
+                <a:solidFill>
+                  <a:srgbClr val="334155"/>
+                </a:solidFill>
+                <a:latin typeface="Calibri"/>
+              </a:rPr>
+              <a:t>No. AI calls run zero-retention in our own cloud tenancy (Option B) — and in air-gapped mode there are provably no external calls at all. Nothing is ever used to train public models.</a:t>
+            </a:r>
+          </a:p>
+        </p:txBody>
+      </p:sp>
+      <p:sp>
+        <p:nvSpPr>
+          <p:cNvPr id="15" name="Rounded Rectangle 14"/>
+          <p:cNvSpPr/>
+          <p:nvPr/>
+        </p:nvSpPr>
+        <p:spPr>
+          <a:xfrm>
+            <a:off x="411480" y="3621024"/>
+            <a:ext cx="11384280" cy="786384"/>
+          </a:xfrm>
+          <a:prstGeom prst="roundRect">
+            <a:avLst>
+              <a:gd name="adj" fmla="val 10000"/>
+            </a:avLst>
+          </a:prstGeom>
+          <a:solidFill>
+            <a:srgbClr val="F1F5F9"/>
+          </a:solidFill>
+          <a:ln>
+            <a:noFill/>
+          </a:ln>
+          <a:effectLst/>
+        </p:spPr>
+        <p:style>
+          <a:lnRef idx="1">
+            <a:schemeClr val="accent1"/>
+          </a:lnRef>
+          <a:fillRef idx="3">
+            <a:schemeClr val="accent1"/>
+          </a:fillRef>
+          <a:effectRef idx="2">
+            <a:schemeClr val="accent1"/>
+          </a:effectRef>
+          <a:fontRef idx="minor">
+            <a:schemeClr val="lt1"/>
+          </a:fontRef>
+        </p:style>
+        <p:txBody>
+          <a:bodyPr rtlCol="0" anchor="ctr"/>
+          <a:lstStyle/>
+          <a:p>
+            <a:pPr algn="ctr"/>
+          </a:p>
+        </p:txBody>
+      </p:sp>
+      <p:sp>
+        <p:nvSpPr>
+          <p:cNvPr id="16" name="TextBox 15"/>
+          <p:cNvSpPr txBox="1"/>
+          <p:nvPr/>
+        </p:nvSpPr>
+        <p:spPr>
+          <a:xfrm>
+            <a:off x="731520" y="3712464"/>
+            <a:ext cx="3566160" cy="640080"/>
+          </a:xfrm>
+          <a:prstGeom prst="rect">
+            <a:avLst/>
+          </a:prstGeom>
+          <a:noFill/>
+        </p:spPr>
+        <p:txBody>
+          <a:bodyPr wrap="square" anchor="t" lIns="0" rIns="0" tIns="0" bIns="0">
+            <a:spAutoFit/>
+          </a:bodyPr>
+          <a:lstStyle/>
+          <a:p>
+            <a:pPr algn="l">
+              <a:lnSpc>
+                <a:spcPct val="108000"/>
+              </a:lnSpc>
+              <a:spcAft>
+                <a:spcPts val="400"/>
+              </a:spcAft>
+            </a:pPr>
+            <a:r>
+              <a:rPr sz="1250" b="1" i="0">
+                <a:solidFill>
+                  <a:srgbClr val="2563EB"/>
+                </a:solidFill>
+                <a:latin typeface="Calibri"/>
+              </a:rPr>
+              <a:t>What if the key developer leaves?</a:t>
+            </a:r>
+          </a:p>
+        </p:txBody>
+      </p:sp>
+      <p:sp>
+        <p:nvSpPr>
+          <p:cNvPr id="17" name="TextBox 16"/>
+          <p:cNvSpPr txBox="1"/>
+          <p:nvPr/>
+        </p:nvSpPr>
+        <p:spPr>
+          <a:xfrm>
+            <a:off x="4480560" y="3712464"/>
+            <a:ext cx="7132320" cy="640080"/>
+          </a:xfrm>
+          <a:prstGeom prst="rect">
+            <a:avLst/>
+          </a:prstGeom>
+          <a:noFill/>
+        </p:spPr>
+        <p:txBody>
+          <a:bodyPr wrap="square" anchor="t" lIns="0" rIns="0" tIns="0" bIns="0">
+            <a:spAutoFit/>
+          </a:bodyPr>
+          <a:lstStyle/>
+          <a:p>
+            <a:pPr algn="l">
+              <a:lnSpc>
+                <a:spcPct val="110000"/>
+              </a:lnSpc>
+              <a:spcAft>
+                <a:spcPts val="400"/>
+              </a:spcAft>
+            </a:pPr>
+            <a:r>
+              <a:rPr sz="1100" b="0" i="0">
+                <a:solidFill>
+                  <a:srgbClr val="334155"/>
+                </a:solidFill>
+                <a:latin typeface="Calibri"/>
+              </a:rPr>
+              <a:t>793 automated tests define how everything must behave, the architecture is documented in writing, and Phase 4 trains a named CAPEE-side maintainer.</a:t>
+            </a:r>
+          </a:p>
+        </p:txBody>
+      </p:sp>
+      <p:sp>
+        <p:nvSpPr>
+          <p:cNvPr id="18" name="Rounded Rectangle 17"/>
+          <p:cNvSpPr/>
+          <p:nvPr/>
+        </p:nvSpPr>
+        <p:spPr>
+          <a:xfrm>
+            <a:off x="411480" y="4517136"/>
+            <a:ext cx="11384280" cy="786384"/>
+          </a:xfrm>
+          <a:prstGeom prst="roundRect">
+            <a:avLst>
+              <a:gd name="adj" fmla="val 10000"/>
+            </a:avLst>
+          </a:prstGeom>
+          <a:solidFill>
+            <a:srgbClr val="FFFFFF"/>
+          </a:solidFill>
+          <a:ln>
+            <a:noFill/>
+          </a:ln>
+          <a:effectLst/>
+        </p:spPr>
+        <p:style>
+          <a:lnRef idx="1">
+            <a:schemeClr val="accent1"/>
+          </a:lnRef>
+          <a:fillRef idx="3">
+            <a:schemeClr val="accent1"/>
+          </a:fillRef>
+          <a:effectRef idx="2">
+            <a:schemeClr val="accent1"/>
+          </a:effectRef>
+          <a:fontRef idx="minor">
+            <a:schemeClr val="lt1"/>
+          </a:fontRef>
+        </p:style>
+        <p:txBody>
+          <a:bodyPr rtlCol="0" anchor="ctr"/>
+          <a:lstStyle/>
+          <a:p>
+            <a:pPr algn="ctr"/>
+          </a:p>
+        </p:txBody>
+      </p:sp>
+      <p:sp>
+        <p:nvSpPr>
+          <p:cNvPr id="19" name="TextBox 18"/>
+          <p:cNvSpPr txBox="1"/>
+          <p:nvPr/>
+        </p:nvSpPr>
+        <p:spPr>
+          <a:xfrm>
+            <a:off x="731520" y="4608576"/>
+            <a:ext cx="3566160" cy="640080"/>
+          </a:xfrm>
+          <a:prstGeom prst="rect">
+            <a:avLst/>
+          </a:prstGeom>
+          <a:noFill/>
+        </p:spPr>
+        <p:txBody>
+          <a:bodyPr wrap="square" anchor="t" lIns="0" rIns="0" tIns="0" bIns="0">
+            <a:spAutoFit/>
+          </a:bodyPr>
+          <a:lstStyle/>
+          <a:p>
+            <a:pPr algn="l">
+              <a:lnSpc>
+                <a:spcPct val="108000"/>
+              </a:lnSpc>
+              <a:spcAft>
+                <a:spcPts val="400"/>
+              </a:spcAft>
+            </a:pPr>
+            <a:r>
+              <a:rPr sz="1250" b="1" i="0">
+                <a:solidFill>
+                  <a:srgbClr val="2563EB"/>
+                </a:solidFill>
+                <a:latin typeface="Calibri"/>
+              </a:rPr>
+              <a:t>What does it cost to run?</a:t>
+            </a:r>
+          </a:p>
+        </p:txBody>
+      </p:sp>
+      <p:sp>
+        <p:nvSpPr>
+          <p:cNvPr id="20" name="TextBox 19"/>
+          <p:cNvSpPr txBox="1"/>
+          <p:nvPr/>
+        </p:nvSpPr>
+        <p:spPr>
+          <a:xfrm>
+            <a:off x="4480560" y="4608576"/>
+            <a:ext cx="7132320" cy="640080"/>
+          </a:xfrm>
+          <a:prstGeom prst="rect">
+            <a:avLst/>
+          </a:prstGeom>
+          <a:noFill/>
+        </p:spPr>
+        <p:txBody>
+          <a:bodyPr wrap="square" anchor="t" lIns="0" rIns="0" tIns="0" bIns="0">
+            <a:spAutoFit/>
+          </a:bodyPr>
+          <a:lstStyle/>
+          <a:p>
+            <a:pPr algn="l">
+              <a:lnSpc>
+                <a:spcPct val="110000"/>
+              </a:lnSpc>
+              <a:spcAft>
+                <a:spcPts val="400"/>
+              </a:spcAft>
+            </a:pPr>
+            <a:r>
+              <a:rPr sz="1100" b="0" i="0">
+                <a:solidFill>
+                  <a:srgbClr val="334155"/>
+                </a:solidFill>
+                <a:latin typeface="Calibri"/>
+              </a:rPr>
+              <a:t>One VM, a standard corporate database, and pay-per-use AI in our tenancy. No licences, no per-seat fees.</a:t>
+            </a:r>
+          </a:p>
+        </p:txBody>
+      </p:sp>
+      <p:sp>
+        <p:nvSpPr>
+          <p:cNvPr id="21" name="Rounded Rectangle 20"/>
+          <p:cNvSpPr/>
+          <p:nvPr/>
+        </p:nvSpPr>
+        <p:spPr>
+          <a:xfrm>
+            <a:off x="411480" y="5413248"/>
+            <a:ext cx="11384280" cy="786384"/>
+          </a:xfrm>
+          <a:prstGeom prst="roundRect">
+            <a:avLst>
+              <a:gd name="adj" fmla="val 10000"/>
+            </a:avLst>
+          </a:prstGeom>
+          <a:solidFill>
+            <a:srgbClr val="F1F5F9"/>
+          </a:solidFill>
+          <a:ln>
+            <a:noFill/>
+          </a:ln>
+          <a:effectLst/>
+        </p:spPr>
+        <p:style>
+          <a:lnRef idx="1">
+            <a:schemeClr val="accent1"/>
+          </a:lnRef>
+          <a:fillRef idx="3">
+            <a:schemeClr val="accent1"/>
+          </a:fillRef>
+          <a:effectRef idx="2">
+            <a:schemeClr val="accent1"/>
+          </a:effectRef>
+          <a:fontRef idx="minor">
+            <a:schemeClr val="lt1"/>
+          </a:fontRef>
+        </p:style>
+        <p:txBody>
+          <a:bodyPr rtlCol="0" anchor="ctr"/>
+          <a:lstStyle/>
+          <a:p>
+            <a:pPr algn="ctr"/>
+          </a:p>
+        </p:txBody>
+      </p:sp>
+      <p:sp>
+        <p:nvSpPr>
+          <p:cNvPr id="22" name="TextBox 21"/>
+          <p:cNvSpPr txBox="1"/>
+          <p:nvPr/>
+        </p:nvSpPr>
+        <p:spPr>
+          <a:xfrm>
+            <a:off x="731520" y="5504688"/>
+            <a:ext cx="3566160" cy="640080"/>
+          </a:xfrm>
+          <a:prstGeom prst="rect">
+            <a:avLst/>
+          </a:prstGeom>
+          <a:noFill/>
+        </p:spPr>
+        <p:txBody>
+          <a:bodyPr wrap="square" anchor="t" lIns="0" rIns="0" tIns="0" bIns="0">
+            <a:spAutoFit/>
+          </a:bodyPr>
+          <a:lstStyle/>
+          <a:p>
+            <a:pPr algn="l">
+              <a:lnSpc>
+                <a:spcPct val="108000"/>
+              </a:lnSpc>
+              <a:spcAft>
+                <a:spcPts val="400"/>
+              </a:spcAft>
+            </a:pPr>
+            <a:r>
+              <a:rPr sz="1250" b="1" i="0">
+                <a:solidFill>
+                  <a:srgbClr val="2563EB"/>
+                </a:solidFill>
+                <a:latin typeface="Calibri"/>
+              </a:rPr>
+              <a:t>How do we know the numbers are right?</a:t>
+            </a:r>
+          </a:p>
+        </p:txBody>
+      </p:sp>
+      <p:sp>
+        <p:nvSpPr>
+          <p:cNvPr id="23" name="TextBox 22"/>
+          <p:cNvSpPr txBox="1"/>
+          <p:nvPr/>
+        </p:nvSpPr>
+        <p:spPr>
+          <a:xfrm>
+            <a:off x="4480560" y="5504688"/>
+            <a:ext cx="7132320" cy="640080"/>
+          </a:xfrm>
+          <a:prstGeom prst="rect">
+            <a:avLst/>
+          </a:prstGeom>
+          <a:noFill/>
+        </p:spPr>
+        <p:txBody>
+          <a:bodyPr wrap="square" anchor="t" lIns="0" rIns="0" tIns="0" bIns="0">
+            <a:spAutoFit/>
+          </a:bodyPr>
+          <a:lstStyle/>
+          <a:p>
+            <a:pPr algn="l">
+              <a:lnSpc>
+                <a:spcPct val="110000"/>
+              </a:lnSpc>
+              <a:spcAft>
+                <a:spcPts val="400"/>
+              </a:spcAft>
+            </a:pPr>
+            <a:r>
+              <a:rPr sz="1100" b="0" i="0">
+                <a:solidFill>
+                  <a:srgbClr val="334155"/>
+                </a:solidFill>
+                <a:latin typeface="Calibri"/>
+              </a:rPr>
+              <a:t>Physics-based cost build-ups on OUR uploaded rates, calibrated against OUR real PO prices — and the accuracy dashboard tracks the error openly, part by part.</a:t>
             </a:r>
           </a:p>
         </p:txBody>

</xml_diff>

<commit_message>
Blueprint deck: bold highlighted IP-ownership banner on business-case slide
The data-ownership statement gets its own full-width green banner on
slide 19, bold: built in-house — code, rate library and knowledge base are
entirely our IP; no vendor owns any part of it. Cost/return panels tightened
to make room.

Co-Authored-By: Claude Fable 5 <noreply@anthropic.com>
Claude-Session: https://claude.ai/code/session_0142L4rKS2AV8rxQTDWMs7dy
</commit_message>
<xml_diff>
--- a/CostVision-Implementation-Blueprint.pptx
+++ b/CostVision-Implementation-Blueprint.pptx
@@ -16644,7 +16644,7 @@
         <p:spPr>
           <a:xfrm>
             <a:off x="411480" y="1828800"/>
-            <a:ext cx="5486400" cy="3520440"/>
+            <a:ext cx="5486400" cy="3200400"/>
           </a:xfrm>
           <a:prstGeom prst="roundRect">
             <a:avLst>
@@ -16689,7 +16689,7 @@
         </p:nvSpPr>
         <p:spPr>
           <a:xfrm>
-            <a:off x="685800" y="2011680"/>
+            <a:off x="685800" y="1993392"/>
             <a:ext cx="4937760" cy="365760"/>
           </a:xfrm>
           <a:prstGeom prst="rect">
@@ -16731,8 +16731,8 @@
         </p:nvSpPr>
         <p:spPr>
           <a:xfrm>
-            <a:off x="685800" y="2487168"/>
-            <a:ext cx="5029200" cy="685800"/>
+            <a:off x="685800" y="2432304"/>
+            <a:ext cx="5029200" cy="640080"/>
           </a:xfrm>
           <a:prstGeom prst="rect">
             <a:avLst/>
@@ -16782,8 +16782,8 @@
         </p:nvSpPr>
         <p:spPr>
           <a:xfrm>
-            <a:off x="685800" y="3200400"/>
-            <a:ext cx="5029200" cy="685800"/>
+            <a:off x="685800" y="3090672"/>
+            <a:ext cx="5029200" cy="640080"/>
           </a:xfrm>
           <a:prstGeom prst="rect">
             <a:avLst/>
@@ -16833,8 +16833,8 @@
         </p:nvSpPr>
         <p:spPr>
           <a:xfrm>
-            <a:off x="685800" y="3913632"/>
-            <a:ext cx="5029200" cy="685800"/>
+            <a:off x="685800" y="3749039"/>
+            <a:ext cx="5029200" cy="640080"/>
           </a:xfrm>
           <a:prstGeom prst="rect">
             <a:avLst/>
@@ -16884,8 +16884,8 @@
         </p:nvSpPr>
         <p:spPr>
           <a:xfrm>
-            <a:off x="685800" y="4626864"/>
-            <a:ext cx="5029200" cy="685800"/>
+            <a:off x="685800" y="4407408"/>
+            <a:ext cx="5029200" cy="640080"/>
           </a:xfrm>
           <a:prstGeom prst="rect">
             <a:avLst/>
@@ -16922,7 +16922,7 @@
                 </a:solidFill>
                 <a:latin typeface="Calibri"/>
               </a:rPr>
-              <a:t>£0 — built in-house. The code, rate library and knowledge base are OUR IP</a:t>
+              <a:t>£0 — built in-house, nothing to buy or renew</a:t>
             </a:r>
           </a:p>
         </p:txBody>
@@ -16936,7 +16936,7 @@
         <p:spPr>
           <a:xfrm>
             <a:off x="6263640" y="1828800"/>
-            <a:ext cx="5532120" cy="3520440"/>
+            <a:ext cx="5532120" cy="3200400"/>
           </a:xfrm>
           <a:prstGeom prst="roundRect">
             <a:avLst>
@@ -16981,7 +16981,7 @@
         </p:nvSpPr>
         <p:spPr>
           <a:xfrm>
-            <a:off x="6537960" y="2011680"/>
+            <a:off x="6537960" y="1993392"/>
             <a:ext cx="4937760" cy="365760"/>
           </a:xfrm>
           <a:prstGeom prst="rect">
@@ -17023,8 +17023,8 @@
         </p:nvSpPr>
         <p:spPr>
           <a:xfrm>
-            <a:off x="6537960" y="2487168"/>
-            <a:ext cx="5029200" cy="685800"/>
+            <a:off x="6537960" y="2432304"/>
+            <a:ext cx="5029200" cy="640080"/>
           </a:xfrm>
           <a:prstGeom prst="rect">
             <a:avLst/>
@@ -17074,8 +17074,8 @@
         </p:nvSpPr>
         <p:spPr>
           <a:xfrm>
-            <a:off x="6537960" y="3200400"/>
-            <a:ext cx="5029200" cy="685800"/>
+            <a:off x="6537960" y="3090672"/>
+            <a:ext cx="5029200" cy="640080"/>
           </a:xfrm>
           <a:prstGeom prst="rect">
             <a:avLst/>
@@ -17125,8 +17125,8 @@
         </p:nvSpPr>
         <p:spPr>
           <a:xfrm>
-            <a:off x="6537960" y="3913632"/>
-            <a:ext cx="5029200" cy="685800"/>
+            <a:off x="6537960" y="3749039"/>
+            <a:ext cx="5029200" cy="640080"/>
           </a:xfrm>
           <a:prstGeom prst="rect">
             <a:avLst/>
@@ -17176,8 +17176,8 @@
         </p:nvSpPr>
         <p:spPr>
           <a:xfrm>
-            <a:off x="6537960" y="4626864"/>
-            <a:ext cx="5029200" cy="685800"/>
+            <a:off x="6537960" y="4407408"/>
+            <a:ext cx="5029200" cy="640080"/>
           </a:xfrm>
           <a:prstGeom prst="rect">
             <a:avLst/>
@@ -17227,8 +17227,149 @@
         </p:nvSpPr>
         <p:spPr>
           <a:xfrm>
-            <a:off x="411480" y="5577840"/>
-            <a:ext cx="11384280" cy="868680"/>
+            <a:off x="411480" y="5193792"/>
+            <a:ext cx="11384280" cy="566928"/>
+          </a:xfrm>
+          <a:prstGeom prst="roundRect">
+            <a:avLst>
+              <a:gd name="adj" fmla="val 12000"/>
+            </a:avLst>
+          </a:prstGeom>
+          <a:solidFill>
+            <a:srgbClr val="ECFDF5"/>
+          </a:solidFill>
+          <a:ln>
+            <a:noFill/>
+          </a:ln>
+          <a:effectLst/>
+        </p:spPr>
+        <p:style>
+          <a:lnRef idx="1">
+            <a:schemeClr val="accent1"/>
+          </a:lnRef>
+          <a:fillRef idx="3">
+            <a:schemeClr val="accent1"/>
+          </a:fillRef>
+          <a:effectRef idx="2">
+            <a:schemeClr val="accent1"/>
+          </a:effectRef>
+          <a:fontRef idx="minor">
+            <a:schemeClr val="lt1"/>
+          </a:fontRef>
+        </p:style>
+        <p:txBody>
+          <a:bodyPr rtlCol="0" anchor="ctr"/>
+          <a:lstStyle/>
+          <a:p>
+            <a:pPr algn="ctr"/>
+          </a:p>
+        </p:txBody>
+      </p:sp>
+      <p:sp>
+        <p:nvSpPr>
+          <p:cNvPr id="22" name="Rectangle 21"/>
+          <p:cNvSpPr/>
+          <p:nvPr/>
+        </p:nvSpPr>
+        <p:spPr>
+          <a:xfrm>
+            <a:off x="411480" y="5193792"/>
+            <a:ext cx="82296" cy="566928"/>
+          </a:xfrm>
+          <a:prstGeom prst="rect">
+            <a:avLst/>
+          </a:prstGeom>
+          <a:solidFill>
+            <a:srgbClr val="059669"/>
+          </a:solidFill>
+          <a:ln>
+            <a:noFill/>
+          </a:ln>
+          <a:effectLst/>
+        </p:spPr>
+        <p:style>
+          <a:lnRef idx="1">
+            <a:schemeClr val="accent1"/>
+          </a:lnRef>
+          <a:fillRef idx="3">
+            <a:schemeClr val="accent1"/>
+          </a:fillRef>
+          <a:effectRef idx="2">
+            <a:schemeClr val="accent1"/>
+          </a:effectRef>
+          <a:fontRef idx="minor">
+            <a:schemeClr val="lt1"/>
+          </a:fontRef>
+        </p:style>
+        <p:txBody>
+          <a:bodyPr rtlCol="0" anchor="ctr"/>
+          <a:lstStyle/>
+          <a:p>
+            <a:pPr algn="ctr"/>
+          </a:p>
+        </p:txBody>
+      </p:sp>
+      <p:sp>
+        <p:nvSpPr>
+          <p:cNvPr id="23" name="TextBox 22"/>
+          <p:cNvSpPr txBox="1"/>
+          <p:nvPr/>
+        </p:nvSpPr>
+        <p:spPr>
+          <a:xfrm>
+            <a:off x="731520" y="5330952"/>
+            <a:ext cx="10881360" cy="365760"/>
+          </a:xfrm>
+          <a:prstGeom prst="rect">
+            <a:avLst/>
+          </a:prstGeom>
+          <a:noFill/>
+        </p:spPr>
+        <p:txBody>
+          <a:bodyPr wrap="square" anchor="t" lIns="0" rIns="0" tIns="0" bIns="0">
+            <a:spAutoFit/>
+          </a:bodyPr>
+          <a:lstStyle/>
+          <a:p>
+            <a:pPr algn="l">
+              <a:lnSpc>
+                <a:spcPct val="100000"/>
+              </a:lnSpc>
+              <a:spcAft>
+                <a:spcPts val="400"/>
+              </a:spcAft>
+            </a:pPr>
+            <a:r>
+              <a:rPr sz="1350" b="1" i="0">
+                <a:solidFill>
+                  <a:srgbClr val="059669"/>
+                </a:solidFill>
+                <a:latin typeface="Calibri"/>
+              </a:rPr>
+              <a:t>OUR IP:  </a:t>
+            </a:r>
+            <a:r>
+              <a:rPr sz="1350" b="1" i="0">
+                <a:solidFill>
+                  <a:srgbClr val="0F172A"/>
+                </a:solidFill>
+                <a:latin typeface="Calibri"/>
+              </a:rPr>
+              <a:t>built in-house — the code, the rate library and the knowledge base are entirely our intellectual property. No vendor owns any part of it.</a:t>
+            </a:r>
+          </a:p>
+        </p:txBody>
+      </p:sp>
+      <p:sp>
+        <p:nvSpPr>
+          <p:cNvPr id="24" name="Rounded Rectangle 23"/>
+          <p:cNvSpPr/>
+          <p:nvPr/>
+        </p:nvSpPr>
+        <p:spPr>
+          <a:xfrm>
+            <a:off x="411480" y="5888736"/>
+            <a:ext cx="11384280" cy="777240"/>
           </a:xfrm>
           <a:prstGeom prst="roundRect">
             <a:avLst>
@@ -17267,14 +17408,14 @@
       </p:sp>
       <p:sp>
         <p:nvSpPr>
-          <p:cNvPr id="22" name="TextBox 21"/>
+          <p:cNvPr id="25" name="TextBox 24"/>
           <p:cNvSpPr txBox="1"/>
           <p:nvPr/>
         </p:nvSpPr>
         <p:spPr>
           <a:xfrm>
-            <a:off x="685800" y="5705856"/>
-            <a:ext cx="10881360" cy="640080"/>
+            <a:off x="685800" y="5989320"/>
+            <a:ext cx="10881360" cy="594360"/>
           </a:xfrm>
           <a:prstGeom prst="rect">
             <a:avLst/>

</xml_diff>

<commit_message>
Presentations: refresh Implementation Blueprint with latest data + features
Update the Implementation Blueprint (Deck 4) to the latest figures and the
newest agentic capabilities. Speaker notes were already humanised throughout;
this refreshes the data and the "latest intelligence" slide.

- Test count 813 -> 1,005 automated tests (5 places: exec summary, risk,
  backup stat card, Q&A)
- "Latest intelligence" slide grown from five to six upgrades: adds the
  self-audit & guardrails row (proven on five real automotive CAD parts,
  fuel tank £217 -> £25) and a learn-from-actuals calibration/drift row;
  row geometry compressed to fit six without overflow
- Notes on that slide extended to cover universal machine-sizing and the
  CI-verified CAD container — both deployment-relevant to this blueprint

Co-Authored-By: Claude Opus 4.8 <noreply@anthropic.com>
Claude-Session: https://claude.ai/code/session_0142L4rKS2AV8rxQTDWMs7dy
</commit_message>
<xml_diff>
--- a/CostVision-Implementation-Blueprint.pptx
+++ b/CostVision-Implementation-Blueprint.pptx
@@ -2146,7 +2146,7 @@
           <a:lstStyle/>
           <a:p>
             <a:r>
-              <a:t>One slide on what's newest, because it directly strengthens the security-and-defensibility case this deck makes. Five upgrades shipped in 2026, all built and tested. Conformal confidence gives an uncertainty band with an actual coverage guarantee from our own logged quotes — a number a buyer can defend. The negotiation coach names the commodity driving a part's cost and writes the counter-argument for the buyer. The autonomous agent now learns which findings actually convert into savings and prioritises the money we can really recover. The what-if engine answers 'if a commodity moves, what happens' for one part or the whole portfolio, as a defensible conditional rather than a forecast. And the principle underneath all of it: everything stays glass-box — every learned number is auditable, nothing is a black box. That is the opposite of how the competitors work, and it's what makes our numbers usable in a real negotiation.</a:t>
+              <a:t>One slide on what's newest, because it directly strengthens the security-and-defensibility case this deck makes. Six upgrades shipped in 2026, all built and tested. The one I'd start with is the self-audit: a deterministic layer that re-checks every single estimate against a list of mistakes we've actually seen, and corrects them within bounds — and I can prove it, because we ran it on five real automotive CAD parts and it caught every one, a fuel tank alone falling from two hundred and seventeen pounds to twenty-five. The tool now also learns from your own logged quotes, building per-segment calibration and watching for drift, so it gets tighter on your parts over time. Alongside those, the machine-sizing that used to be hard-coded is now universal across commodities. The negotiation coach names the commodity driving a cost and writes the buyer's counter-argument; the autonomous agent prioritises the savings we can really recover; and the what-if engine answers 'if a commodity moves, what happens' as a defensible conditional. Underneath all of it, everything stays glass-box — every learned number is auditable, nothing is a black box — and the whole thing, CAD engine included, ships in a container whose build is verified in our CI pipeline. That is exactly the combination — checked, learned-from-data, and auditable — that makes these numbers safe to deploy and defend.</a:t>
             </a:r>
           </a:p>
         </p:txBody>
@@ -13208,7 +13208,7 @@
                 </a:solidFill>
                 <a:latin typeface="Calibri"/>
               </a:rPr>
-              <a:t>813 automated tests, written architecture docs, and a named CAPEE-side maintainer trained during Phase 4.</a:t>
+              <a:t>1,005 automated tests, written architecture docs, and a named CAPEE-side maintainer trained during Phase 4.</a:t>
             </a:r>
           </a:p>
         </p:txBody>
@@ -18659,7 +18659,7 @@
                 </a:solidFill>
                 <a:latin typeface="Calibri"/>
               </a:rPr>
-              <a:t>The tool is built, tested (813 automated tests) and proven on live runs — the value is waiting on deployment, not development.</a:t>
+              <a:t>The tool is built, tested (1,005 automated tests) and proven on live runs — the value is waiting on deployment, not development.</a:t>
             </a:r>
           </a:p>
         </p:txBody>
@@ -20853,7 +20853,7 @@
                 </a:solidFill>
                 <a:latin typeface="Calibri"/>
               </a:rPr>
-              <a:t>813</a:t>
+              <a:t>1,005</a:t>
             </a:r>
           </a:p>
         </p:txBody>
@@ -21962,7 +21962,7 @@
                 </a:solidFill>
                 <a:latin typeface="Calibri"/>
               </a:rPr>
-              <a:t>813 automated tests define how everything must behave, the architecture is documented in writing, and Phase 4 trains a named CAPEE-side maintainer.</a:t>
+              <a:t>1,005 automated tests define how everything must behave, the architecture is documented in writing, and Phase 4 trains a named CAPEE-side maintainer.</a:t>
             </a:r>
           </a:p>
         </p:txBody>
@@ -28126,7 +28126,7 @@
                 </a:solidFill>
                 <a:latin typeface="Calibri"/>
               </a:rPr>
-              <a:t>estimating error cut from 10.9% to 0.3% after learning from 3 real quotes  ·  £512k/yr of pricing issues found autonomously in the live demo  ·  813 automated tests protect it all.</a:t>
+              <a:t>estimating error cut from 10.9% to 0.3% after learning from 3 real quotes  ·  £512k/yr of pricing issues found autonomously in the live demo  ·  1,005 automated tests protect it all.</a:t>
             </a:r>
           </a:p>
         </p:txBody>
@@ -28455,7 +28455,7 @@
                 </a:solidFill>
                 <a:latin typeface="Calibri"/>
               </a:rPr>
-              <a:t>Latest intelligence — five upgrades that widen the moat</a:t>
+              <a:t>Latest intelligence — six upgrades that widen the moat</a:t>
             </a:r>
           </a:p>
         </p:txBody>
@@ -28469,7 +28469,7 @@
         <p:spPr>
           <a:xfrm>
             <a:off x="411480" y="1828800"/>
-            <a:ext cx="11384280" cy="786384"/>
+            <a:ext cx="11384280" cy="676656"/>
           </a:xfrm>
           <a:prstGeom prst="roundRect">
             <a:avLst>
@@ -28515,7 +28515,181 @@
         <p:spPr>
           <a:xfrm>
             <a:off x="411480" y="1828800"/>
-            <a:ext cx="82296" cy="786384"/>
+            <a:ext cx="82296" cy="676656"/>
+          </a:xfrm>
+          <a:prstGeom prst="rect">
+            <a:avLst/>
+          </a:prstGeom>
+          <a:solidFill>
+            <a:srgbClr val="4F46E5"/>
+          </a:solidFill>
+          <a:ln>
+            <a:noFill/>
+          </a:ln>
+          <a:effectLst/>
+        </p:spPr>
+        <p:style>
+          <a:lnRef idx="1">
+            <a:schemeClr val="accent1"/>
+          </a:lnRef>
+          <a:fillRef idx="3">
+            <a:schemeClr val="accent1"/>
+          </a:fillRef>
+          <a:effectRef idx="2">
+            <a:schemeClr val="accent1"/>
+          </a:effectRef>
+          <a:fontRef idx="minor">
+            <a:schemeClr val="lt1"/>
+          </a:fontRef>
+        </p:style>
+        <p:txBody>
+          <a:bodyPr rtlCol="0" anchor="ctr"/>
+          <a:lstStyle/>
+          <a:p>
+            <a:pPr algn="ctr"/>
+          </a:p>
+        </p:txBody>
+      </p:sp>
+      <p:sp>
+        <p:nvSpPr>
+          <p:cNvPr id="11" name="TextBox 10"/>
+          <p:cNvSpPr txBox="1"/>
+          <p:nvPr/>
+        </p:nvSpPr>
+        <p:spPr>
+          <a:xfrm>
+            <a:off x="713232" y="1920240"/>
+            <a:ext cx="3200400" cy="502920"/>
+          </a:xfrm>
+          <a:prstGeom prst="rect">
+            <a:avLst/>
+          </a:prstGeom>
+          <a:noFill/>
+        </p:spPr>
+        <p:txBody>
+          <a:bodyPr wrap="square" anchor="t" lIns="0" rIns="0" tIns="0" bIns="0">
+            <a:spAutoFit/>
+          </a:bodyPr>
+          <a:lstStyle/>
+          <a:p>
+            <a:pPr algn="l">
+              <a:lnSpc>
+                <a:spcPct val="100000"/>
+              </a:lnSpc>
+              <a:spcAft>
+                <a:spcPts val="400"/>
+              </a:spcAft>
+            </a:pPr>
+            <a:r>
+              <a:rPr sz="1250" b="1" i="0">
+                <a:solidFill>
+                  <a:srgbClr val="4F46E5"/>
+                </a:solidFill>
+                <a:latin typeface="Calibri"/>
+              </a:rPr>
+              <a:t>Self-audit &amp; guardrails</a:t>
+            </a:r>
+          </a:p>
+        </p:txBody>
+      </p:sp>
+      <p:sp>
+        <p:nvSpPr>
+          <p:cNvPr id="12" name="TextBox 11"/>
+          <p:cNvSpPr txBox="1"/>
+          <p:nvPr/>
+        </p:nvSpPr>
+        <p:spPr>
+          <a:xfrm>
+            <a:off x="3931920" y="1911096"/>
+            <a:ext cx="7680960" cy="548640"/>
+          </a:xfrm>
+          <a:prstGeom prst="rect">
+            <a:avLst/>
+          </a:prstGeom>
+          <a:noFill/>
+        </p:spPr>
+        <p:txBody>
+          <a:bodyPr wrap="square" anchor="t" lIns="0" rIns="0" tIns="0" bIns="0">
+            <a:spAutoFit/>
+          </a:bodyPr>
+          <a:lstStyle/>
+          <a:p>
+            <a:pPr algn="l">
+              <a:lnSpc>
+                <a:spcPct val="108000"/>
+              </a:lnSpc>
+              <a:spcAft>
+                <a:spcPts val="400"/>
+              </a:spcAft>
+            </a:pPr>
+            <a:r>
+              <a:rPr sz="1100" b="0" i="0">
+                <a:solidFill>
+                  <a:srgbClr val="334155"/>
+                </a:solidFill>
+                <a:latin typeface="Calibri"/>
+              </a:rPr>
+              <a:t>A deterministic layer re-checks every estimate for known errors and applies bounded corrections — proven on five real automotive CAD parts (a fuel tank fell from £217 to £25). Geometry stays ground truth; the AI never overrules it.</a:t>
+            </a:r>
+          </a:p>
+        </p:txBody>
+      </p:sp>
+      <p:sp>
+        <p:nvSpPr>
+          <p:cNvPr id="13" name="Rounded Rectangle 12"/>
+          <p:cNvSpPr/>
+          <p:nvPr/>
+        </p:nvSpPr>
+        <p:spPr>
+          <a:xfrm>
+            <a:off x="411480" y="2578608"/>
+            <a:ext cx="11384280" cy="676656"/>
+          </a:xfrm>
+          <a:prstGeom prst="roundRect">
+            <a:avLst>
+              <a:gd name="adj" fmla="val 10000"/>
+            </a:avLst>
+          </a:prstGeom>
+          <a:solidFill>
+            <a:srgbClr val="FFFFFF"/>
+          </a:solidFill>
+          <a:ln>
+            <a:noFill/>
+          </a:ln>
+          <a:effectLst/>
+        </p:spPr>
+        <p:style>
+          <a:lnRef idx="1">
+            <a:schemeClr val="accent1"/>
+          </a:lnRef>
+          <a:fillRef idx="3">
+            <a:schemeClr val="accent1"/>
+          </a:fillRef>
+          <a:effectRef idx="2">
+            <a:schemeClr val="accent1"/>
+          </a:effectRef>
+          <a:fontRef idx="minor">
+            <a:schemeClr val="lt1"/>
+          </a:fontRef>
+        </p:style>
+        <p:txBody>
+          <a:bodyPr rtlCol="0" anchor="ctr"/>
+          <a:lstStyle/>
+          <a:p>
+            <a:pPr algn="ctr"/>
+          </a:p>
+        </p:txBody>
+      </p:sp>
+      <p:sp>
+        <p:nvSpPr>
+          <p:cNvPr id="14" name="Rectangle 13"/>
+          <p:cNvSpPr/>
+          <p:nvPr/>
+        </p:nvSpPr>
+        <p:spPr>
+          <a:xfrm>
+            <a:off x="411480" y="2578608"/>
+            <a:ext cx="82296" cy="676656"/>
           </a:xfrm>
           <a:prstGeom prst="rect">
             <a:avLst/>
@@ -28552,14 +28726,14 @@
       </p:sp>
       <p:sp>
         <p:nvSpPr>
-          <p:cNvPr id="11" name="TextBox 10"/>
+          <p:cNvPr id="15" name="TextBox 14"/>
           <p:cNvSpPr txBox="1"/>
           <p:nvPr/>
         </p:nvSpPr>
         <p:spPr>
           <a:xfrm>
-            <a:off x="713232" y="1938528"/>
-            <a:ext cx="3200400" cy="548640"/>
+            <a:off x="713232" y="2670048"/>
+            <a:ext cx="3200400" cy="502920"/>
           </a:xfrm>
           <a:prstGeom prst="rect">
             <a:avLst/>
@@ -28587,21 +28761,21 @@
                 </a:solidFill>
                 <a:latin typeface="Calibri"/>
               </a:rPr>
-              <a:t>Conformal confidence</a:t>
-            </a:r>
-          </a:p>
-        </p:txBody>
-      </p:sp>
-      <p:sp>
-        <p:nvSpPr>
-          <p:cNvPr id="12" name="TextBox 11"/>
+              <a:t>Learns from your quotes</a:t>
+            </a:r>
+          </a:p>
+        </p:txBody>
+      </p:sp>
+      <p:sp>
+        <p:nvSpPr>
+          <p:cNvPr id="16" name="TextBox 15"/>
           <p:cNvSpPr txBox="1"/>
           <p:nvPr/>
         </p:nvSpPr>
         <p:spPr>
           <a:xfrm>
-            <a:off x="3931920" y="1938528"/>
-            <a:ext cx="7680960" cy="594360"/>
+            <a:off x="3931920" y="2660904"/>
+            <a:ext cx="7680960" cy="548640"/>
           </a:xfrm>
           <a:prstGeom prst="rect">
             <a:avLst/>
@@ -28616,34 +28790,208 @@
           <a:p>
             <a:pPr algn="l">
               <a:lnSpc>
-                <a:spcPct val="112000"/>
+                <a:spcPct val="108000"/>
               </a:lnSpc>
               <a:spcAft>
                 <a:spcPts val="400"/>
               </a:spcAft>
             </a:pPr>
             <a:r>
-              <a:rPr sz="1150" b="0" i="0">
+              <a:rPr sz="1100" b="0" i="0">
                 <a:solidFill>
                   <a:srgbClr val="334155"/>
                 </a:solidFill>
                 <a:latin typeface="Calibri"/>
               </a:rPr>
-              <a:t>An empirical band with a coverage guarantee — "90% of your logged quotes landed within ±6.5%". Defensible, not asserted.</a:t>
-            </a:r>
-          </a:p>
-        </p:txBody>
-      </p:sp>
-      <p:sp>
-        <p:nvSpPr>
-          <p:cNvPr id="13" name="Rounded Rectangle 12"/>
+              <a:t>Bulk-import logged actuals; the engine builds per-segment calibration and watches for drift, so the number tightens as your own history grows — and status rides on every estimate.</a:t>
+            </a:r>
+          </a:p>
+        </p:txBody>
+      </p:sp>
+      <p:sp>
+        <p:nvSpPr>
+          <p:cNvPr id="17" name="Rounded Rectangle 16"/>
           <p:cNvSpPr/>
           <p:nvPr/>
         </p:nvSpPr>
         <p:spPr>
           <a:xfrm>
-            <a:off x="411480" y="2724912"/>
-            <a:ext cx="11384280" cy="786384"/>
+            <a:off x="411480" y="3328415"/>
+            <a:ext cx="11384280" cy="676656"/>
+          </a:xfrm>
+          <a:prstGeom prst="roundRect">
+            <a:avLst>
+              <a:gd name="adj" fmla="val 10000"/>
+            </a:avLst>
+          </a:prstGeom>
+          <a:solidFill>
+            <a:srgbClr val="F1F5F9"/>
+          </a:solidFill>
+          <a:ln>
+            <a:noFill/>
+          </a:ln>
+          <a:effectLst/>
+        </p:spPr>
+        <p:style>
+          <a:lnRef idx="1">
+            <a:schemeClr val="accent1"/>
+          </a:lnRef>
+          <a:fillRef idx="3">
+            <a:schemeClr val="accent1"/>
+          </a:fillRef>
+          <a:effectRef idx="2">
+            <a:schemeClr val="accent1"/>
+          </a:effectRef>
+          <a:fontRef idx="minor">
+            <a:schemeClr val="lt1"/>
+          </a:fontRef>
+        </p:style>
+        <p:txBody>
+          <a:bodyPr rtlCol="0" anchor="ctr"/>
+          <a:lstStyle/>
+          <a:p>
+            <a:pPr algn="ctr"/>
+          </a:p>
+        </p:txBody>
+      </p:sp>
+      <p:sp>
+        <p:nvSpPr>
+          <p:cNvPr id="18" name="Rectangle 17"/>
+          <p:cNvSpPr/>
+          <p:nvPr/>
+        </p:nvSpPr>
+        <p:spPr>
+          <a:xfrm>
+            <a:off x="411480" y="3328415"/>
+            <a:ext cx="82296" cy="676656"/>
+          </a:xfrm>
+          <a:prstGeom prst="rect">
+            <a:avLst/>
+          </a:prstGeom>
+          <a:solidFill>
+            <a:srgbClr val="2563EB"/>
+          </a:solidFill>
+          <a:ln>
+            <a:noFill/>
+          </a:ln>
+          <a:effectLst/>
+        </p:spPr>
+        <p:style>
+          <a:lnRef idx="1">
+            <a:schemeClr val="accent1"/>
+          </a:lnRef>
+          <a:fillRef idx="3">
+            <a:schemeClr val="accent1"/>
+          </a:fillRef>
+          <a:effectRef idx="2">
+            <a:schemeClr val="accent1"/>
+          </a:effectRef>
+          <a:fontRef idx="minor">
+            <a:schemeClr val="lt1"/>
+          </a:fontRef>
+        </p:style>
+        <p:txBody>
+          <a:bodyPr rtlCol="0" anchor="ctr"/>
+          <a:lstStyle/>
+          <a:p>
+            <a:pPr algn="ctr"/>
+          </a:p>
+        </p:txBody>
+      </p:sp>
+      <p:sp>
+        <p:nvSpPr>
+          <p:cNvPr id="19" name="TextBox 18"/>
+          <p:cNvSpPr txBox="1"/>
+          <p:nvPr/>
+        </p:nvSpPr>
+        <p:spPr>
+          <a:xfrm>
+            <a:off x="713232" y="3419855"/>
+            <a:ext cx="3200400" cy="502920"/>
+          </a:xfrm>
+          <a:prstGeom prst="rect">
+            <a:avLst/>
+          </a:prstGeom>
+          <a:noFill/>
+        </p:spPr>
+        <p:txBody>
+          <a:bodyPr wrap="square" anchor="t" lIns="0" rIns="0" tIns="0" bIns="0">
+            <a:spAutoFit/>
+          </a:bodyPr>
+          <a:lstStyle/>
+          <a:p>
+            <a:pPr algn="l">
+              <a:lnSpc>
+                <a:spcPct val="100000"/>
+              </a:lnSpc>
+              <a:spcAft>
+                <a:spcPts val="400"/>
+              </a:spcAft>
+            </a:pPr>
+            <a:r>
+              <a:rPr sz="1250" b="1" i="0">
+                <a:solidFill>
+                  <a:srgbClr val="2563EB"/>
+                </a:solidFill>
+                <a:latin typeface="Calibri"/>
+              </a:rPr>
+              <a:t>Negotiation coach</a:t>
+            </a:r>
+          </a:p>
+        </p:txBody>
+      </p:sp>
+      <p:sp>
+        <p:nvSpPr>
+          <p:cNvPr id="20" name="TextBox 19"/>
+          <p:cNvSpPr txBox="1"/>
+          <p:nvPr/>
+        </p:nvSpPr>
+        <p:spPr>
+          <a:xfrm>
+            <a:off x="3931920" y="3410711"/>
+            <a:ext cx="7680960" cy="548640"/>
+          </a:xfrm>
+          <a:prstGeom prst="rect">
+            <a:avLst/>
+          </a:prstGeom>
+          <a:noFill/>
+        </p:spPr>
+        <p:txBody>
+          <a:bodyPr wrap="square" anchor="t" lIns="0" rIns="0" tIns="0" bIns="0">
+            <a:spAutoFit/>
+          </a:bodyPr>
+          <a:lstStyle/>
+          <a:p>
+            <a:pPr algn="l">
+              <a:lnSpc>
+                <a:spcPct val="108000"/>
+              </a:lnSpc>
+              <a:spcAft>
+                <a:spcPts val="400"/>
+              </a:spcAft>
+            </a:pPr>
+            <a:r>
+              <a:rPr sz="1100" b="0" i="0">
+                <a:solidFill>
+                  <a:srgbClr val="334155"/>
+                </a:solidFill>
+                <a:latin typeface="Calibri"/>
+              </a:rPr>
+              <a:t>Names the cost driver and writes the counter: "a quote of £95 implies aluminium +14% above spot — hold at £86.34."</a:t>
+            </a:r>
+          </a:p>
+        </p:txBody>
+      </p:sp>
+      <p:sp>
+        <p:nvSpPr>
+          <p:cNvPr id="21" name="Rounded Rectangle 20"/>
+          <p:cNvSpPr/>
+          <p:nvPr/>
+        </p:nvSpPr>
+        <p:spPr>
+          <a:xfrm>
+            <a:off x="411480" y="4078224"/>
+            <a:ext cx="11384280" cy="676656"/>
           </a:xfrm>
           <a:prstGeom prst="roundRect">
             <a:avLst>
@@ -28682,20 +29030,20 @@
       </p:sp>
       <p:sp>
         <p:nvSpPr>
-          <p:cNvPr id="14" name="Rectangle 13"/>
+          <p:cNvPr id="22" name="Rectangle 21"/>
           <p:cNvSpPr/>
           <p:nvPr/>
         </p:nvSpPr>
         <p:spPr>
           <a:xfrm>
-            <a:off x="411480" y="2724912"/>
-            <a:ext cx="82296" cy="786384"/>
+            <a:off x="411480" y="4078224"/>
+            <a:ext cx="82296" cy="676656"/>
           </a:xfrm>
           <a:prstGeom prst="rect">
             <a:avLst/>
           </a:prstGeom>
           <a:solidFill>
-            <a:srgbClr val="2563EB"/>
+            <a:srgbClr val="7C3AED"/>
           </a:solidFill>
           <a:ln>
             <a:noFill/>
@@ -28726,14 +29074,14 @@
       </p:sp>
       <p:sp>
         <p:nvSpPr>
-          <p:cNvPr id="15" name="TextBox 14"/>
+          <p:cNvPr id="23" name="TextBox 22"/>
           <p:cNvSpPr txBox="1"/>
           <p:nvPr/>
         </p:nvSpPr>
         <p:spPr>
           <a:xfrm>
-            <a:off x="713232" y="2834640"/>
-            <a:ext cx="3200400" cy="548640"/>
+            <a:off x="713232" y="4169664"/>
+            <a:ext cx="3200400" cy="502920"/>
           </a:xfrm>
           <a:prstGeom prst="rect">
             <a:avLst/>
@@ -28757,25 +29105,25 @@
             <a:r>
               <a:rPr sz="1250" b="1" i="0">
                 <a:solidFill>
-                  <a:srgbClr val="2563EB"/>
-                </a:solidFill>
-                <a:latin typeface="Calibri"/>
-              </a:rPr>
-              <a:t>Negotiation coach</a:t>
-            </a:r>
-          </a:p>
-        </p:txBody>
-      </p:sp>
-      <p:sp>
-        <p:nvSpPr>
-          <p:cNvPr id="16" name="TextBox 15"/>
+                  <a:srgbClr val="7C3AED"/>
+                </a:solidFill>
+                <a:latin typeface="Calibri"/>
+              </a:rPr>
+              <a:t>Outcome-weighted findings</a:t>
+            </a:r>
+          </a:p>
+        </p:txBody>
+      </p:sp>
+      <p:sp>
+        <p:nvSpPr>
+          <p:cNvPr id="24" name="TextBox 23"/>
           <p:cNvSpPr txBox="1"/>
           <p:nvPr/>
         </p:nvSpPr>
         <p:spPr>
           <a:xfrm>
-            <a:off x="3931920" y="2834640"/>
-            <a:ext cx="7680960" cy="594360"/>
+            <a:off x="3931920" y="4160520"/>
+            <a:ext cx="7680960" cy="548640"/>
           </a:xfrm>
           <a:prstGeom prst="rect">
             <a:avLst/>
@@ -28790,34 +29138,34 @@
           <a:p>
             <a:pPr algn="l">
               <a:lnSpc>
-                <a:spcPct val="112000"/>
+                <a:spcPct val="108000"/>
               </a:lnSpc>
               <a:spcAft>
                 <a:spcPts val="400"/>
               </a:spcAft>
             </a:pPr>
             <a:r>
-              <a:rPr sz="1150" b="0" i="0">
+              <a:rPr sz="1100" b="0" i="0">
                 <a:solidFill>
                   <a:srgbClr val="334155"/>
                 </a:solidFill>
                 <a:latin typeface="Calibri"/>
               </a:rPr>
-              <a:t>Names the cost driver and writes the counter: "a quote of £95 implies aluminium +14% above spot — hold at £86.34."</a:t>
-            </a:r>
-          </a:p>
-        </p:txBody>
-      </p:sp>
-      <p:sp>
-        <p:nvSpPr>
-          <p:cNvPr id="17" name="Rounded Rectangle 16"/>
+              <a:t>The agent learns which findings convert and ranks by money it can really recover — a £100k gap that closes beats a £200k gap that never does.</a:t>
+            </a:r>
+          </a:p>
+        </p:txBody>
+      </p:sp>
+      <p:sp>
+        <p:nvSpPr>
+          <p:cNvPr id="25" name="Rounded Rectangle 24"/>
           <p:cNvSpPr/>
           <p:nvPr/>
         </p:nvSpPr>
         <p:spPr>
           <a:xfrm>
-            <a:off x="411480" y="3621024"/>
-            <a:ext cx="11384280" cy="786384"/>
+            <a:off x="411480" y="4828031"/>
+            <a:ext cx="11384280" cy="676656"/>
           </a:xfrm>
           <a:prstGeom prst="roundRect">
             <a:avLst>
@@ -28856,20 +29204,20 @@
       </p:sp>
       <p:sp>
         <p:nvSpPr>
-          <p:cNvPr id="18" name="Rectangle 17"/>
+          <p:cNvPr id="26" name="Rectangle 25"/>
           <p:cNvSpPr/>
           <p:nvPr/>
         </p:nvSpPr>
         <p:spPr>
           <a:xfrm>
-            <a:off x="411480" y="3621024"/>
-            <a:ext cx="82296" cy="786384"/>
+            <a:off x="411480" y="4828031"/>
+            <a:ext cx="82296" cy="676656"/>
           </a:xfrm>
           <a:prstGeom prst="rect">
             <a:avLst/>
           </a:prstGeom>
           <a:solidFill>
-            <a:srgbClr val="7C3AED"/>
+            <a:srgbClr val="0891B2"/>
           </a:solidFill>
           <a:ln>
             <a:noFill/>
@@ -28900,14 +29248,14 @@
       </p:sp>
       <p:sp>
         <p:nvSpPr>
-          <p:cNvPr id="19" name="TextBox 18"/>
+          <p:cNvPr id="27" name="TextBox 26"/>
           <p:cNvSpPr txBox="1"/>
           <p:nvPr/>
         </p:nvSpPr>
         <p:spPr>
           <a:xfrm>
-            <a:off x="713232" y="3730752"/>
-            <a:ext cx="3200400" cy="548640"/>
+            <a:off x="713232" y="4919471"/>
+            <a:ext cx="3200400" cy="502920"/>
           </a:xfrm>
           <a:prstGeom prst="rect">
             <a:avLst/>
@@ -28931,25 +29279,25 @@
             <a:r>
               <a:rPr sz="1250" b="1" i="0">
                 <a:solidFill>
-                  <a:srgbClr val="7C3AED"/>
-                </a:solidFill>
-                <a:latin typeface="Calibri"/>
-              </a:rPr>
-              <a:t>Outcome-weighted findings</a:t>
-            </a:r>
-          </a:p>
-        </p:txBody>
-      </p:sp>
-      <p:sp>
-        <p:nvSpPr>
-          <p:cNvPr id="20" name="TextBox 19"/>
+                  <a:srgbClr val="0891B2"/>
+                </a:solidFill>
+                <a:latin typeface="Calibri"/>
+              </a:rPr>
+              <a:t>What-if engine</a:t>
+            </a:r>
+          </a:p>
+        </p:txBody>
+      </p:sp>
+      <p:sp>
+        <p:nvSpPr>
+          <p:cNvPr id="28" name="TextBox 27"/>
           <p:cNvSpPr txBox="1"/>
           <p:nvPr/>
         </p:nvSpPr>
         <p:spPr>
           <a:xfrm>
-            <a:off x="3931920" y="3730752"/>
-            <a:ext cx="7680960" cy="594360"/>
+            <a:off x="3931920" y="4910327"/>
+            <a:ext cx="7680960" cy="548640"/>
           </a:xfrm>
           <a:prstGeom prst="rect">
             <a:avLst/>
@@ -28964,34 +29312,34 @@
           <a:p>
             <a:pPr algn="l">
               <a:lnSpc>
-                <a:spcPct val="112000"/>
+                <a:spcPct val="108000"/>
               </a:lnSpc>
               <a:spcAft>
                 <a:spcPts val="400"/>
               </a:spcAft>
             </a:pPr>
             <a:r>
-              <a:rPr sz="1150" b="0" i="0">
+              <a:rPr sz="1100" b="0" i="0">
                 <a:solidFill>
                   <a:srgbClr val="334155"/>
                 </a:solidFill>
                 <a:latin typeface="Calibri"/>
               </a:rPr>
-              <a:t>The agent learns which findings convert and ranks by money it can really recover — a £100k gap that closes beats a £200k gap that never does.</a:t>
-            </a:r>
-          </a:p>
-        </p:txBody>
-      </p:sp>
-      <p:sp>
-        <p:nvSpPr>
-          <p:cNvPr id="21" name="Rounded Rectangle 20"/>
+              <a:t>Drag a commodity ±20% and the price recomputes live; run it across the whole portfolio ("if steel +10%, 7 parts go underwater").</a:t>
+            </a:r>
+          </a:p>
+        </p:txBody>
+      </p:sp>
+      <p:sp>
+        <p:nvSpPr>
+          <p:cNvPr id="29" name="Rounded Rectangle 28"/>
           <p:cNvSpPr/>
           <p:nvPr/>
         </p:nvSpPr>
         <p:spPr>
           <a:xfrm>
-            <a:off x="411480" y="4517136"/>
-            <a:ext cx="11384280" cy="786384"/>
+            <a:off x="411480" y="5577840"/>
+            <a:ext cx="11384280" cy="676656"/>
           </a:xfrm>
           <a:prstGeom prst="roundRect">
             <a:avLst>
@@ -29030,188 +29378,14 @@
       </p:sp>
       <p:sp>
         <p:nvSpPr>
-          <p:cNvPr id="22" name="Rectangle 21"/>
+          <p:cNvPr id="30" name="Rectangle 29"/>
           <p:cNvSpPr/>
           <p:nvPr/>
         </p:nvSpPr>
         <p:spPr>
           <a:xfrm>
-            <a:off x="411480" y="4517136"/>
-            <a:ext cx="82296" cy="786384"/>
-          </a:xfrm>
-          <a:prstGeom prst="rect">
-            <a:avLst/>
-          </a:prstGeom>
-          <a:solidFill>
-            <a:srgbClr val="0891B2"/>
-          </a:solidFill>
-          <a:ln>
-            <a:noFill/>
-          </a:ln>
-          <a:effectLst/>
-        </p:spPr>
-        <p:style>
-          <a:lnRef idx="1">
-            <a:schemeClr val="accent1"/>
-          </a:lnRef>
-          <a:fillRef idx="3">
-            <a:schemeClr val="accent1"/>
-          </a:fillRef>
-          <a:effectRef idx="2">
-            <a:schemeClr val="accent1"/>
-          </a:effectRef>
-          <a:fontRef idx="minor">
-            <a:schemeClr val="lt1"/>
-          </a:fontRef>
-        </p:style>
-        <p:txBody>
-          <a:bodyPr rtlCol="0" anchor="ctr"/>
-          <a:lstStyle/>
-          <a:p>
-            <a:pPr algn="ctr"/>
-          </a:p>
-        </p:txBody>
-      </p:sp>
-      <p:sp>
-        <p:nvSpPr>
-          <p:cNvPr id="23" name="TextBox 22"/>
-          <p:cNvSpPr txBox="1"/>
-          <p:nvPr/>
-        </p:nvSpPr>
-        <p:spPr>
-          <a:xfrm>
-            <a:off x="713232" y="4626864"/>
-            <a:ext cx="3200400" cy="548640"/>
-          </a:xfrm>
-          <a:prstGeom prst="rect">
-            <a:avLst/>
-          </a:prstGeom>
-          <a:noFill/>
-        </p:spPr>
-        <p:txBody>
-          <a:bodyPr wrap="square" anchor="t" lIns="0" rIns="0" tIns="0" bIns="0">
-            <a:spAutoFit/>
-          </a:bodyPr>
-          <a:lstStyle/>
-          <a:p>
-            <a:pPr algn="l">
-              <a:lnSpc>
-                <a:spcPct val="100000"/>
-              </a:lnSpc>
-              <a:spcAft>
-                <a:spcPts val="400"/>
-              </a:spcAft>
-            </a:pPr>
-            <a:r>
-              <a:rPr sz="1250" b="1" i="0">
-                <a:solidFill>
-                  <a:srgbClr val="0891B2"/>
-                </a:solidFill>
-                <a:latin typeface="Calibri"/>
-              </a:rPr>
-              <a:t>What-if engine</a:t>
-            </a:r>
-          </a:p>
-        </p:txBody>
-      </p:sp>
-      <p:sp>
-        <p:nvSpPr>
-          <p:cNvPr id="24" name="TextBox 23"/>
-          <p:cNvSpPr txBox="1"/>
-          <p:nvPr/>
-        </p:nvSpPr>
-        <p:spPr>
-          <a:xfrm>
-            <a:off x="3931920" y="4626864"/>
-            <a:ext cx="7680960" cy="594360"/>
-          </a:xfrm>
-          <a:prstGeom prst="rect">
-            <a:avLst/>
-          </a:prstGeom>
-          <a:noFill/>
-        </p:spPr>
-        <p:txBody>
-          <a:bodyPr wrap="square" anchor="t" lIns="0" rIns="0" tIns="0" bIns="0">
-            <a:spAutoFit/>
-          </a:bodyPr>
-          <a:lstStyle/>
-          <a:p>
-            <a:pPr algn="l">
-              <a:lnSpc>
-                <a:spcPct val="112000"/>
-              </a:lnSpc>
-              <a:spcAft>
-                <a:spcPts val="400"/>
-              </a:spcAft>
-            </a:pPr>
-            <a:r>
-              <a:rPr sz="1150" b="0" i="0">
-                <a:solidFill>
-                  <a:srgbClr val="334155"/>
-                </a:solidFill>
-                <a:latin typeface="Calibri"/>
-              </a:rPr>
-              <a:t>Drag a commodity ±20% and the price recomputes live; run it across the whole portfolio ("if steel +10%, 7 parts go underwater").</a:t>
-            </a:r>
-          </a:p>
-        </p:txBody>
-      </p:sp>
-      <p:sp>
-        <p:nvSpPr>
-          <p:cNvPr id="25" name="Rounded Rectangle 24"/>
-          <p:cNvSpPr/>
-          <p:nvPr/>
-        </p:nvSpPr>
-        <p:spPr>
-          <a:xfrm>
-            <a:off x="411480" y="5413248"/>
-            <a:ext cx="11384280" cy="786384"/>
-          </a:xfrm>
-          <a:prstGeom prst="roundRect">
-            <a:avLst>
-              <a:gd name="adj" fmla="val 10000"/>
-            </a:avLst>
-          </a:prstGeom>
-          <a:solidFill>
-            <a:srgbClr val="F1F5F9"/>
-          </a:solidFill>
-          <a:ln>
-            <a:noFill/>
-          </a:ln>
-          <a:effectLst/>
-        </p:spPr>
-        <p:style>
-          <a:lnRef idx="1">
-            <a:schemeClr val="accent1"/>
-          </a:lnRef>
-          <a:fillRef idx="3">
-            <a:schemeClr val="accent1"/>
-          </a:fillRef>
-          <a:effectRef idx="2">
-            <a:schemeClr val="accent1"/>
-          </a:effectRef>
-          <a:fontRef idx="minor">
-            <a:schemeClr val="lt1"/>
-          </a:fontRef>
-        </p:style>
-        <p:txBody>
-          <a:bodyPr rtlCol="0" anchor="ctr"/>
-          <a:lstStyle/>
-          <a:p>
-            <a:pPr algn="ctr"/>
-          </a:p>
-        </p:txBody>
-      </p:sp>
-      <p:sp>
-        <p:nvSpPr>
-          <p:cNvPr id="26" name="Rectangle 25"/>
-          <p:cNvSpPr/>
-          <p:nvPr/>
-        </p:nvSpPr>
-        <p:spPr>
-          <a:xfrm>
-            <a:off x="411480" y="5413248"/>
-            <a:ext cx="82296" cy="786384"/>
+            <a:off x="411480" y="5577840"/>
+            <a:ext cx="82296" cy="676656"/>
           </a:xfrm>
           <a:prstGeom prst="rect">
             <a:avLst/>
@@ -29248,14 +29422,14 @@
       </p:sp>
       <p:sp>
         <p:nvSpPr>
-          <p:cNvPr id="27" name="TextBox 26"/>
+          <p:cNvPr id="31" name="TextBox 30"/>
           <p:cNvSpPr txBox="1"/>
           <p:nvPr/>
         </p:nvSpPr>
         <p:spPr>
           <a:xfrm>
-            <a:off x="713232" y="5522976"/>
-            <a:ext cx="3200400" cy="548640"/>
+            <a:off x="713232" y="5669280"/>
+            <a:ext cx="3200400" cy="502920"/>
           </a:xfrm>
           <a:prstGeom prst="rect">
             <a:avLst/>
@@ -29290,14 +29464,14 @@
       </p:sp>
       <p:sp>
         <p:nvSpPr>
-          <p:cNvPr id="28" name="TextBox 27"/>
+          <p:cNvPr id="32" name="TextBox 31"/>
           <p:cNvSpPr txBox="1"/>
           <p:nvPr/>
         </p:nvSpPr>
         <p:spPr>
           <a:xfrm>
-            <a:off x="3931920" y="5522976"/>
-            <a:ext cx="7680960" cy="594360"/>
+            <a:off x="3931920" y="5660136"/>
+            <a:ext cx="7680960" cy="548640"/>
           </a:xfrm>
           <a:prstGeom prst="rect">
             <a:avLst/>
@@ -29312,14 +29486,14 @@
           <a:p>
             <a:pPr algn="l">
               <a:lnSpc>
-                <a:spcPct val="112000"/>
+                <a:spcPct val="108000"/>
               </a:lnSpc>
               <a:spcAft>
                 <a:spcPts val="400"/>
               </a:spcAft>
             </a:pPr>
             <a:r>
-              <a:rPr sz="1150" b="0" i="0">
+              <a:rPr sz="1100" b="0" i="0">
                 <a:solidFill>
                   <a:srgbClr val="334155"/>
                 </a:solidFill>

</xml_diff>

<commit_message>
Blueprint: reframe CAPEE as existing should-cost software CostVision integrates into
Sharpen the integration story so it reads as "CostVision plugs INTO CAPEE, our
existing should-cost software, and upgrades its costing engine" — not a parallel
tool beside a generic workflow.

- Integration slide: title -> "CostVision inside CAPEE — should-cost, upgraded";
  left panel now "CAPEE (existing should-cost software)" with "its costing engine
  now powered by CostVision"; right panel "the engine it plugs in"
- Exec-summary "Why CAPEE wins" + notes: CAPEE is our existing should-cost
  software; CostVision plugs in to upgrade its engine, no rip-and-replace
- Title subtitle + feasibility verdict + closing notes reworded to "integrated
  into CAPEE"
- Companion PDF regenerated

Co-Authored-By: Claude Opus 4.8 <noreply@anthropic.com>
Claude-Session: https://claude.ai/code/session_0142L4rKS2AV8rxQTDWMs7dy
</commit_message>
<xml_diff>
--- a/CostVision-Implementation-Blueprint.pptx
+++ b/CostVision-Implementation-Blueprint.pptx
@@ -957,7 +957,7 @@
           <a:lstStyle/>
           <a:p>
             <a:r>
-              <a:t>The integration philosophy: CAPEE stays the front door — the workflow, approvals and reporting our teams already know. CostVision becomes the engine behind it, called over internal APIs that already exist. The six flows that matter: CAPEE sends a part, gets a full should-cost back. It sends a CAD file, gets auto-filled inputs. It asks about a new part, gets similar history and suggestions. And the best one: every PO price CAPEE already captures feeds the learning loop automatically — CAPEE's data makes CostVision smarter without anyone lifting a finger. One shared rate library and knowledge database means one version of the truth.</a:t>
+              <a:t>The integration philosophy in one line: CostVision integrates INTO CAPEE, the should-cost software our teams already use — it doesn't sit beside it. CAPEE keeps the workflow, the approvals and the reporting; what changes is that its costing engine is now powered by CostVision underneath, called over internal APIs that already exist. So users open CAPEE exactly as they do today and simply get better should-cost numbers. The six flows that matter: CAPEE sends a part, gets a full should-cost back. It sends a CAD file, gets auto-filled inputs. It asks about a new part, gets similar history and suggestions. And the best one: every PO price CAPEE already captures feeds the learning loop automatically — CAPEE's own data makes the engine smarter without anyone lifting a finger. One shared rate library and knowledge database means one version of the truth across both.</a:t>
             </a:r>
           </a:p>
         </p:txBody>
@@ -1307,7 +1307,7 @@
           <a:lstStyle/>
           <a:p>
             <a:r>
-              <a:t>To summarise: secure deployment with CAD fully internal is feasible — in fact, the platform was built that way, and the two controls that complete it — private AI routing and the air-gapped switch — are already built, tested and demonstrated live. CAPEE integration is feasible and high-value, with CAPEE remaining the front door. The remaining changes are bounded — roughly three to five weeks, not months — and governance is defined. The ask today is simple: approve Phases 1 and 2, the security assessment and the architecture design. The full written plan, including the security checklist, is ready to hand to the IT-Security team. Thank you — questions welcome.</a:t>
+              <a:t>To summarise: secure deployment with CAD fully internal is feasible — in fact, the platform was built that way, and the two controls that complete it — private AI routing and the air-gapped switch — are already built, tested and demonstrated live. Integrating into CAPEE is feasible and high-value: CostVision plugs in as the should-cost engine while CAPEE stays the tool teams work in. The remaining changes are bounded — roughly three to five weeks, not months — and governance is defined. The ask today is simple: approve Phases 1 and 2, the security assessment and the architecture design. The full written plan, including the security checklist, is ready to hand to the IT-Security team. Thank you — questions welcome.</a:t>
             </a:r>
           </a:p>
         </p:txBody>
@@ -1517,7 +1517,7 @@
           <a:lstStyle/>
           <a:p>
             <a:r>
-              <a:t>One clear ask: approve the first two phases — the security assessment and the architecture design. That's five to seven weeks with existing teams and no new licence spend. Why now? Because the tool itself is finished and proven; what remains is deployment. Why is it safe? Because CAD processing already happens entirely inside the server — we verified this in the code — and the two security controls this plan called for, private AI routing and the air-gapped switch, are now built into the platform and tested live. And why does CAPEE win? Because we are not replacing CAPEE — we're giving it an AI engine and a memory.</a:t>
+              <a:t>One clear ask: approve the first two phases — the security assessment and the architecture design. That's five to seven weeks with existing teams and no new licence spend. Why now? Because the tool itself is finished and proven; what remains is deployment. Why is it safe? Because CAD processing already happens entirely inside the server — we verified this in the code — and the two security controls this plan called for, private AI routing and the air-gapped switch, are now built into the platform and tested live. And why does CAPEE win? Because we are not replacing CAPEE — it stays the should-cost software our teams already use; CostVision integrates into it and upgrades its engine with AI, physics and a memory.</a:t>
             </a:r>
           </a:p>
         </p:txBody>
@@ -5879,7 +5879,7 @@
                 </a:solidFill>
                 <a:latin typeface="Calibri"/>
               </a:rPr>
-              <a:t>Secure enterprise deployment inside our network — and integration with CAPEE.</a:t>
+              <a:t>Secure deployment inside our network — integrated into CAPEE, our existing should-cost software.</a:t>
             </a:r>
           </a:p>
           <a:p>
@@ -9372,7 +9372,7 @@
                 </a:solidFill>
                 <a:latin typeface="Calibri"/>
               </a:rPr>
-              <a:t>CAPEE + CostVision — better together</a:t>
+              <a:t>CostVision inside CAPEE — should-cost, upgraded</a:t>
             </a:r>
           </a:p>
         </p:txBody>
@@ -9460,7 +9460,7 @@
                 </a:solidFill>
                 <a:latin typeface="Calibri"/>
               </a:rPr>
-              <a:t>CAPEE  (stays the front door)</a:t>
+              <a:t>CAPEE  (existing should-cost software)</a:t>
             </a:r>
           </a:p>
           <a:p>
@@ -9479,7 +9479,7 @@
                 </a:solidFill>
                 <a:latin typeface="Calibri"/>
               </a:rPr>
-              <a:t>• Costing workflow, approvals, reporting</a:t>
+              <a:t>• Should-cost workflow, approvals, reporting</a:t>
             </a:r>
           </a:p>
           <a:p>
@@ -9517,7 +9517,7 @@
                 </a:solidFill>
                 <a:latin typeface="Calibri"/>
               </a:rPr>
-              <a:t>• Calls CostVision services behind the scenes</a:t>
+              <a:t>• Its costing engine now powered by CostVision</a:t>
             </a:r>
           </a:p>
         </p:txBody>
@@ -9605,7 +9605,7 @@
                 </a:solidFill>
                 <a:latin typeface="Calibri"/>
               </a:rPr>
-              <a:t>CostVision  (the engine behind it)</a:t>
+              <a:t>CostVision  (the engine it plugs in)</a:t>
             </a:r>
           </a:p>
           <a:p>
@@ -15487,7 +15487,7 @@
                 </a:solidFill>
                 <a:latin typeface="Calibri"/>
               </a:rPr>
-              <a:t>CAPEE + CostVision integration</a:t>
+              <a:t>Integration into CAPEE</a:t>
             </a:r>
           </a:p>
         </p:txBody>
@@ -15529,7 +15529,7 @@
                 </a:solidFill>
                 <a:latin typeface="Calibri"/>
               </a:rPr>
-              <a:t>FEASIBLE — API-first design; CAPEE stays the front door</a:t>
+              <a:t>FEASIBLE — API-first; plugs into CAPEE as its should-cost engine, no rip-and-replace</a:t>
             </a:r>
           </a:p>
         </p:txBody>
@@ -19800,7 +19800,7 @@
                 </a:solidFill>
                 <a:latin typeface="Calibri"/>
               </a:rPr>
-              <a:t>CAPEE keeps the workflow; CostVision adds the AI, physics and organisational memory behind it. No tool replacement.</a:t>
+              <a:t>CAPEE is our existing should-cost software; CostVision plugs into it to upgrade its engine with AI, physics and memory. No rip-and-replace.</a:t>
             </a:r>
           </a:p>
         </p:txBody>

</xml_diff>